<commit_message>
docs: scrub voice (no em-dashes, no emoji/check-marks, no filler) + add speaker notes
Voice rules now enforced and verified by scripts/qa pass:
  - No em-dashes (replaced with commas, periods, colons, or parentheses).
  - No emoji or unicode check/cross marks.
  - No filler phrases (it's worth noting, importantly, this means that, etc.).
  - No hedging (arguably, it should be noted, as mentioned above).
  - Rationale adds new information rather than restating the decision.
  - Eliminated within-document repetition between adjacent paragraphs.

Speaker notes added to every slide via slide.notes_slide.notes_text_frame.
Total ~1,936 words of notes across 15 slides (88-171 words per slide),
roughly 13 minutes at 150 wpm, fitting the 7-15 minute video requirement.
</commit_message>
<xml_diff>
--- a/reports/FalsePositive_SupplyChain_Honey.pptx
+++ b/reports/FalsePositive_SupplyChain_Honey.pptx
@@ -6,20 +6,20 @@
   </p:sldMasterIdLst>
   <p:sldIdLst>
     <p:sldId id="256" r:id="rId7"/>
-    <p:sldId id="257" r:id="rId8"/>
-    <p:sldId id="258" r:id="rId9"/>
-    <p:sldId id="259" r:id="rId10"/>
-    <p:sldId id="260" r:id="rId11"/>
-    <p:sldId id="261" r:id="rId12"/>
-    <p:sldId id="262" r:id="rId13"/>
-    <p:sldId id="263" r:id="rId14"/>
-    <p:sldId id="264" r:id="rId15"/>
-    <p:sldId id="265" r:id="rId16"/>
-    <p:sldId id="266" r:id="rId17"/>
-    <p:sldId id="267" r:id="rId18"/>
-    <p:sldId id="268" r:id="rId19"/>
-    <p:sldId id="269" r:id="rId20"/>
-    <p:sldId id="270" r:id="rId21"/>
+    <p:sldId id="257" r:id="rId9"/>
+    <p:sldId id="258" r:id="rId10"/>
+    <p:sldId id="259" r:id="rId11"/>
+    <p:sldId id="260" r:id="rId12"/>
+    <p:sldId id="261" r:id="rId13"/>
+    <p:sldId id="262" r:id="rId14"/>
+    <p:sldId id="263" r:id="rId15"/>
+    <p:sldId id="264" r:id="rId16"/>
+    <p:sldId id="265" r:id="rId17"/>
+    <p:sldId id="266" r:id="rId18"/>
+    <p:sldId id="267" r:id="rId19"/>
+    <p:sldId id="268" r:id="rId20"/>
+    <p:sldId id="269" r:id="rId21"/>
+    <p:sldId id="270" r:id="rId22"/>
   </p:sldIdLst>
   <p:sldSz cx="12191695" cy="6858000" type="screen4x3"/>
   <p:notesSz cx="6858000" cy="9144000"/>
@@ -119,6 +119,1451 @@
     </a:lvl9pPr>
   </p:defaultTextStyle>
 </p:presentation>
+</file>
+
+<file path=ppt/notesMasters/notesMaster1.xml><?xml version="1.0" encoding="utf-8"?>
+<p:notesMaster xmlns:a="http://schemas.openxmlformats.org/drawingml/2006/main" xmlns:p="http://schemas.openxmlformats.org/presentationml/2006/main" xmlns:r="http://schemas.openxmlformats.org/officeDocument/2006/relationships">
+  <p:cSld>
+    <p:bg>
+      <p:bgRef idx="1001">
+        <a:schemeClr val="bg1"/>
+      </p:bgRef>
+    </p:bg>
+    <p:spTree>
+      <p:nvGrpSpPr>
+        <p:cNvPr id="1" name=""/>
+        <p:cNvGrpSpPr/>
+        <p:nvPr/>
+      </p:nvGrpSpPr>
+      <p:grpSpPr>
+        <a:xfrm>
+          <a:off x="0" y="0"/>
+          <a:ext cx="0" cy="0"/>
+          <a:chOff x="0" y="0"/>
+          <a:chExt cx="0" cy="0"/>
+        </a:xfrm>
+      </p:grpSpPr>
+      <p:sp>
+        <p:nvSpPr>
+          <p:cNvPr id="2" name="Header Placeholder 1"/>
+          <p:cNvSpPr>
+            <a:spLocks noGrp="1"/>
+          </p:cNvSpPr>
+          <p:nvPr>
+            <p:ph type="hdr" sz="quarter"/>
+          </p:nvPr>
+        </p:nvSpPr>
+        <p:spPr>
+          <a:xfrm>
+            <a:off x="0" y="0"/>
+            <a:ext cx="2971800" cy="457200"/>
+          </a:xfrm>
+          <a:prstGeom prst="rect">
+            <a:avLst/>
+          </a:prstGeom>
+        </p:spPr>
+        <p:txBody>
+          <a:bodyPr vert="horz" lIns="91440" tIns="45720" rIns="91440" bIns="45720" rtlCol="0"/>
+          <a:lstStyle>
+            <a:lvl1pPr algn="l">
+              <a:defRPr sz="1200"/>
+            </a:lvl1pPr>
+          </a:lstStyle>
+          <a:p>
+            <a:endParaRPr lang="en-US"/>
+          </a:p>
+        </p:txBody>
+      </p:sp>
+      <p:sp>
+        <p:nvSpPr>
+          <p:cNvPr id="3" name="Date Placeholder 2"/>
+          <p:cNvSpPr>
+            <a:spLocks noGrp="1"/>
+          </p:cNvSpPr>
+          <p:nvPr>
+            <p:ph type="dt" idx="1"/>
+          </p:nvPr>
+        </p:nvSpPr>
+        <p:spPr>
+          <a:xfrm>
+            <a:off x="3884613" y="0"/>
+            <a:ext cx="2971800" cy="457200"/>
+          </a:xfrm>
+          <a:prstGeom prst="rect">
+            <a:avLst/>
+          </a:prstGeom>
+        </p:spPr>
+        <p:txBody>
+          <a:bodyPr vert="horz" lIns="91440" tIns="45720" rIns="91440" bIns="45720" rtlCol="0"/>
+          <a:lstStyle>
+            <a:lvl1pPr algn="r">
+              <a:defRPr sz="1200"/>
+            </a:lvl1pPr>
+          </a:lstStyle>
+          <a:p>
+            <a:fld id="{0F89C1C7-3DCD-1040-A9CF-14679D8B5DDD}" type="datetimeFigureOut">
+              <a:rPr lang="en-US" smtClean="0"/>
+              <a:t>10/17/16</a:t>
+            </a:fld>
+            <a:endParaRPr lang="en-US"/>
+          </a:p>
+        </p:txBody>
+      </p:sp>
+      <p:sp>
+        <p:nvSpPr>
+          <p:cNvPr id="4" name="Slide Image Placeholder 3"/>
+          <p:cNvSpPr>
+            <a:spLocks noGrp="1" noRot="1" noChangeAspect="1"/>
+          </p:cNvSpPr>
+          <p:nvPr>
+            <p:ph type="sldImg" idx="2"/>
+          </p:nvPr>
+        </p:nvSpPr>
+        <p:spPr>
+          <a:xfrm>
+            <a:off x="1143000" y="685800"/>
+            <a:ext cx="4572000" cy="3429000"/>
+          </a:xfrm>
+          <a:prstGeom prst="rect">
+            <a:avLst/>
+          </a:prstGeom>
+          <a:noFill/>
+          <a:ln w="12700">
+            <a:solidFill>
+              <a:prstClr val="black"/>
+            </a:solidFill>
+          </a:ln>
+        </p:spPr>
+        <p:txBody>
+          <a:bodyPr vert="horz" lIns="91440" tIns="45720" rIns="91440" bIns="45720" rtlCol="0" anchor="ctr"/>
+          <a:lstStyle/>
+          <a:p>
+            <a:endParaRPr lang="en-US"/>
+          </a:p>
+        </p:txBody>
+      </p:sp>
+      <p:sp>
+        <p:nvSpPr>
+          <p:cNvPr id="5" name="Notes Placeholder 4"/>
+          <p:cNvSpPr>
+            <a:spLocks noGrp="1"/>
+          </p:cNvSpPr>
+          <p:nvPr>
+            <p:ph type="body" sz="quarter" idx="3"/>
+          </p:nvPr>
+        </p:nvSpPr>
+        <p:spPr>
+          <a:xfrm>
+            <a:off x="685800" y="4343400"/>
+            <a:ext cx="5486400" cy="4114800"/>
+          </a:xfrm>
+          <a:prstGeom prst="rect">
+            <a:avLst/>
+          </a:prstGeom>
+        </p:spPr>
+        <p:txBody>
+          <a:bodyPr vert="horz" lIns="91440" tIns="45720" rIns="91440" bIns="45720" rtlCol="0"/>
+          <a:lstStyle/>
+          <a:p>
+            <a:pPr lvl="0"/>
+            <a:r>
+              <a:rPr lang="en-US" smtClean="0"/>
+              <a:t>Click to edit Master text styles</a:t>
+            </a:r>
+          </a:p>
+          <a:p>
+            <a:pPr lvl="1"/>
+            <a:r>
+              <a:rPr lang="en-US" smtClean="0"/>
+              <a:t>Second level</a:t>
+            </a:r>
+          </a:p>
+          <a:p>
+            <a:pPr lvl="2"/>
+            <a:r>
+              <a:rPr lang="en-US" smtClean="0"/>
+              <a:t>Third level</a:t>
+            </a:r>
+          </a:p>
+          <a:p>
+            <a:pPr lvl="3"/>
+            <a:r>
+              <a:rPr lang="en-US" smtClean="0"/>
+              <a:t>Fourth level</a:t>
+            </a:r>
+          </a:p>
+          <a:p>
+            <a:pPr lvl="4"/>
+            <a:r>
+              <a:rPr lang="en-US" smtClean="0"/>
+              <a:t>Fifth level</a:t>
+            </a:r>
+            <a:endParaRPr lang="en-US"/>
+          </a:p>
+        </p:txBody>
+      </p:sp>
+      <p:sp>
+        <p:nvSpPr>
+          <p:cNvPr id="6" name="Footer Placeholder 5"/>
+          <p:cNvSpPr>
+            <a:spLocks noGrp="1"/>
+          </p:cNvSpPr>
+          <p:nvPr>
+            <p:ph type="ftr" sz="quarter" idx="4"/>
+          </p:nvPr>
+        </p:nvSpPr>
+        <p:spPr>
+          <a:xfrm>
+            <a:off x="0" y="8685213"/>
+            <a:ext cx="2971800" cy="457200"/>
+          </a:xfrm>
+          <a:prstGeom prst="rect">
+            <a:avLst/>
+          </a:prstGeom>
+        </p:spPr>
+        <p:txBody>
+          <a:bodyPr vert="horz" lIns="91440" tIns="45720" rIns="91440" bIns="45720" rtlCol="0" anchor="b"/>
+          <a:lstStyle>
+            <a:lvl1pPr algn="l">
+              <a:defRPr sz="1200"/>
+            </a:lvl1pPr>
+          </a:lstStyle>
+          <a:p>
+            <a:endParaRPr lang="en-US"/>
+          </a:p>
+        </p:txBody>
+      </p:sp>
+      <p:sp>
+        <p:nvSpPr>
+          <p:cNvPr id="7" name="Slide Number Placeholder 6"/>
+          <p:cNvSpPr>
+            <a:spLocks noGrp="1"/>
+          </p:cNvSpPr>
+          <p:nvPr>
+            <p:ph type="sldNum" sz="quarter" idx="5"/>
+          </p:nvPr>
+        </p:nvSpPr>
+        <p:spPr>
+          <a:xfrm>
+            <a:off x="3884613" y="8685213"/>
+            <a:ext cx="2971800" cy="457200"/>
+          </a:xfrm>
+          <a:prstGeom prst="rect">
+            <a:avLst/>
+          </a:prstGeom>
+        </p:spPr>
+        <p:txBody>
+          <a:bodyPr vert="horz" lIns="91440" tIns="45720" rIns="91440" bIns="45720" rtlCol="0" anchor="b"/>
+          <a:lstStyle>
+            <a:lvl1pPr algn="r">
+              <a:defRPr sz="1200"/>
+            </a:lvl1pPr>
+          </a:lstStyle>
+          <a:p>
+            <a:fld id="{BB5E49A5-4136-284D-997B-48E1D791AD67}" type="slidenum">
+              <a:rPr lang="en-US" smtClean="0"/>
+              <a:t>‹#›</a:t>
+            </a:fld>
+            <a:endParaRPr lang="en-US"/>
+          </a:p>
+        </p:txBody>
+      </p:sp>
+    </p:spTree>
+    <p:extLst>
+      <p:ext uri="{BB962C8B-B14F-4D97-AF65-F5344CB8AC3E}">
+        <p14:creationId xmlns:p14="http://schemas.microsoft.com/office/powerpoint/2010/main" val="2623252185"/>
+      </p:ext>
+    </p:extLst>
+  </p:cSld>
+  <p:clrMap bg1="lt1" tx1="dk1" bg2="lt2" tx2="dk2" accent1="accent1" accent2="accent2" accent3="accent3" accent4="accent4" accent5="accent5" accent6="accent6" hlink="hlink" folHlink="folHlink"/>
+  <p:notesStyle>
+    <a:lvl1pPr marL="0" algn="l" defTabSz="457200" rtl="0" eaLnBrk="1" latinLnBrk="0" hangingPunct="1">
+      <a:defRPr sz="1200" kern="1200">
+        <a:solidFill>
+          <a:schemeClr val="tx1"/>
+        </a:solidFill>
+        <a:latin typeface="+mn-lt"/>
+        <a:ea typeface="+mn-ea"/>
+        <a:cs typeface="+mn-cs"/>
+      </a:defRPr>
+    </a:lvl1pPr>
+    <a:lvl2pPr marL="457200" algn="l" defTabSz="457200" rtl="0" eaLnBrk="1" latinLnBrk="0" hangingPunct="1">
+      <a:defRPr sz="1200" kern="1200">
+        <a:solidFill>
+          <a:schemeClr val="tx1"/>
+        </a:solidFill>
+        <a:latin typeface="+mn-lt"/>
+        <a:ea typeface="+mn-ea"/>
+        <a:cs typeface="+mn-cs"/>
+      </a:defRPr>
+    </a:lvl2pPr>
+    <a:lvl3pPr marL="914400" algn="l" defTabSz="457200" rtl="0" eaLnBrk="1" latinLnBrk="0" hangingPunct="1">
+      <a:defRPr sz="1200" kern="1200">
+        <a:solidFill>
+          <a:schemeClr val="tx1"/>
+        </a:solidFill>
+        <a:latin typeface="+mn-lt"/>
+        <a:ea typeface="+mn-ea"/>
+        <a:cs typeface="+mn-cs"/>
+      </a:defRPr>
+    </a:lvl3pPr>
+    <a:lvl4pPr marL="1371600" algn="l" defTabSz="457200" rtl="0" eaLnBrk="1" latinLnBrk="0" hangingPunct="1">
+      <a:defRPr sz="1200" kern="1200">
+        <a:solidFill>
+          <a:schemeClr val="tx1"/>
+        </a:solidFill>
+        <a:latin typeface="+mn-lt"/>
+        <a:ea typeface="+mn-ea"/>
+        <a:cs typeface="+mn-cs"/>
+      </a:defRPr>
+    </a:lvl4pPr>
+    <a:lvl5pPr marL="1828800" algn="l" defTabSz="457200" rtl="0" eaLnBrk="1" latinLnBrk="0" hangingPunct="1">
+      <a:defRPr sz="1200" kern="1200">
+        <a:solidFill>
+          <a:schemeClr val="tx1"/>
+        </a:solidFill>
+        <a:latin typeface="+mn-lt"/>
+        <a:ea typeface="+mn-ea"/>
+        <a:cs typeface="+mn-cs"/>
+      </a:defRPr>
+    </a:lvl5pPr>
+    <a:lvl6pPr marL="2286000" algn="l" defTabSz="457200" rtl="0" eaLnBrk="1" latinLnBrk="0" hangingPunct="1">
+      <a:defRPr sz="1200" kern="1200">
+        <a:solidFill>
+          <a:schemeClr val="tx1"/>
+        </a:solidFill>
+        <a:latin typeface="+mn-lt"/>
+        <a:ea typeface="+mn-ea"/>
+        <a:cs typeface="+mn-cs"/>
+      </a:defRPr>
+    </a:lvl6pPr>
+    <a:lvl7pPr marL="2743200" algn="l" defTabSz="457200" rtl="0" eaLnBrk="1" latinLnBrk="0" hangingPunct="1">
+      <a:defRPr sz="1200" kern="1200">
+        <a:solidFill>
+          <a:schemeClr val="tx1"/>
+        </a:solidFill>
+        <a:latin typeface="+mn-lt"/>
+        <a:ea typeface="+mn-ea"/>
+        <a:cs typeface="+mn-cs"/>
+      </a:defRPr>
+    </a:lvl7pPr>
+    <a:lvl8pPr marL="3200400" algn="l" defTabSz="457200" rtl="0" eaLnBrk="1" latinLnBrk="0" hangingPunct="1">
+      <a:defRPr sz="1200" kern="1200">
+        <a:solidFill>
+          <a:schemeClr val="tx1"/>
+        </a:solidFill>
+        <a:latin typeface="+mn-lt"/>
+        <a:ea typeface="+mn-ea"/>
+        <a:cs typeface="+mn-cs"/>
+      </a:defRPr>
+    </a:lvl8pPr>
+    <a:lvl9pPr marL="3657600" algn="l" defTabSz="457200" rtl="0" eaLnBrk="1" latinLnBrk="0" hangingPunct="1">
+      <a:defRPr sz="1200" kern="1200">
+        <a:solidFill>
+          <a:schemeClr val="tx1"/>
+        </a:solidFill>
+        <a:latin typeface="+mn-lt"/>
+        <a:ea typeface="+mn-ea"/>
+        <a:cs typeface="+mn-cs"/>
+      </a:defRPr>
+    </a:lvl9pPr>
+  </p:notesStyle>
+</p:notesMaster>
+</file>
+
+<file path=ppt/notesSlides/notesSlide1.xml><?xml version="1.0" encoding="utf-8"?>
+<p:notes xmlns:a="http://schemas.openxmlformats.org/drawingml/2006/main" xmlns:p="http://schemas.openxmlformats.org/presentationml/2006/main" xmlns:r="http://schemas.openxmlformats.org/officeDocument/2006/relationships">
+  <p:cSld>
+    <p:spTree>
+      <p:nvGrpSpPr>
+        <p:cNvPr id="1" name=""/>
+        <p:cNvGrpSpPr/>
+        <p:nvPr/>
+      </p:nvGrpSpPr>
+      <p:grpSpPr>
+        <a:xfrm>
+          <a:off x="0" y="0"/>
+          <a:ext cx="0" cy="0"/>
+          <a:chOff x="0" y="0"/>
+          <a:chExt cx="0" cy="0"/>
+        </a:xfrm>
+      </p:grpSpPr>
+      <p:sp>
+        <p:nvSpPr>
+          <p:cNvPr id="2" name="Slide Image Placeholder 1"/>
+          <p:cNvSpPr>
+            <a:spLocks noGrp="1"/>
+          </p:cNvSpPr>
+          <p:nvPr>
+            <p:ph type="sldImg" idx="2"/>
+          </p:nvPr>
+        </p:nvSpPr>
+        <p:spPr/>
+      </p:sp>
+      <p:sp>
+        <p:nvSpPr>
+          <p:cNvPr id="3" name="Notes Placeholder 2"/>
+          <p:cNvSpPr>
+            <a:spLocks noGrp="1"/>
+          </p:cNvSpPr>
+          <p:nvPr>
+            <p:ph type="body" idx="3" sz="quarter"/>
+          </p:nvPr>
+        </p:nvSpPr>
+        <p:spPr/>
+        <p:txBody>
+          <a:bodyPr/>
+          <a:lstStyle/>
+          <a:p>
+            <a:r>
+              <a:rPr sz="1200">
+                <a:latin typeface="Calibri"/>
+              </a:rPr>
+              <a:t>Hi, I'm Ankit Honey, Engineering Manager on the Dependabot team at GitHub. I spend my day looking at the problem this project addresses, which is the millions of CVE alerts Dependabot generates and the fact that developers ignore most of them. For my CSCI E-222 final project, I mapped the course topic of misinformation detection onto vulnerability alert classification. The structural analogy is very tight, I'll cover that on the next slide. The bottom row shows the headline results before I get into the methodology. 10,000 real advisories from the GitHub Advisory Database, full-pipeline F1 of 0.995, recall 0.99, and zero false alarms. I'll be honest later in the talk about what that 0.995 number means and what it doesn't.</a:t>
+            </a:r>
+          </a:p>
+        </p:txBody>
+      </p:sp>
+      <p:sp>
+        <p:nvSpPr>
+          <p:cNvPr id="4" name="Slide Number Placeholder 3"/>
+          <p:cNvSpPr>
+            <a:spLocks noGrp="1"/>
+          </p:cNvSpPr>
+          <p:nvPr>
+            <p:ph type="sldNum" idx="5" sz="quarter"/>
+          </p:nvPr>
+        </p:nvSpPr>
+        <p:spPr/>
+      </p:sp>
+    </p:spTree>
+  </p:cSld>
+  <p:clrMapOvr>
+    <a:masterClrMapping/>
+  </p:clrMapOvr>
+</p:notes>
+</file>
+
+<file path=ppt/notesSlides/notesSlide10.xml><?xml version="1.0" encoding="utf-8"?>
+<p:notes xmlns:a="http://schemas.openxmlformats.org/drawingml/2006/main" xmlns:p="http://schemas.openxmlformats.org/presentationml/2006/main" xmlns:r="http://schemas.openxmlformats.org/officeDocument/2006/relationships">
+  <p:cSld>
+    <p:spTree>
+      <p:nvGrpSpPr>
+        <p:cNvPr id="1" name=""/>
+        <p:cNvGrpSpPr/>
+        <p:nvPr/>
+      </p:nvGrpSpPr>
+      <p:grpSpPr>
+        <a:xfrm>
+          <a:off x="0" y="0"/>
+          <a:ext cx="0" cy="0"/>
+          <a:chOff x="0" y="0"/>
+          <a:chExt cx="0" cy="0"/>
+        </a:xfrm>
+      </p:grpSpPr>
+      <p:sp>
+        <p:nvSpPr>
+          <p:cNvPr id="2" name="Slide Image Placeholder 1"/>
+          <p:cNvSpPr>
+            <a:spLocks noGrp="1"/>
+          </p:cNvSpPr>
+          <p:nvPr>
+            <p:ph type="sldImg" idx="2"/>
+          </p:nvPr>
+        </p:nvSpPr>
+        <p:spPr/>
+      </p:sp>
+      <p:sp>
+        <p:nvSpPr>
+          <p:cNvPr id="3" name="Notes Placeholder 2"/>
+          <p:cNvSpPr>
+            <a:spLocks noGrp="1"/>
+          </p:cNvSpPr>
+          <p:nvPr>
+            <p:ph type="body" idx="3" sz="quarter"/>
+          </p:nvPr>
+        </p:nvSpPr>
+        <p:spPr/>
+        <p:txBody>
+          <a:bodyPr/>
+          <a:lstStyle/>
+          <a:p>
+            <a:r>
+              <a:rPr sz="1200">
+                <a:latin typeface="Calibri"/>
+              </a:rPr>
+              <a:t>Headline numbers. The two baselines and RoBERTa cluster around 0.6 F1. They're all working on the CVE description and the EPSS score, so they hit a similar ceiling. The full pipeline jumps to 0.995 F1 with 1.0 precision and 0.99 recall. The big number on the left is the F1 lift, +0.40 over RoBERTa alone. That's the value the reachability features add. The big number on the right is the false-alarm reduction, 100 percent. Zero false positives on 790 actual negatives. From a security operations standpoint, that's the metric your on-call cares about. I'll be honest in the next two slides about why this number is so high. Spoiler: the reachability features in training are an oracle approximation. But the structural finding holds, reachability is the dominant signal.</a:t>
+            </a:r>
+          </a:p>
+        </p:txBody>
+      </p:sp>
+      <p:sp>
+        <p:nvSpPr>
+          <p:cNvPr id="4" name="Slide Number Placeholder 3"/>
+          <p:cNvSpPr>
+            <a:spLocks noGrp="1"/>
+          </p:cNvSpPr>
+          <p:nvPr>
+            <p:ph type="sldNum" idx="5" sz="quarter"/>
+          </p:nvPr>
+        </p:nvSpPr>
+        <p:spPr/>
+      </p:sp>
+    </p:spTree>
+  </p:cSld>
+  <p:clrMapOvr>
+    <a:masterClrMapping/>
+  </p:clrMapOvr>
+</p:notes>
+</file>
+
+<file path=ppt/notesSlides/notesSlide11.xml><?xml version="1.0" encoding="utf-8"?>
+<p:notes xmlns:a="http://schemas.openxmlformats.org/drawingml/2006/main" xmlns:p="http://schemas.openxmlformats.org/presentationml/2006/main" xmlns:r="http://schemas.openxmlformats.org/officeDocument/2006/relationships">
+  <p:cSld>
+    <p:spTree>
+      <p:nvGrpSpPr>
+        <p:cNvPr id="1" name=""/>
+        <p:cNvGrpSpPr/>
+        <p:nvPr/>
+      </p:nvGrpSpPr>
+      <p:grpSpPr>
+        <a:xfrm>
+          <a:off x="0" y="0"/>
+          <a:ext cx="0" cy="0"/>
+          <a:chOff x="0" y="0"/>
+          <a:chExt cx="0" cy="0"/>
+        </a:xfrm>
+      </p:grpSpPr>
+      <p:sp>
+        <p:nvSpPr>
+          <p:cNvPr id="2" name="Slide Image Placeholder 1"/>
+          <p:cNvSpPr>
+            <a:spLocks noGrp="1"/>
+          </p:cNvSpPr>
+          <p:nvPr>
+            <p:ph type="sldImg" idx="2"/>
+          </p:nvPr>
+        </p:nvSpPr>
+        <p:spPr/>
+      </p:sp>
+      <p:sp>
+        <p:nvSpPr>
+          <p:cNvPr id="3" name="Notes Placeholder 2"/>
+          <p:cNvSpPr>
+            <a:spLocks noGrp="1"/>
+          </p:cNvSpPr>
+          <p:nvPr>
+            <p:ph type="body" idx="3" sz="quarter"/>
+          </p:nvPr>
+        </p:nvSpPr>
+        <p:spPr/>
+        <p:txBody>
+          <a:bodyPr/>
+          <a:lstStyle/>
+          <a:p>
+            <a:r>
+              <a:rPr sz="1200">
+                <a:latin typeface="Calibri"/>
+              </a:rPr>
+              <a:t>Confusion matrix on the 1,002-alert test set. Top row, the 790 actual negatives. All 790 predicted as negative. Zero false alarms. Bottom row, the 212 actual positives. 210 correctly predicted as positive, 2 missed. False-negative rate is 0.94 percent. Why this matters for security: in this domain, recall matters more than precision. If you miss a true positive, a real vulnerability stays unpatched. If you raise a false positive, you waste an engineer's time. Those costs are not symmetric. The pipeline ends up favouring recall, which is what you want.</a:t>
+            </a:r>
+          </a:p>
+        </p:txBody>
+      </p:sp>
+      <p:sp>
+        <p:nvSpPr>
+          <p:cNvPr id="4" name="Slide Number Placeholder 3"/>
+          <p:cNvSpPr>
+            <a:spLocks noGrp="1"/>
+          </p:cNvSpPr>
+          <p:nvPr>
+            <p:ph type="sldNum" idx="5" sz="quarter"/>
+          </p:nvPr>
+        </p:nvSpPr>
+        <p:spPr/>
+      </p:sp>
+    </p:spTree>
+  </p:cSld>
+  <p:clrMapOvr>
+    <a:masterClrMapping/>
+  </p:clrMapOvr>
+</p:notes>
+</file>
+
+<file path=ppt/notesSlides/notesSlide12.xml><?xml version="1.0" encoding="utf-8"?>
+<p:notes xmlns:a="http://schemas.openxmlformats.org/drawingml/2006/main" xmlns:p="http://schemas.openxmlformats.org/presentationml/2006/main" xmlns:r="http://schemas.openxmlformats.org/officeDocument/2006/relationships">
+  <p:cSld>
+    <p:spTree>
+      <p:nvGrpSpPr>
+        <p:cNvPr id="1" name=""/>
+        <p:cNvGrpSpPr/>
+        <p:nvPr/>
+      </p:nvGrpSpPr>
+      <p:grpSpPr>
+        <a:xfrm>
+          <a:off x="0" y="0"/>
+          <a:ext cx="0" cy="0"/>
+          <a:chOff x="0" y="0"/>
+          <a:chExt cx="0" cy="0"/>
+        </a:xfrm>
+      </p:grpSpPr>
+      <p:sp>
+        <p:nvSpPr>
+          <p:cNvPr id="2" name="Slide Image Placeholder 1"/>
+          <p:cNvSpPr>
+            <a:spLocks noGrp="1"/>
+          </p:cNvSpPr>
+          <p:nvPr>
+            <p:ph type="sldImg" idx="2"/>
+          </p:nvPr>
+        </p:nvSpPr>
+        <p:spPr/>
+      </p:sp>
+      <p:sp>
+        <p:nvSpPr>
+          <p:cNvPr id="3" name="Notes Placeholder 2"/>
+          <p:cNvSpPr>
+            <a:spLocks noGrp="1"/>
+          </p:cNvSpPr>
+          <p:nvPr>
+            <p:ph type="body" idx="3" sz="quarter"/>
+          </p:nvPr>
+        </p:nvSpPr>
+        <p:spPr/>
+        <p:txBody>
+          <a:bodyPr/>
+          <a:lstStyle/>
+          <a:p>
+            <a:r>
+              <a:rPr sz="1200">
+                <a:latin typeface="Calibri"/>
+              </a:rPr>
+              <a:t>The honest slide. Left column, what worked. Reproducibility was a goal from day one. Cloning the repo and running the notebook end-to-end takes 5 minutes on a fresh Colab. The static call graph distinguishes safe from vulnerable lodash apps perfectly. The 0.42-point F1 jump matches what the proposal predicted, which validates the architectural hypothesis. FAISS retrieval shows clean separation. 15 tests pass in 3 seconds. Right column, what didn't work or what to caveat. Flan-T5 returned the wrong verdict on the VULN lodash app, that's the main negative finding. The 0.995 headline F1 is an upper bound because the reachability features in training are synthesised from the label with 15 percent noise. In a real deployment you'd run is_reachable on each alert's actual consumer repo. The JS parser is regex-based, so dynamic dispatch and eval slip through. The curated symbol table is 10 CVEs deep, production needs three orders of magnitude more. And the proxy label correlates with EPSS by construction, which slightly inflates what the EPSS rule baseline can do.</a:t>
+            </a:r>
+          </a:p>
+        </p:txBody>
+      </p:sp>
+      <p:sp>
+        <p:nvSpPr>
+          <p:cNvPr id="4" name="Slide Number Placeholder 3"/>
+          <p:cNvSpPr>
+            <a:spLocks noGrp="1"/>
+          </p:cNvSpPr>
+          <p:nvPr>
+            <p:ph type="sldNum" idx="5" sz="quarter"/>
+          </p:nvPr>
+        </p:nvSpPr>
+        <p:spPr/>
+      </p:sp>
+    </p:spTree>
+  </p:cSld>
+  <p:clrMapOvr>
+    <a:masterClrMapping/>
+  </p:clrMapOvr>
+</p:notes>
+</file>
+
+<file path=ppt/notesSlides/notesSlide13.xml><?xml version="1.0" encoding="utf-8"?>
+<p:notes xmlns:a="http://schemas.openxmlformats.org/drawingml/2006/main" xmlns:p="http://schemas.openxmlformats.org/presentationml/2006/main" xmlns:r="http://schemas.openxmlformats.org/officeDocument/2006/relationships">
+  <p:cSld>
+    <p:spTree>
+      <p:nvGrpSpPr>
+        <p:cNvPr id="1" name=""/>
+        <p:cNvGrpSpPr/>
+        <p:nvPr/>
+      </p:nvGrpSpPr>
+      <p:grpSpPr>
+        <a:xfrm>
+          <a:off x="0" y="0"/>
+          <a:ext cx="0" cy="0"/>
+          <a:chOff x="0" y="0"/>
+          <a:chExt cx="0" cy="0"/>
+        </a:xfrm>
+      </p:grpSpPr>
+      <p:sp>
+        <p:nvSpPr>
+          <p:cNvPr id="2" name="Slide Image Placeholder 1"/>
+          <p:cNvSpPr>
+            <a:spLocks noGrp="1"/>
+          </p:cNvSpPr>
+          <p:nvPr>
+            <p:ph type="sldImg" idx="2"/>
+          </p:nvPr>
+        </p:nvSpPr>
+        <p:spPr/>
+      </p:sp>
+      <p:sp>
+        <p:nvSpPr>
+          <p:cNvPr id="3" name="Notes Placeholder 2"/>
+          <p:cNvSpPr>
+            <a:spLocks noGrp="1"/>
+          </p:cNvSpPr>
+          <p:nvPr>
+            <p:ph type="body" idx="3" sz="quarter"/>
+          </p:nvPr>
+        </p:nvSpPr>
+        <p:spPr/>
+        <p:txBody>
+          <a:bodyPr/>
+          <a:lstStyle/>
+          <a:p>
+            <a:r>
+              <a:rPr sz="1200">
+                <a:latin typeface="Calibri"/>
+              </a:rPr>
+              <a:t>Six concrete things I'd do next, ordered by how much they matter. One, tree-sitter for the JS parser. Cheap fix, broad coverage win. Two, bigger LLM reasoner. Qwen-2.5-Coder-7B or Llama-3-8B-Instruct. This is the direct fix for the Flan-T5 miss on the VULN app. Three, lightweight static taint analysis. Source-to-sink tracking for a small set of known dangerous patterns, like req.query flowing into eval. Removes the LLM dependency for the easy cases. Four, the big one. A real reachability oracle. Sample a few hundred advisories with public patch commits, mine the vulnerable symbol from the diff, then label reachability against a corpus of real consumer repos. That's what replaces the synthesised reachability features in training and converts the 0.995 upper bound into a defensible production number. Five, calibrated confidence. Three-way output: reachable, unreachable, unknown, with probability thresholds. Route only the unknown bucket to human review. Six, LLM-extracted symbol map. Run an extraction prompt over patch diffs to scale the curated symbol table from 10 entries to 10,000.</a:t>
+            </a:r>
+          </a:p>
+        </p:txBody>
+      </p:sp>
+      <p:sp>
+        <p:nvSpPr>
+          <p:cNvPr id="4" name="Slide Number Placeholder 3"/>
+          <p:cNvSpPr>
+            <a:spLocks noGrp="1"/>
+          </p:cNvSpPr>
+          <p:nvPr>
+            <p:ph type="sldNum" idx="5" sz="quarter"/>
+          </p:nvPr>
+        </p:nvSpPr>
+        <p:spPr/>
+      </p:sp>
+    </p:spTree>
+  </p:cSld>
+  <p:clrMapOvr>
+    <a:masterClrMapping/>
+  </p:clrMapOvr>
+</p:notes>
+</file>
+
+<file path=ppt/notesSlides/notesSlide14.xml><?xml version="1.0" encoding="utf-8"?>
+<p:notes xmlns:a="http://schemas.openxmlformats.org/drawingml/2006/main" xmlns:p="http://schemas.openxmlformats.org/presentationml/2006/main" xmlns:r="http://schemas.openxmlformats.org/officeDocument/2006/relationships">
+  <p:cSld>
+    <p:spTree>
+      <p:nvGrpSpPr>
+        <p:cNvPr id="1" name=""/>
+        <p:cNvGrpSpPr/>
+        <p:nvPr/>
+      </p:nvGrpSpPr>
+      <p:grpSpPr>
+        <a:xfrm>
+          <a:off x="0" y="0"/>
+          <a:ext cx="0" cy="0"/>
+          <a:chOff x="0" y="0"/>
+          <a:chExt cx="0" cy="0"/>
+        </a:xfrm>
+      </p:grpSpPr>
+      <p:sp>
+        <p:nvSpPr>
+          <p:cNvPr id="2" name="Slide Image Placeholder 1"/>
+          <p:cNvSpPr>
+            <a:spLocks noGrp="1"/>
+          </p:cNvSpPr>
+          <p:nvPr>
+            <p:ph type="sldImg" idx="2"/>
+          </p:nvPr>
+        </p:nvSpPr>
+        <p:spPr/>
+      </p:sp>
+      <p:sp>
+        <p:nvSpPr>
+          <p:cNvPr id="3" name="Notes Placeholder 2"/>
+          <p:cNvSpPr>
+            <a:spLocks noGrp="1"/>
+          </p:cNvSpPr>
+          <p:nvPr>
+            <p:ph type="body" idx="3" sz="quarter"/>
+          </p:nvPr>
+        </p:nvSpPr>
+        <p:spPr/>
+        <p:txBody>
+          <a:bodyPr/>
+          <a:lstStyle/>
+          <a:p>
+            <a:r>
+              <a:rPr sz="1200">
+                <a:latin typeface="Calibri"/>
+              </a:rPr>
+              <a:t>Reproducibility was a hard requirement for this project. Everything is public. Option A, Colab. Open the notebook from the badge in the README, switch to an A100 runtime, Runtime &gt; Run all. 5 minutes in synthetic mode, 25 minutes in real mode on an A100. Option B, local. Clone, virtualenv, pip install, pytest. The 15 tests run in 3 seconds and exercise the loader, dataset builder, and call graph. Datasets are not bundled because of the 10 MB Canvas limit. The notebook shallow-clones the Advisory Database (around 400 MB) on first run. EPSS is a daily CSV pulled live from FIRST. Both get cached so subsequent runs are fast.</a:t>
+            </a:r>
+          </a:p>
+        </p:txBody>
+      </p:sp>
+      <p:sp>
+        <p:nvSpPr>
+          <p:cNvPr id="4" name="Slide Number Placeholder 3"/>
+          <p:cNvSpPr>
+            <a:spLocks noGrp="1"/>
+          </p:cNvSpPr>
+          <p:nvPr>
+            <p:ph type="sldNum" idx="5" sz="quarter"/>
+          </p:nvPr>
+        </p:nvSpPr>
+        <p:spPr/>
+      </p:sp>
+    </p:spTree>
+  </p:cSld>
+  <p:clrMapOvr>
+    <a:masterClrMapping/>
+  </p:clrMapOvr>
+</p:notes>
+</file>
+
+<file path=ppt/notesSlides/notesSlide15.xml><?xml version="1.0" encoding="utf-8"?>
+<p:notes xmlns:a="http://schemas.openxmlformats.org/drawingml/2006/main" xmlns:p="http://schemas.openxmlformats.org/presentationml/2006/main" xmlns:r="http://schemas.openxmlformats.org/officeDocument/2006/relationships">
+  <p:cSld>
+    <p:spTree>
+      <p:nvGrpSpPr>
+        <p:cNvPr id="1" name=""/>
+        <p:cNvGrpSpPr/>
+        <p:nvPr/>
+      </p:nvGrpSpPr>
+      <p:grpSpPr>
+        <a:xfrm>
+          <a:off x="0" y="0"/>
+          <a:ext cx="0" cy="0"/>
+          <a:chOff x="0" y="0"/>
+          <a:chExt cx="0" cy="0"/>
+        </a:xfrm>
+      </p:grpSpPr>
+      <p:sp>
+        <p:nvSpPr>
+          <p:cNvPr id="2" name="Slide Image Placeholder 1"/>
+          <p:cNvSpPr>
+            <a:spLocks noGrp="1"/>
+          </p:cNvSpPr>
+          <p:nvPr>
+            <p:ph type="sldImg" idx="2"/>
+          </p:nvPr>
+        </p:nvSpPr>
+        <p:spPr/>
+      </p:sp>
+      <p:sp>
+        <p:nvSpPr>
+          <p:cNvPr id="3" name="Notes Placeholder 2"/>
+          <p:cNvSpPr>
+            <a:spLocks noGrp="1"/>
+          </p:cNvSpPr>
+          <p:nvPr>
+            <p:ph type="body" idx="3" sz="quarter"/>
+          </p:nvPr>
+        </p:nvSpPr>
+        <p:spPr/>
+        <p:txBody>
+          <a:bodyPr/>
+          <a:lstStyle/>
+          <a:p>
+            <a:r>
+              <a:rPr sz="1200">
+                <a:latin typeface="Calibri"/>
+              </a:rPr>
+              <a:t>Closing slide. Two things to mention. One, the video URL on the card is the 10-minute walkthrough recording. Update that URL with the real link before submission. The same URL appears on the report cover page. Two, the GitHub repository at github.com/honeyankit/reachability-llm has everything: the notebook, the data loaders, the tests, the report, and these slides. The generation scripts that produce the report and slides are in scripts/. The notebook re-runs end to end in 5 minutes on Colab. Thanks for the course. Happy to take questions on the methodology, the Flan-T5 negative finding, or how this maps to real-world Dependabot operations.</a:t>
+            </a:r>
+          </a:p>
+        </p:txBody>
+      </p:sp>
+      <p:sp>
+        <p:nvSpPr>
+          <p:cNvPr id="4" name="Slide Number Placeholder 3"/>
+          <p:cNvSpPr>
+            <a:spLocks noGrp="1"/>
+          </p:cNvSpPr>
+          <p:nvPr>
+            <p:ph type="sldNum" idx="5" sz="quarter"/>
+          </p:nvPr>
+        </p:nvSpPr>
+        <p:spPr/>
+      </p:sp>
+    </p:spTree>
+  </p:cSld>
+  <p:clrMapOvr>
+    <a:masterClrMapping/>
+  </p:clrMapOvr>
+</p:notes>
+</file>
+
+<file path=ppt/notesSlides/notesSlide2.xml><?xml version="1.0" encoding="utf-8"?>
+<p:notes xmlns:a="http://schemas.openxmlformats.org/drawingml/2006/main" xmlns:p="http://schemas.openxmlformats.org/presentationml/2006/main" xmlns:r="http://schemas.openxmlformats.org/officeDocument/2006/relationships">
+  <p:cSld>
+    <p:spTree>
+      <p:nvGrpSpPr>
+        <p:cNvPr id="1" name=""/>
+        <p:cNvGrpSpPr/>
+        <p:nvPr/>
+      </p:nvGrpSpPr>
+      <p:grpSpPr>
+        <a:xfrm>
+          <a:off x="0" y="0"/>
+          <a:ext cx="0" cy="0"/>
+          <a:chOff x="0" y="0"/>
+          <a:chExt cx="0" cy="0"/>
+        </a:xfrm>
+      </p:grpSpPr>
+      <p:sp>
+        <p:nvSpPr>
+          <p:cNvPr id="2" name="Slide Image Placeholder 1"/>
+          <p:cNvSpPr>
+            <a:spLocks noGrp="1"/>
+          </p:cNvSpPr>
+          <p:nvPr>
+            <p:ph type="sldImg" idx="2"/>
+          </p:nvPr>
+        </p:nvSpPr>
+        <p:spPr/>
+      </p:sp>
+      <p:sp>
+        <p:nvSpPr>
+          <p:cNvPr id="3" name="Notes Placeholder 2"/>
+          <p:cNvSpPr>
+            <a:spLocks noGrp="1"/>
+          </p:cNvSpPr>
+          <p:nvPr>
+            <p:ph type="body" idx="3" sz="quarter"/>
+          </p:nvPr>
+        </p:nvSpPr>
+        <p:spPr/>
+        <p:txBody>
+          <a:bodyPr/>
+          <a:lstStyle/>
+          <a:p>
+            <a:r>
+              <a:rPr sz="1200">
+                <a:latin typeface="Calibri"/>
+              </a:rPr>
+              <a:t>The setup. Dependabot scans millions of repos every day and generates a vulnerability alert for any dependency that's affected by a CVE. The pain point is that most of those alerts are technically valid but irrelevant in practice. The two code blocks on the right are real examples for CVE-2021-23337, the lodash command-injection bug. Both applications pin the exact same vulnerable version of lodash. CVSS is the same, EPSS is the same. The top one is safe because it never calls _.template. The bottom one is dangerous because it calls _.template with a sourceURL coming from req.query, which is user-controlled. The course topic is misinformation detection. The analogy is exact: an article can be technically true but misleading in context, and a CVE can be technically present but unreachable in context. That's the bridge between the course material and this project.</a:t>
+            </a:r>
+          </a:p>
+        </p:txBody>
+      </p:sp>
+      <p:sp>
+        <p:nvSpPr>
+          <p:cNvPr id="4" name="Slide Number Placeholder 3"/>
+          <p:cNvSpPr>
+            <a:spLocks noGrp="1"/>
+          </p:cNvSpPr>
+          <p:nvPr>
+            <p:ph type="sldNum" idx="5" sz="quarter"/>
+          </p:nvPr>
+        </p:nvSpPr>
+        <p:spPr/>
+      </p:sp>
+    </p:spTree>
+  </p:cSld>
+  <p:clrMapOvr>
+    <a:masterClrMapping/>
+  </p:clrMapOvr>
+</p:notes>
+</file>
+
+<file path=ppt/notesSlides/notesSlide3.xml><?xml version="1.0" encoding="utf-8"?>
+<p:notes xmlns:a="http://schemas.openxmlformats.org/drawingml/2006/main" xmlns:p="http://schemas.openxmlformats.org/presentationml/2006/main" xmlns:r="http://schemas.openxmlformats.org/officeDocument/2006/relationships">
+  <p:cSld>
+    <p:spTree>
+      <p:nvGrpSpPr>
+        <p:cNvPr id="1" name=""/>
+        <p:cNvGrpSpPr/>
+        <p:nvPr/>
+      </p:nvGrpSpPr>
+      <p:grpSpPr>
+        <a:xfrm>
+          <a:off x="0" y="0"/>
+          <a:ext cx="0" cy="0"/>
+          <a:chOff x="0" y="0"/>
+          <a:chExt cx="0" cy="0"/>
+        </a:xfrm>
+      </p:grpSpPr>
+      <p:sp>
+        <p:nvSpPr>
+          <p:cNvPr id="2" name="Slide Image Placeholder 1"/>
+          <p:cNvSpPr>
+            <a:spLocks noGrp="1"/>
+          </p:cNvSpPr>
+          <p:nvPr>
+            <p:ph type="sldImg" idx="2"/>
+          </p:nvPr>
+        </p:nvSpPr>
+        <p:spPr/>
+      </p:sp>
+      <p:sp>
+        <p:nvSpPr>
+          <p:cNvPr id="3" name="Notes Placeholder 2"/>
+          <p:cNvSpPr>
+            <a:spLocks noGrp="1"/>
+          </p:cNvSpPr>
+          <p:nvPr>
+            <p:ph type="body" idx="3" sz="quarter"/>
+          </p:nvPr>
+        </p:nvSpPr>
+        <p:spPr/>
+        <p:txBody>
+          <a:bodyPr/>
+          <a:lstStyle/>
+          <a:p>
+            <a:r>
+              <a:rPr sz="1200">
+                <a:latin typeface="Calibri"/>
+              </a:rPr>
+              <a:t>High-level architecture. Four stages, each one feeds the next. Stage 1 is the two simple baselines you'd expect: a rule that just thresholds EPSS, and a TF-IDF Logistic Regression over the CVE description. They establish the floor. Stage 2 fine-tunes roberta-base on the CVE descriptions to get a 768-d semantic embedding plus a binary classification head. Stage 3 is where the project lives. Static call-graph analysis tells us whether the vulnerable symbol is reached. Flan-T5-large reasons about whether user-controlled data flows into it. CodeBERT plus FAISS is the fallback for monorepos where the static graph is impractical. Stage 4 concatenates the 768-d embedding, 5 structured features, and 2 reachability signals into a 775-d vector and trains a Logistic Regression head. I'll walk through each stage with results in the next few slides.</a:t>
+            </a:r>
+          </a:p>
+        </p:txBody>
+      </p:sp>
+      <p:sp>
+        <p:nvSpPr>
+          <p:cNvPr id="4" name="Slide Number Placeholder 3"/>
+          <p:cNvSpPr>
+            <a:spLocks noGrp="1"/>
+          </p:cNvSpPr>
+          <p:nvPr>
+            <p:ph type="sldNum" idx="5" sz="quarter"/>
+          </p:nvPr>
+        </p:nvSpPr>
+        <p:spPr/>
+      </p:sp>
+    </p:spTree>
+  </p:cSld>
+  <p:clrMapOvr>
+    <a:masterClrMapping/>
+  </p:clrMapOvr>
+</p:notes>
+</file>
+
+<file path=ppt/notesSlides/notesSlide4.xml><?xml version="1.0" encoding="utf-8"?>
+<p:notes xmlns:a="http://schemas.openxmlformats.org/drawingml/2006/main" xmlns:p="http://schemas.openxmlformats.org/presentationml/2006/main" xmlns:r="http://schemas.openxmlformats.org/officeDocument/2006/relationships">
+  <p:cSld>
+    <p:spTree>
+      <p:nvGrpSpPr>
+        <p:cNvPr id="1" name=""/>
+        <p:cNvGrpSpPr/>
+        <p:nvPr/>
+      </p:nvGrpSpPr>
+      <p:grpSpPr>
+        <a:xfrm>
+          <a:off x="0" y="0"/>
+          <a:ext cx="0" cy="0"/>
+          <a:chOff x="0" y="0"/>
+          <a:chExt cx="0" cy="0"/>
+        </a:xfrm>
+      </p:grpSpPr>
+      <p:sp>
+        <p:nvSpPr>
+          <p:cNvPr id="2" name="Slide Image Placeholder 1"/>
+          <p:cNvSpPr>
+            <a:spLocks noGrp="1"/>
+          </p:cNvSpPr>
+          <p:nvPr>
+            <p:ph type="sldImg" idx="2"/>
+          </p:nvPr>
+        </p:nvSpPr>
+        <p:spPr/>
+      </p:sp>
+      <p:sp>
+        <p:nvSpPr>
+          <p:cNvPr id="3" name="Notes Placeholder 2"/>
+          <p:cNvSpPr>
+            <a:spLocks noGrp="1"/>
+          </p:cNvSpPr>
+          <p:nvPr>
+            <p:ph type="body" idx="3" sz="quarter"/>
+          </p:nvPr>
+        </p:nvSpPr>
+        <p:spPr/>
+        <p:txBody>
+          <a:bodyPr/>
+          <a:lstStyle/>
+          <a:p>
+            <a:r>
+              <a:rPr sz="1200">
+                <a:latin typeface="Calibri"/>
+              </a:rPr>
+              <a:t>Data sources. Three of them, all public. The Advisory Database is the primary source. EPSS gives me exploitation probability. NVD is wired up for CWE and CVSS detail but isn't required for the headline numbers. Labels are a proxy. Real analyst verdicts aren't published at scale, so I combine EPSS plus severity into a heuristic that yields the same 0.6-ish ceiling the EPSS rule baseline gets at Dependabot internally. The rule is documented in dataset.py and reproducible from seed 42. I cap the majority class at 4x the minority. The natural skew is heavier than that, and an extreme imbalance makes training unstable. The parser bug at the bottom is worth a mention because it cost me a day. Older OSV docs say aliases is a list of dicts, current schema says strings. Four regression tests guard the loader.</a:t>
+            </a:r>
+          </a:p>
+        </p:txBody>
+      </p:sp>
+      <p:sp>
+        <p:nvSpPr>
+          <p:cNvPr id="4" name="Slide Number Placeholder 3"/>
+          <p:cNvSpPr>
+            <a:spLocks noGrp="1"/>
+          </p:cNvSpPr>
+          <p:nvPr>
+            <p:ph type="sldNum" idx="5" sz="quarter"/>
+          </p:nvPr>
+        </p:nvSpPr>
+        <p:spPr/>
+      </p:sp>
+    </p:spTree>
+  </p:cSld>
+  <p:clrMapOvr>
+    <a:masterClrMapping/>
+  </p:clrMapOvr>
+</p:notes>
+</file>
+
+<file path=ppt/notesSlides/notesSlide5.xml><?xml version="1.0" encoding="utf-8"?>
+<p:notes xmlns:a="http://schemas.openxmlformats.org/drawingml/2006/main" xmlns:p="http://schemas.openxmlformats.org/presentationml/2006/main" xmlns:r="http://schemas.openxmlformats.org/officeDocument/2006/relationships">
+  <p:cSld>
+    <p:spTree>
+      <p:nvGrpSpPr>
+        <p:cNvPr id="1" name=""/>
+        <p:cNvGrpSpPr/>
+        <p:nvPr/>
+      </p:nvGrpSpPr>
+      <p:grpSpPr>
+        <a:xfrm>
+          <a:off x="0" y="0"/>
+          <a:ext cx="0" cy="0"/>
+          <a:chOff x="0" y="0"/>
+          <a:chExt cx="0" cy="0"/>
+        </a:xfrm>
+      </p:grpSpPr>
+      <p:sp>
+        <p:nvSpPr>
+          <p:cNvPr id="2" name="Slide Image Placeholder 1"/>
+          <p:cNvSpPr>
+            <a:spLocks noGrp="1"/>
+          </p:cNvSpPr>
+          <p:nvPr>
+            <p:ph type="sldImg" idx="2"/>
+          </p:nvPr>
+        </p:nvSpPr>
+        <p:spPr/>
+      </p:sp>
+      <p:sp>
+        <p:nvSpPr>
+          <p:cNvPr id="3" name="Notes Placeholder 2"/>
+          <p:cNvSpPr>
+            <a:spLocks noGrp="1"/>
+          </p:cNvSpPr>
+          <p:nvPr>
+            <p:ph type="body" idx="3" sz="quarter"/>
+          </p:nvPr>
+        </p:nvSpPr>
+        <p:spPr/>
+        <p:txBody>
+          <a:bodyPr/>
+          <a:lstStyle/>
+          <a:p>
+            <a:r>
+              <a:rPr sz="1200">
+                <a:latin typeface="Calibri"/>
+              </a:rPr>
+              <a:t>Baselines. They define the floor. EPSS rule says: if the exploit-probability score is at least 0.01, predict TRUE_POSITIVE. This is roughly how Dependabot today decides what to prioritise. F1 of 0.58 is exactly where you'd expect. TF-IDF plus Logistic Regression does slightly better at 0.61 F1 and notably better on AUC (0.85 versus 0.76). Bag-of-words over CVE descriptions catches some signal the rule misses. Neither baseline can see the application code. They make verdicts only on the CVE itself. That's the gap the rest of the pipeline closes.</a:t>
+            </a:r>
+          </a:p>
+        </p:txBody>
+      </p:sp>
+      <p:sp>
+        <p:nvSpPr>
+          <p:cNvPr id="4" name="Slide Number Placeholder 3"/>
+          <p:cNvSpPr>
+            <a:spLocks noGrp="1"/>
+          </p:cNvSpPr>
+          <p:nvPr>
+            <p:ph type="sldNum" idx="5" sz="quarter"/>
+          </p:nvPr>
+        </p:nvSpPr>
+        <p:spPr/>
+      </p:sp>
+    </p:spTree>
+  </p:cSld>
+  <p:clrMapOvr>
+    <a:masterClrMapping/>
+  </p:clrMapOvr>
+</p:notes>
+</file>
+
+<file path=ppt/notesSlides/notesSlide6.xml><?xml version="1.0" encoding="utf-8"?>
+<p:notes xmlns:a="http://schemas.openxmlformats.org/drawingml/2006/main" xmlns:p="http://schemas.openxmlformats.org/presentationml/2006/main" xmlns:r="http://schemas.openxmlformats.org/officeDocument/2006/relationships">
+  <p:cSld>
+    <p:spTree>
+      <p:nvGrpSpPr>
+        <p:cNvPr id="1" name=""/>
+        <p:cNvGrpSpPr/>
+        <p:nvPr/>
+      </p:nvGrpSpPr>
+      <p:grpSpPr>
+        <a:xfrm>
+          <a:off x="0" y="0"/>
+          <a:ext cx="0" cy="0"/>
+          <a:chOff x="0" y="0"/>
+          <a:chExt cx="0" cy="0"/>
+        </a:xfrm>
+      </p:grpSpPr>
+      <p:sp>
+        <p:nvSpPr>
+          <p:cNvPr id="2" name="Slide Image Placeholder 1"/>
+          <p:cNvSpPr>
+            <a:spLocks noGrp="1"/>
+          </p:cNvSpPr>
+          <p:nvPr>
+            <p:ph type="sldImg" idx="2"/>
+          </p:nvPr>
+        </p:nvSpPr>
+        <p:spPr/>
+      </p:sp>
+      <p:sp>
+        <p:nvSpPr>
+          <p:cNvPr id="3" name="Notes Placeholder 2"/>
+          <p:cNvSpPr>
+            <a:spLocks noGrp="1"/>
+          </p:cNvSpPr>
+          <p:nvPr>
+            <p:ph type="body" idx="3" sz="quarter"/>
+          </p:nvPr>
+        </p:nvSpPr>
+        <p:spPr/>
+        <p:txBody>
+          <a:bodyPr/>
+          <a:lstStyle/>
+          <a:p>
+            <a:r>
+              <a:rPr sz="1200">
+                <a:latin typeface="Calibri"/>
+              </a:rPr>
+              <a:t>Stage 2, RoBERTa fine-tune. Standard hyperparameters. 3 epochs, batch 16, learning rate 2e-5. Around 95 seconds on the A100. Validation F1 climbs steadily across the three epochs. The loss is still going down at epoch 3, so longer training would probably help, but I capped the budget at 3 epochs to keep the comparison clean. On the held-out test set, RoBERTa gets F1 = 0.593 and AUC = 0.828. AUC is better than the EPSS rule, but the F1 is essentially unchanged from the TF-IDF baseline. RoBERTa captures real semantic signal, but text alone cannot solve the harder cases. The reachability features in Stage 3 are what closes the gap.</a:t>
+            </a:r>
+          </a:p>
+        </p:txBody>
+      </p:sp>
+      <p:sp>
+        <p:nvSpPr>
+          <p:cNvPr id="4" name="Slide Number Placeholder 3"/>
+          <p:cNvSpPr>
+            <a:spLocks noGrp="1"/>
+          </p:cNvSpPr>
+          <p:nvPr>
+            <p:ph type="sldNum" idx="5" sz="quarter"/>
+          </p:nvPr>
+        </p:nvSpPr>
+        <p:spPr/>
+      </p:sp>
+    </p:spTree>
+  </p:cSld>
+  <p:clrMapOvr>
+    <a:masterClrMapping/>
+  </p:clrMapOvr>
+</p:notes>
+</file>
+
+<file path=ppt/notesSlides/notesSlide7.xml><?xml version="1.0" encoding="utf-8"?>
+<p:notes xmlns:a="http://schemas.openxmlformats.org/drawingml/2006/main" xmlns:p="http://schemas.openxmlformats.org/presentationml/2006/main" xmlns:r="http://schemas.openxmlformats.org/officeDocument/2006/relationships">
+  <p:cSld>
+    <p:spTree>
+      <p:nvGrpSpPr>
+        <p:cNvPr id="1" name=""/>
+        <p:cNvGrpSpPr/>
+        <p:nvPr/>
+      </p:nvGrpSpPr>
+      <p:grpSpPr>
+        <a:xfrm>
+          <a:off x="0" y="0"/>
+          <a:ext cx="0" cy="0"/>
+          <a:chOff x="0" y="0"/>
+          <a:chExt cx="0" cy="0"/>
+        </a:xfrm>
+      </p:grpSpPr>
+      <p:sp>
+        <p:nvSpPr>
+          <p:cNvPr id="2" name="Slide Image Placeholder 1"/>
+          <p:cNvSpPr>
+            <a:spLocks noGrp="1"/>
+          </p:cNvSpPr>
+          <p:nvPr>
+            <p:ph type="sldImg" idx="2"/>
+          </p:nvPr>
+        </p:nvSpPr>
+        <p:spPr/>
+      </p:sp>
+      <p:sp>
+        <p:nvSpPr>
+          <p:cNvPr id="3" name="Notes Placeholder 2"/>
+          <p:cNvSpPr>
+            <a:spLocks noGrp="1"/>
+          </p:cNvSpPr>
+          <p:nvPr>
+            <p:ph type="body" idx="3" sz="quarter"/>
+          </p:nvPr>
+        </p:nvSpPr>
+        <p:spPr/>
+        <p:txBody>
+          <a:bodyPr/>
+          <a:lstStyle/>
+          <a:p>
+            <a:r>
+              <a:rPr sz="1200">
+                <a:latin typeface="Calibri"/>
+              </a:rPr>
+              <a:t>The core technical contribution. Three layers. The static layer builds a call graph using ast for Python and regex over imports and call expressions for JavaScript. It does a forward search from entry-points to the vulnerable symbol and returns up to 5 paths. This layer is deterministic. No model, no randomness. The semantic layer wraps that with Flan-T5-large. The prompt includes the CVE summary, the static verdict, the paths, and the relevant code excerpt. Flan-T5 returns YES or NO plus a rationale. The intent is that the LLM supplies context the static graph misses, like taint flow. The scale layer handles million-line codebases. Chunk all source files into 25-line windows, embed with MiniLM, build a FAISS index, retrieve the top-k similar chunks to feed to the reasoner. Important caveat. The LLM layer is the weakest link in this build. I'll show you exactly how on the next slide.</a:t>
+            </a:r>
+          </a:p>
+        </p:txBody>
+      </p:sp>
+      <p:sp>
+        <p:nvSpPr>
+          <p:cNvPr id="4" name="Slide Number Placeholder 3"/>
+          <p:cNvSpPr>
+            <a:spLocks noGrp="1"/>
+          </p:cNvSpPr>
+          <p:nvPr>
+            <p:ph type="sldNum" idx="5" sz="quarter"/>
+          </p:nvPr>
+        </p:nvSpPr>
+        <p:spPr/>
+      </p:sp>
+    </p:spTree>
+  </p:cSld>
+  <p:clrMapOvr>
+    <a:masterClrMapping/>
+  </p:clrMapOvr>
+</p:notes>
+</file>
+
+<file path=ppt/notesSlides/notesSlide8.xml><?xml version="1.0" encoding="utf-8"?>
+<p:notes xmlns:a="http://schemas.openxmlformats.org/drawingml/2006/main" xmlns:p="http://schemas.openxmlformats.org/presentationml/2006/main" xmlns:r="http://schemas.openxmlformats.org/officeDocument/2006/relationships">
+  <p:cSld>
+    <p:spTree>
+      <p:nvGrpSpPr>
+        <p:cNvPr id="1" name=""/>
+        <p:cNvGrpSpPr/>
+        <p:nvPr/>
+      </p:nvGrpSpPr>
+      <p:grpSpPr>
+        <a:xfrm>
+          <a:off x="0" y="0"/>
+          <a:ext cx="0" cy="0"/>
+          <a:chOff x="0" y="0"/>
+          <a:chExt cx="0" cy="0"/>
+        </a:xfrm>
+      </p:grpSpPr>
+      <p:sp>
+        <p:nvSpPr>
+          <p:cNvPr id="2" name="Slide Image Placeholder 1"/>
+          <p:cNvSpPr>
+            <a:spLocks noGrp="1"/>
+          </p:cNvSpPr>
+          <p:nvPr>
+            <p:ph type="sldImg" idx="2"/>
+          </p:nvPr>
+        </p:nvSpPr>
+        <p:spPr/>
+      </p:sp>
+      <p:sp>
+        <p:nvSpPr>
+          <p:cNvPr id="3" name="Notes Placeholder 2"/>
+          <p:cNvSpPr>
+            <a:spLocks noGrp="1"/>
+          </p:cNvSpPr>
+          <p:nvPr>
+            <p:ph type="body" idx="3" sz="quarter"/>
+          </p:nvPr>
+        </p:nvSpPr>
+        <p:spPr/>
+        <p:txBody>
+          <a:bodyPr/>
+          <a:lstStyle/>
+          <a:p>
+            <a:r>
+              <a:rPr sz="1200">
+                <a:latin typeface="Calibri"/>
+              </a:rPr>
+              <a:t>This is the slide I'm most proud of, because it's the honest finding. Two synthetic Express apps, both require lodash@4.17.20, identical boilerplate. Only difference is what lodash functions get called. On the SAFE app, the static call graph finds 17 nodes, 16 edges, and _.template is correctly NOT in the graph. Flan-T5 agrees. Verdict is FALSE_POSITIVE at confidence 0.90. Both layers correct. On the VULN app, the static graph correctly identifies that lodash_vuln.js calls _.template. The path is in the evidence. The code literally shows sourceURL = req.query.src, which is the textbook taint pattern. Flan-T5 still returns NO. It says FALSE_POSITIVE at confidence 0.80. That's wrong. Two likely reasons. Flan-T5-large is 780M parameters, which is small for taint reasoning. The prompt also asks a conjunction, reachable AND user-controlled, and Flan-T5 tends to answer NO when it can't satisfy both halves confidently. Lesson: the deterministic part of the pipeline is solid, the LLM contextualiser isn't there yet at this scale. Future work slide has the fix.</a:t>
+            </a:r>
+          </a:p>
+        </p:txBody>
+      </p:sp>
+      <p:sp>
+        <p:nvSpPr>
+          <p:cNvPr id="4" name="Slide Number Placeholder 3"/>
+          <p:cNvSpPr>
+            <a:spLocks noGrp="1"/>
+          </p:cNvSpPr>
+          <p:nvPr>
+            <p:ph type="sldNum" idx="5" sz="quarter"/>
+          </p:nvPr>
+        </p:nvSpPr>
+        <p:spPr/>
+      </p:sp>
+    </p:spTree>
+  </p:cSld>
+  <p:clrMapOvr>
+    <a:masterClrMapping/>
+  </p:clrMapOvr>
+</p:notes>
+</file>
+
+<file path=ppt/notesSlides/notesSlide9.xml><?xml version="1.0" encoding="utf-8"?>
+<p:notes xmlns:a="http://schemas.openxmlformats.org/drawingml/2006/main" xmlns:p="http://schemas.openxmlformats.org/presentationml/2006/main" xmlns:r="http://schemas.openxmlformats.org/officeDocument/2006/relationships">
+  <p:cSld>
+    <p:spTree>
+      <p:nvGrpSpPr>
+        <p:cNvPr id="1" name=""/>
+        <p:cNvGrpSpPr/>
+        <p:nvPr/>
+      </p:nvGrpSpPr>
+      <p:grpSpPr>
+        <a:xfrm>
+          <a:off x="0" y="0"/>
+          <a:ext cx="0" cy="0"/>
+          <a:chOff x="0" y="0"/>
+          <a:chExt cx="0" cy="0"/>
+        </a:xfrm>
+      </p:grpSpPr>
+      <p:sp>
+        <p:nvSpPr>
+          <p:cNvPr id="2" name="Slide Image Placeholder 1"/>
+          <p:cNvSpPr>
+            <a:spLocks noGrp="1"/>
+          </p:cNvSpPr>
+          <p:nvPr>
+            <p:ph type="sldImg" idx="2"/>
+          </p:nvPr>
+        </p:nvSpPr>
+        <p:spPr/>
+      </p:sp>
+      <p:sp>
+        <p:nvSpPr>
+          <p:cNvPr id="3" name="Notes Placeholder 2"/>
+          <p:cNvSpPr>
+            <a:spLocks noGrp="1"/>
+          </p:cNvSpPr>
+          <p:nvPr>
+            <p:ph type="body" idx="3" sz="quarter"/>
+          </p:nvPr>
+        </p:nvSpPr>
+        <p:spPr/>
+        <p:txBody>
+          <a:bodyPr/>
+          <a:lstStyle/>
+          <a:p>
+            <a:r>
+              <a:rPr sz="1200">
+                <a:latin typeface="Calibri"/>
+              </a:rPr>
+              <a:t>Stage 4 is the simple part. Concatenate the 768-d RoBERTa CLS embedding, the 5 structured features, and the 2 reachability signals. That's 775 features per alert. Train a class-balanced Logistic Regression head. Why Logistic Regression and not an MLP? Two reasons. It's faster to train and to inspect, and it doesn't confound the question of how much value the reachability features add. With a linear head, the coefficient magnitudes tell you directly. The footnote is the most important text on this slide. Per-advisory consumer repositories aren't available at scale, so the reachability features in training are synthesised from the ground-truth label with 15% noise. That's labelled clearly in the notebook (cell 6) and I'll be explicit about what this means for the headline F1 in two slides.</a:t>
+            </a:r>
+          </a:p>
+        </p:txBody>
+      </p:sp>
+      <p:sp>
+        <p:nvSpPr>
+          <p:cNvPr id="4" name="Slide Number Placeholder 3"/>
+          <p:cNvSpPr>
+            <a:spLocks noGrp="1"/>
+          </p:cNvSpPr>
+          <p:nvPr>
+            <p:ph type="sldNum" idx="5" sz="quarter"/>
+          </p:nvPr>
+        </p:nvSpPr>
+        <p:spPr/>
+      </p:sp>
+    </p:spTree>
+  </p:cSld>
+  <p:clrMapOvr>
+    <a:masterClrMapping/>
+  </p:clrMapOvr>
+</p:notes>
 </file>
 
 <file path=ppt/slideLayouts/slideLayout1.xml><?xml version="1.0" encoding="utf-8"?>
@@ -3162,13 +4607,13 @@
           <a:noFill/>
         </p:spPr>
         <p:txBody>
-          <a:bodyPr wrap="none" lIns="0">
-            <a:spAutoFit/>
-          </a:bodyPr>
-          <a:lstStyle/>
-          <a:p>
-            <a:r>
-              <a:rPr sz="1300" b="1" i="0">
+          <a:bodyPr wrap="none">
+            <a:spAutoFit/>
+          </a:bodyPr>
+          <a:lstStyle/>
+          <a:p>
+            <a:r>
+              <a:rPr sz="1300" b="1">
                 <a:solidFill>
                   <a:srgbClr val="CADCFC"/>
                 </a:solidFill>
@@ -3196,7 +4641,7 @@
           <a:noFill/>
         </p:spPr>
         <p:txBody>
-          <a:bodyPr wrap="square" lIns="0">
+          <a:bodyPr wrap="square">
             <a:spAutoFit/>
           </a:bodyPr>
           <a:lstStyle/>
@@ -3242,7 +4687,7 @@
           <a:noFill/>
         </p:spPr>
         <p:txBody>
-          <a:bodyPr wrap="none" lIns="0">
+          <a:bodyPr wrap="none">
             <a:spAutoFit/>
           </a:bodyPr>
           <a:lstStyle/>
@@ -3276,7 +4721,7 @@
           <a:noFill/>
         </p:spPr>
         <p:txBody>
-          <a:bodyPr wrap="none" lIns="0">
+          <a:bodyPr wrap="none">
             <a:spAutoFit/>
           </a:bodyPr>
           <a:lstStyle/>
@@ -3288,7 +4733,7 @@
                 </a:solidFill>
                 <a:latin typeface="Calibri"/>
               </a:rPr>
-              <a:t>Harvard Extension School · Foundations of Large Language Models</a:t>
+              <a:t>Harvard Extension School, Foundations of Large Language Models</a:t>
             </a:r>
           </a:p>
         </p:txBody>
@@ -3310,7 +4755,7 @@
           <a:noFill/>
         </p:spPr>
         <p:txBody>
-          <a:bodyPr wrap="none" lIns="0">
+          <a:bodyPr wrap="none">
             <a:spAutoFit/>
           </a:bodyPr>
           <a:lstStyle/>
@@ -3357,7 +4802,7 @@
           <a:noFill/>
         </p:spPr>
         <p:txBody>
-          <a:bodyPr wrap="none" lIns="0">
+          <a:bodyPr wrap="none">
             <a:spAutoFit/>
           </a:bodyPr>
           <a:lstStyle/>
@@ -3404,7 +4849,7 @@
           <a:noFill/>
         </p:spPr>
         <p:txBody>
-          <a:bodyPr wrap="none" lIns="0">
+          <a:bodyPr wrap="none">
             <a:spAutoFit/>
           </a:bodyPr>
           <a:lstStyle/>
@@ -3429,7 +4874,7 @@
                 </a:solidFill>
                 <a:latin typeface="Calibri"/>
               </a:rPr>
-              <a:t>only 2 of 212 TPs missed</a:t>
+              <a:t>2 of 212 TPs missed</a:t>
             </a:r>
           </a:p>
         </p:txBody>
@@ -3451,7 +4896,7 @@
           <a:noFill/>
         </p:spPr>
         <p:txBody>
-          <a:bodyPr wrap="none" lIns="0">
+          <a:bodyPr wrap="none">
             <a:spAutoFit/>
           </a:bodyPr>
           <a:lstStyle/>
@@ -3559,7 +5004,7 @@
           <a:noFill/>
         </p:spPr>
         <p:txBody>
-          <a:bodyPr wrap="none" lIns="0">
+          <a:bodyPr wrap="none">
             <a:spAutoFit/>
           </a:bodyPr>
           <a:lstStyle/>
@@ -3572,7 +5017,7 @@
                 </a:solidFill>
                 <a:latin typeface="Calibri"/>
               </a:rPr>
-              <a:t>Results — 1,002-alert held-out test set</a:t>
+              <a:t>Results: 1,002-alert held-out test set</a:t>
             </a:r>
           </a:p>
         </p:txBody>
@@ -3594,7 +5039,7 @@
           <a:noFill/>
         </p:spPr>
         <p:txBody>
-          <a:bodyPr wrap="none" lIns="0">
+          <a:bodyPr wrap="none">
             <a:spAutoFit/>
           </a:bodyPr>
           <a:lstStyle/>
@@ -3607,7 +5052,7 @@
                 </a:solidFill>
                 <a:latin typeface="Calibri"/>
               </a:rPr>
-              <a:t>Each stage's marginal contribution to F1</a:t>
+              <a:t>Marginal F1 contribution at each stage.</a:t>
             </a:r>
           </a:p>
         </p:txBody>
@@ -3768,7 +5213,7 @@
                           </a:solidFill>
                           <a:latin typeface="Calibri"/>
                         </a:rPr>
-                        <a:t>EPSS-threshold rule (≥ 0.01)</a:t>
+                        <a:t>EPSS rule (threshold 0.01)</a:t>
                       </a:r>
                     </a:p>
                   </a:txBody>
@@ -4475,7 +5920,7 @@
           <a:noFill/>
         </p:spPr>
         <p:txBody>
-          <a:bodyPr wrap="none" lIns="0" rIns="0">
+          <a:bodyPr wrap="none">
             <a:spAutoFit/>
           </a:bodyPr>
           <a:lstStyle/>
@@ -4606,7 +6051,7 @@
           <a:noFill/>
         </p:spPr>
         <p:txBody>
-          <a:bodyPr wrap="none" lIns="0">
+          <a:bodyPr wrap="none">
             <a:spAutoFit/>
           </a:bodyPr>
           <a:lstStyle/>
@@ -4619,7 +6064,7 @@
                 </a:solidFill>
                 <a:latin typeface="Calibri"/>
               </a:rPr>
-              <a:t>Confusion matrix — full pipeline</a:t>
+              <a:t>Confusion matrix: full pipeline</a:t>
             </a:r>
           </a:p>
         </p:txBody>
@@ -4641,7 +6086,7 @@
           <a:noFill/>
         </p:spPr>
         <p:txBody>
-          <a:bodyPr wrap="none" lIns="0">
+          <a:bodyPr wrap="none">
             <a:spAutoFit/>
           </a:bodyPr>
           <a:lstStyle/>
@@ -4654,7 +6099,7 @@
                 </a:solidFill>
                 <a:latin typeface="Calibri"/>
               </a:rPr>
-              <a:t>2 misses on 212 true positives.  0 false alarms on 790 negatives.</a:t>
+              <a:t>Two misses on 212 true positives. Zero false alarms on 790 negatives.</a:t>
             </a:r>
           </a:p>
         </p:txBody>
@@ -4766,7 +6211,7 @@
           <a:noFill/>
         </p:spPr>
         <p:txBody>
-          <a:bodyPr wrap="none" lIns="0">
+          <a:bodyPr wrap="none">
             <a:spAutoFit/>
           </a:bodyPr>
           <a:lstStyle/>
@@ -4846,7 +6291,7 @@
           <a:noFill/>
         </p:spPr>
         <p:txBody>
-          <a:bodyPr wrap="none" lIns="0">
+          <a:bodyPr wrap="none">
             <a:spAutoFit/>
           </a:bodyPr>
           <a:lstStyle/>
@@ -4926,7 +6371,7 @@
           <a:noFill/>
         </p:spPr>
         <p:txBody>
-          <a:bodyPr wrap="none" lIns="0">
+          <a:bodyPr wrap="none">
             <a:spAutoFit/>
           </a:bodyPr>
           <a:lstStyle/>
@@ -4961,7 +6406,7 @@
           <a:noFill/>
         </p:spPr>
         <p:txBody>
-          <a:bodyPr wrap="none" lIns="0">
+          <a:bodyPr wrap="none">
             <a:spAutoFit/>
           </a:bodyPr>
           <a:lstStyle/>
@@ -5041,7 +6486,7 @@
           <a:noFill/>
         </p:spPr>
         <p:txBody>
-          <a:bodyPr wrap="none" lIns="0">
+          <a:bodyPr wrap="none">
             <a:spAutoFit/>
           </a:bodyPr>
           <a:lstStyle/>
@@ -5076,7 +6521,7 @@
           <a:noFill/>
         </p:spPr>
         <p:txBody>
-          <a:bodyPr wrap="none" lIns="0">
+          <a:bodyPr wrap="none">
             <a:spAutoFit/>
           </a:bodyPr>
           <a:lstStyle/>
@@ -5156,7 +6601,7 @@
           <a:noFill/>
         </p:spPr>
         <p:txBody>
-          <a:bodyPr wrap="none" lIns="0">
+          <a:bodyPr wrap="none">
             <a:spAutoFit/>
           </a:bodyPr>
           <a:lstStyle/>
@@ -5191,7 +6636,7 @@
           <a:noFill/>
         </p:spPr>
         <p:txBody>
-          <a:bodyPr wrap="none" lIns="0">
+          <a:bodyPr wrap="none">
             <a:spAutoFit/>
           </a:bodyPr>
           <a:lstStyle/>
@@ -5271,7 +6716,7 @@
           <a:noFill/>
         </p:spPr>
         <p:txBody>
-          <a:bodyPr wrap="none" lIns="0">
+          <a:bodyPr wrap="none">
             <a:spAutoFit/>
           </a:bodyPr>
           <a:lstStyle/>
@@ -5306,7 +6751,7 @@
           <a:noFill/>
         </p:spPr>
         <p:txBody>
-          <a:bodyPr wrap="none" lIns="0">
+          <a:bodyPr wrap="none">
             <a:spAutoFit/>
           </a:bodyPr>
           <a:lstStyle/>
@@ -5386,7 +6831,7 @@
           <a:noFill/>
         </p:spPr>
         <p:txBody>
-          <a:bodyPr wrap="none" lIns="0">
+          <a:bodyPr wrap="none">
             <a:spAutoFit/>
           </a:bodyPr>
           <a:lstStyle/>
@@ -5421,7 +6866,7 @@
           <a:noFill/>
         </p:spPr>
         <p:txBody>
-          <a:bodyPr wrap="none" lIns="0">
+          <a:bodyPr wrap="none">
             <a:spAutoFit/>
           </a:bodyPr>
           <a:lstStyle/>
@@ -5501,7 +6946,7 @@
           <a:noFill/>
         </p:spPr>
         <p:txBody>
-          <a:bodyPr wrap="none" lIns="0">
+          <a:bodyPr wrap="none">
             <a:spAutoFit/>
           </a:bodyPr>
           <a:lstStyle/>
@@ -5536,7 +6981,7 @@
           <a:noFill/>
         </p:spPr>
         <p:txBody>
-          <a:bodyPr wrap="none" lIns="0">
+          <a:bodyPr wrap="none">
             <a:spAutoFit/>
           </a:bodyPr>
           <a:lstStyle/>
@@ -5584,7 +7029,7 @@
                 </a:solidFill>
                 <a:latin typeface="Calibri"/>
               </a:rPr>
-              <a:t>Recall = 0.991 — only two TPs missed.  Precision = 1.000 — zero false alarms.  F1 = 0.995.</a:t>
+              <a:t>Recall 0.991, precision 1.000, F1 0.995. Trading one false alarm against one missed exploit is the wrong tradeoff in security.</a:t>
             </a:r>
           </a:p>
         </p:txBody>
@@ -5606,7 +7051,7 @@
           <a:noFill/>
         </p:spPr>
         <p:txBody>
-          <a:bodyPr wrap="none" lIns="0" rIns="0">
+          <a:bodyPr wrap="none">
             <a:spAutoFit/>
           </a:bodyPr>
           <a:lstStyle/>
@@ -5737,7 +7182,7 @@
           <a:noFill/>
         </p:spPr>
         <p:txBody>
-          <a:bodyPr wrap="none" lIns="0">
+          <a:bodyPr wrap="none">
             <a:spAutoFit/>
           </a:bodyPr>
           <a:lstStyle/>
@@ -5750,7 +7195,7 @@
                 </a:solidFill>
                 <a:latin typeface="Calibri"/>
               </a:rPr>
-              <a:t>What worked — and what did not</a:t>
+              <a:t>What worked, and what did not</a:t>
             </a:r>
           </a:p>
         </p:txBody>
@@ -5772,7 +7217,7 @@
           <a:noFill/>
         </p:spPr>
         <p:txBody>
-          <a:bodyPr wrap="none" lIns="0">
+          <a:bodyPr wrap="none">
             <a:spAutoFit/>
           </a:bodyPr>
           <a:lstStyle/>
@@ -5785,7 +7230,7 @@
                 </a:solidFill>
                 <a:latin typeface="Calibri"/>
               </a:rPr>
-              <a:t>Honest accounting before we promise this in production</a:t>
+              <a:t>Honest accounting before any production claim.</a:t>
             </a:r>
           </a:p>
         </p:txBody>
@@ -5866,7 +7311,7 @@
                 </a:solidFill>
                 <a:latin typeface="Calibri"/>
               </a:rPr>
-              <a:t>✓ Worked</a:t>
+              <a:t>Worked</a:t>
             </a:r>
           </a:p>
         </p:txBody>
@@ -5905,7 +7350,7 @@
                 </a:solidFill>
                 <a:latin typeface="Calibri"/>
               </a:rPr>
-              <a:t>•  End-to-end pipeline reproducible from fresh Colab in ~5 min.</a:t>
+              <a:t>•  Reproducible from a fresh Colab session in around 5 minutes.</a:t>
             </a:r>
           </a:p>
           <a:p>
@@ -5921,7 +7366,7 @@
                 </a:solidFill>
                 <a:latin typeface="Calibri"/>
               </a:rPr>
-              <a:t>•  Static call graph correctly distinguishes SAFE vs VULN lodash apps.</a:t>
+              <a:t>•  Static call graph correctly distinguishes the SAFE and VULN lodash apps.</a:t>
             </a:r>
           </a:p>
           <a:p>
@@ -5937,7 +7382,7 @@
                 </a:solidFill>
                 <a:latin typeface="Calibri"/>
               </a:rPr>
-              <a:t>•  0.42-point F1 lift from RoBERTa alone to full pipeline confirms reachability is the dominant signal.</a:t>
+              <a:t>•  0.42-point F1 lift over RoBERTa alone matches the project hypothesis.</a:t>
             </a:r>
           </a:p>
           <a:p>
@@ -5953,7 +7398,7 @@
                 </a:solidFill>
                 <a:latin typeface="Calibri"/>
               </a:rPr>
-              <a:t>•  CodeBERT + FAISS scales: 3.5× sim gap between vulnerable and safe code.</a:t>
+              <a:t>•  FAISS fallback gives a 3.5x similarity gap between vulnerable and safe code.</a:t>
             </a:r>
           </a:p>
           <a:p>
@@ -5969,7 +7414,7 @@
                 </a:solidFill>
                 <a:latin typeface="Calibri"/>
               </a:rPr>
-              <a:t>•  15 unit tests; CI-friendly module layout; pip-installable.</a:t>
+              <a:t>•  15 unit tests, CI-friendly module layout, pip-installable package.</a:t>
             </a:r>
           </a:p>
         </p:txBody>
@@ -6050,7 +7495,7 @@
                 </a:solidFill>
                 <a:latin typeface="Calibri"/>
               </a:rPr>
-              <a:t>✗ Did not work / limitations</a:t>
+              <a:t>Did not work / limitations</a:t>
             </a:r>
           </a:p>
         </p:txBody>
@@ -6089,7 +7534,7 @@
                 </a:solidFill>
                 <a:latin typeface="Calibri"/>
               </a:rPr>
-              <a:t>•  Flan-T5-large returned wrong verdict on VULN lodash — taint reasoning is beyond its capability.</a:t>
+              <a:t>•  Flan-T5-large returned the wrong verdict on the VULN lodash app.</a:t>
             </a:r>
           </a:p>
           <a:p>
@@ -6105,7 +7550,7 @@
                 </a:solidFill>
                 <a:latin typeface="Calibri"/>
               </a:rPr>
-              <a:t>•  0.995 F1 is an UPPER BOUND — reachability features for the 10K set are synthesised with 15% noise.</a:t>
+              <a:t>•  0.995 F1 is an upper bound. Training reachability features are synthesised with 15% noise.</a:t>
             </a:r>
           </a:p>
           <a:p>
@@ -6121,7 +7566,7 @@
                 </a:solidFill>
                 <a:latin typeface="Calibri"/>
               </a:rPr>
-              <a:t>•  Regex JS parser misses dynamic dispatch and eval (≈85-90% coverage).</a:t>
+              <a:t>•  Regex JS parser misses dynamic dispatch and eval (around 85-90% coverage).</a:t>
             </a:r>
           </a:p>
           <a:p>
@@ -6137,7 +7582,7 @@
                 </a:solidFill>
                 <a:latin typeface="Calibri"/>
               </a:rPr>
-              <a:t>•  VULN_SYMBOL_MAP curated for 10 CVEs; production needs ~10K.</a:t>
+              <a:t>•  VULN_SYMBOL_MAP covers 10 CVEs. Production needs roughly 10K.</a:t>
             </a:r>
           </a:p>
           <a:p>
@@ -6153,7 +7598,7 @@
                 </a:solidFill>
                 <a:latin typeface="Calibri"/>
               </a:rPr>
-              <a:t>•  Proxy labels correlate with EPSS by construction — inflates the EPSS-rule baseline ceiling.</a:t>
+              <a:t>•  Proxy label correlates with EPSS, which inflates the EPSS-rule ceiling.</a:t>
             </a:r>
           </a:p>
         </p:txBody>
@@ -6175,7 +7620,7 @@
           <a:noFill/>
         </p:spPr>
         <p:txBody>
-          <a:bodyPr wrap="none" lIns="0" rIns="0">
+          <a:bodyPr wrap="none">
             <a:spAutoFit/>
           </a:bodyPr>
           <a:lstStyle/>
@@ -6306,7 +7751,7 @@
           <a:noFill/>
         </p:spPr>
         <p:txBody>
-          <a:bodyPr wrap="none" lIns="0">
+          <a:bodyPr wrap="none">
             <a:spAutoFit/>
           </a:bodyPr>
           <a:lstStyle/>
@@ -6319,7 +7764,7 @@
                 </a:solidFill>
                 <a:latin typeface="Calibri"/>
               </a:rPr>
-              <a:t>Future work — concrete next steps</a:t>
+              <a:t>Future work: concrete next steps</a:t>
             </a:r>
           </a:p>
         </p:txBody>
@@ -6341,7 +7786,7 @@
           <a:noFill/>
         </p:spPr>
         <p:txBody>
-          <a:bodyPr wrap="none" lIns="0">
+          <a:bodyPr wrap="none">
             <a:spAutoFit/>
           </a:bodyPr>
           <a:lstStyle/>
@@ -6354,7 +7799,7 @@
                 </a:solidFill>
                 <a:latin typeface="Calibri"/>
               </a:rPr>
-              <a:t>Each item below addresses a specific limitation from the previous slide</a:t>
+              <a:t>Each item maps to a specific limitation from the previous slide.</a:t>
             </a:r>
           </a:p>
         </p:txBody>
@@ -6395,7 +7840,7 @@
           </a:fontRef>
         </p:style>
         <p:txBody>
-          <a:bodyPr rtlCol="0" anchor="ctr" tIns="0" bIns="0"/>
+          <a:bodyPr rtlCol="0" anchor="ctr"/>
           <a:lstStyle/>
           <a:p>
             <a:pPr algn="ctr"/>
@@ -6441,7 +7886,7 @@
                 </a:solidFill>
                 <a:latin typeface="Calibri"/>
               </a:rPr>
-              <a:t>Replace regex JS parser with tree-sitter</a:t>
+              <a:t>Replace the regex JS parser with tree-sitter</a:t>
             </a:r>
           </a:p>
         </p:txBody>
@@ -6476,7 +7921,7 @@
                 </a:solidFill>
                 <a:latin typeface="Calibri"/>
               </a:rPr>
-              <a:t>AST-level accuracy. Closes the dynamic-dispatch and TS-generics gaps.</a:t>
+              <a:t>AST-level accuracy closes the dynamic-dispatch and TypeScript-generics gaps.</a:t>
             </a:r>
           </a:p>
         </p:txBody>
@@ -6517,7 +7962,7 @@
           </a:fontRef>
         </p:style>
         <p:txBody>
-          <a:bodyPr rtlCol="0" anchor="ctr" tIns="0" bIns="0"/>
+          <a:bodyPr rtlCol="0" anchor="ctr"/>
           <a:lstStyle/>
           <a:p>
             <a:pPr algn="ctr"/>
@@ -6639,7 +8084,7 @@
           </a:fontRef>
         </p:style>
         <p:txBody>
-          <a:bodyPr rtlCol="0" anchor="ctr" tIns="0" bIns="0"/>
+          <a:bodyPr rtlCol="0" anchor="ctr"/>
           <a:lstStyle/>
           <a:p>
             <a:pPr algn="ctr"/>
@@ -6720,7 +8165,7 @@
                 </a:solidFill>
                 <a:latin typeface="Calibri"/>
               </a:rPr>
-              <a:t>Track sources (req.query, req.body, env) to sinks (exec, eval, template sourceURL). Removes the LLM dependency for the easy taint cases.</a:t>
+              <a:t>Track sources (req.query, req.body, env) to sinks (exec, eval, template sourceURL). Removes the LLM dependency for easy taint cases.</a:t>
             </a:r>
           </a:p>
         </p:txBody>
@@ -6761,7 +8206,7 @@
           </a:fontRef>
         </p:style>
         <p:txBody>
-          <a:bodyPr rtlCol="0" anchor="ctr" tIns="0" bIns="0"/>
+          <a:bodyPr rtlCol="0" anchor="ctr"/>
           <a:lstStyle/>
           <a:p>
             <a:pPr algn="ctr"/>
@@ -6842,7 +8287,7 @@
                 </a:solidFill>
                 <a:latin typeface="Calibri"/>
               </a:rPr>
-              <a:t>Sample 200-500 advisories with public patch commits → mine the vulnerable symbol → label reachability against a real consumer-repo corpus. Converts the 0.995 upper bound into a defensible production number.</a:t>
+              <a:t>Sample 200 to 500 advisories with public patch commits, mine the vulnerable symbol from the diff, label reachability against real consumer repos. Converts the 0.995 upper bound into a deployment number.</a:t>
             </a:r>
           </a:p>
         </p:txBody>
@@ -6883,7 +8328,7 @@
           </a:fontRef>
         </p:style>
         <p:txBody>
-          <a:bodyPr rtlCol="0" anchor="ctr" tIns="0" bIns="0"/>
+          <a:bodyPr rtlCol="0" anchor="ctr"/>
           <a:lstStyle/>
           <a:p>
             <a:pPr algn="ctr"/>
@@ -6964,7 +8409,7 @@
                 </a:solidFill>
                 <a:latin typeface="Calibri"/>
               </a:rPr>
-              <a:t>Return reachable / unreachable / unknown with thresholded probabilities, not a hard boolean. Surface only the uncertain band to human analysts.</a:t>
+              <a:t>Return reachable, unreachable, or unknown with thresholded probabilities. Surface only the uncertain band to a human reviewer.</a:t>
             </a:r>
           </a:p>
         </p:txBody>
@@ -7005,7 +8450,7 @@
           </a:fontRef>
         </p:style>
         <p:txBody>
-          <a:bodyPr rtlCol="0" anchor="ctr" tIns="0" bIns="0"/>
+          <a:bodyPr rtlCol="0" anchor="ctr"/>
           <a:lstStyle/>
           <a:p>
             <a:pPr algn="ctr"/>
@@ -7086,7 +8531,7 @@
                 </a:solidFill>
                 <a:latin typeface="Calibri"/>
               </a:rPr>
-              <a:t>Prompt for vulnerable symbol from patch diff; cache; manual review of low-confidence extractions.</a:t>
+              <a:t>Prompt for the vulnerable symbol from each patch diff, cache, manually review the low-confidence extractions.</a:t>
             </a:r>
           </a:p>
         </p:txBody>
@@ -7108,7 +8553,7 @@
           <a:noFill/>
         </p:spPr>
         <p:txBody>
-          <a:bodyPr wrap="none" lIns="0" rIns="0">
+          <a:bodyPr wrap="none">
             <a:spAutoFit/>
           </a:bodyPr>
           <a:lstStyle/>
@@ -7239,7 +8684,7 @@
           <a:noFill/>
         </p:spPr>
         <p:txBody>
-          <a:bodyPr wrap="none" lIns="0">
+          <a:bodyPr wrap="none">
             <a:spAutoFit/>
           </a:bodyPr>
           <a:lstStyle/>
@@ -7252,7 +8697,7 @@
                 </a:solidFill>
                 <a:latin typeface="Calibri"/>
               </a:rPr>
-              <a:t>Reproducibility — clone, run, get the same numbers</a:t>
+              <a:t>Reproducibility: clone, run, get the same numbers</a:t>
             </a:r>
           </a:p>
         </p:txBody>
@@ -7274,7 +8719,7 @@
           <a:noFill/>
         </p:spPr>
         <p:txBody>
-          <a:bodyPr wrap="none" lIns="0">
+          <a:bodyPr wrap="none">
             <a:spAutoFit/>
           </a:bodyPr>
           <a:lstStyle/>
@@ -7287,7 +8732,7 @@
                 </a:solidFill>
                 <a:latin typeface="Calibri"/>
               </a:rPr>
-              <a:t>All code public.  All datasets public.  All seeds fixed.</a:t>
+              <a:t>All code public. All datasets public. All seeds fixed.</a:t>
             </a:r>
           </a:p>
         </p:txBody>
@@ -7322,7 +8767,7 @@
                 </a:solidFill>
                 <a:latin typeface="Calibri"/>
               </a:rPr>
-              <a:t>Option A — Google Colab (recommended)</a:t>
+              <a:t>Option A, Google Colab (recommended)</a:t>
             </a:r>
           </a:p>
         </p:txBody>
@@ -7387,7 +8832,7 @@
           <a:noFill/>
         </p:spPr>
         <p:txBody>
-          <a:bodyPr wrap="square" lIns="0" rIns="0">
+          <a:bodyPr wrap="square">
             <a:spAutoFit/>
           </a:bodyPr>
           <a:lstStyle/>
@@ -7420,7 +8865,7 @@
                 </a:solidFill>
                 <a:latin typeface="Consolas"/>
               </a:rPr>
-              <a:t>2. Runtime → Change runtime type → A100 GPU</a:t>
+              <a:t>2. Runtime &gt; Change runtime type &gt; A100 GPU</a:t>
             </a:r>
           </a:p>
           <a:p>
@@ -7436,7 +8881,7 @@
                 </a:solidFill>
                 <a:latin typeface="Consolas"/>
               </a:rPr>
-              <a:t>3. Runtime → Run all  (≈ 5 min in synthetic mode, ≈ 25 min in real mode on A100)</a:t>
+              <a:t>3. Runtime &gt; Run all  (around 5 min synthetic, around 25 min real on A100)</a:t>
             </a:r>
           </a:p>
         </p:txBody>
@@ -7471,7 +8916,7 @@
                 </a:solidFill>
                 <a:latin typeface="Calibri"/>
               </a:rPr>
-              <a:t>Option B — local</a:t>
+              <a:t>Option B, local</a:t>
             </a:r>
           </a:p>
         </p:txBody>
@@ -7536,7 +8981,7 @@
           <a:noFill/>
         </p:spPr>
         <p:txBody>
-          <a:bodyPr wrap="square" lIns="0" rIns="0">
+          <a:bodyPr wrap="square">
             <a:spAutoFit/>
           </a:bodyPr>
           <a:lstStyle/>
@@ -7691,7 +9136,7 @@
                 </a:solidFill>
                 <a:latin typeface="Calibri"/>
               </a:rPr>
-              <a:t>•  github/advisory-database  —  shallow-clone (~400 MB), auto-downloaded on first run</a:t>
+              <a:t>•  github/advisory-database, shallow-clone (~400 MB), auto-downloaded on first run.</a:t>
             </a:r>
           </a:p>
           <a:p>
@@ -7707,7 +9152,7 @@
                 </a:solidFill>
                 <a:latin typeface="Calibri"/>
               </a:rPr>
-              <a:t>•  FIRST EPSS  —  daily CSV, auto-downloaded; cached to Drive in Colab</a:t>
+              <a:t>•  FIRST EPSS, daily CSV, auto-downloaded. Cached to Drive in Colab.</a:t>
             </a:r>
           </a:p>
         </p:txBody>
@@ -7729,7 +9174,7 @@
           <a:noFill/>
         </p:spPr>
         <p:txBody>
-          <a:bodyPr wrap="none" lIns="0" rIns="0">
+          <a:bodyPr wrap="none">
             <a:spAutoFit/>
           </a:bodyPr>
           <a:lstStyle/>
@@ -7860,7 +9305,7 @@
           <a:noFill/>
         </p:spPr>
         <p:txBody>
-          <a:bodyPr wrap="none" lIns="0">
+          <a:bodyPr wrap="none">
             <a:spAutoFit/>
           </a:bodyPr>
           <a:lstStyle/>
@@ -7895,7 +9340,7 @@
           <a:noFill/>
         </p:spPr>
         <p:txBody>
-          <a:bodyPr wrap="none" lIns="0">
+          <a:bodyPr wrap="none">
             <a:spAutoFit/>
           </a:bodyPr>
           <a:lstStyle/>
@@ -7975,7 +9420,7 @@
           <a:noFill/>
         </p:spPr>
         <p:txBody>
-          <a:bodyPr wrap="none" lIns="0">
+          <a:bodyPr wrap="none">
             <a:spAutoFit/>
           </a:bodyPr>
           <a:lstStyle/>
@@ -8010,7 +9455,7 @@
           <a:noFill/>
         </p:spPr>
         <p:txBody>
-          <a:bodyPr wrap="none" lIns="0">
+          <a:bodyPr wrap="none">
             <a:spAutoFit/>
           </a:bodyPr>
           <a:lstStyle/>
@@ -8058,7 +9503,7 @@
                 </a:solidFill>
                 <a:latin typeface="Calibri"/>
               </a:rPr>
-              <a:t>@AnkitKumarHoney  |  CSCI E-222  |  Spring 2026</a:t>
+              <a:t>Ankit Kumar Honey  |  CSCI E-222  |  Spring 2026</a:t>
             </a:r>
           </a:p>
         </p:txBody>
@@ -8141,7 +9586,7 @@
           <a:noFill/>
         </p:spPr>
         <p:txBody>
-          <a:bodyPr wrap="none" lIns="0">
+          <a:bodyPr wrap="none">
             <a:spAutoFit/>
           </a:bodyPr>
           <a:lstStyle/>
@@ -8154,7 +9599,7 @@
                 </a:solidFill>
                 <a:latin typeface="Calibri"/>
               </a:rPr>
-              <a:t>The problem — alert fatigue is the bottleneck</a:t>
+              <a:t>The problem: alert fatigue is the bottleneck</a:t>
             </a:r>
           </a:p>
         </p:txBody>
@@ -8176,7 +9621,7 @@
           <a:noFill/>
         </p:spPr>
         <p:txBody>
-          <a:bodyPr wrap="none" lIns="0">
+          <a:bodyPr wrap="none">
             <a:spAutoFit/>
           </a:bodyPr>
           <a:lstStyle/>
@@ -8189,7 +9634,7 @@
                 </a:solidFill>
                 <a:latin typeface="Calibri"/>
               </a:rPr>
-              <a:t>Same CVE. Same package. Same CVSS. Same EPSS. Different real-world risk.</a:t>
+              <a:t>Same CVE, same package, same CVSS, same EPSS, different real-world risk.</a:t>
             </a:r>
           </a:p>
         </p:txBody>
@@ -8244,7 +9689,7 @@
                 </a:solidFill>
                 <a:latin typeface="Calibri"/>
               </a:rPr>
-              <a:t>•  A large fraction are technically valid but functionally irrelevant — the vulnerable function is never reached by the consuming application.</a:t>
+              <a:t>•  A large fraction are technically valid but functionally irrelevant. The vulnerable function is never reached by the consuming application.</a:t>
             </a:r>
           </a:p>
           <a:p>
@@ -8276,7 +9721,7 @@
                 </a:solidFill>
                 <a:latin typeface="Calibri"/>
               </a:rPr>
-              <a:t>•  Pure severity (CVSS) and exploit probability (EPSS) cannot resolve this — they describe the CVE, not the application.</a:t>
+              <a:t>•  Pure severity (CVSS) and exploit probability (EPSS) cannot resolve this. They describe the CVE, not the application.</a:t>
             </a:r>
           </a:p>
           <a:p>
@@ -8292,7 +9737,7 @@
                 </a:solidFill>
                 <a:latin typeface="Calibri"/>
               </a:rPr>
-              <a:t>•  Course parallel: identical structure to fake-news classification — true vs. misleading-in-context.</a:t>
+              <a:t>•  Course parallel: identical structure to fake-news classification. True versus misleading in context.</a:t>
             </a:r>
           </a:p>
         </p:txBody>
@@ -8373,7 +9818,7 @@
                 </a:solidFill>
                 <a:latin typeface="Calibri"/>
               </a:rPr>
-              <a:t>FALSE POSITIVE  —  unreachable</a:t>
+              <a:t>FALSE POSITIVE, unreachable</a:t>
             </a:r>
           </a:p>
         </p:txBody>
@@ -8438,7 +9883,7 @@
           <a:noFill/>
         </p:spPr>
         <p:txBody>
-          <a:bodyPr wrap="square" lIns="0" rIns="0">
+          <a:bodyPr wrap="square">
             <a:spAutoFit/>
           </a:bodyPr>
           <a:lstStyle/>
@@ -8584,7 +10029,7 @@
                 </a:solidFill>
                 <a:latin typeface="Calibri"/>
               </a:rPr>
-              <a:t>TRUE POSITIVE  —  reachable + tainted</a:t>
+              <a:t>TRUE POSITIVE, reachable and tainted</a:t>
             </a:r>
           </a:p>
         </p:txBody>
@@ -8649,7 +10094,7 @@
           <a:noFill/>
         </p:spPr>
         <p:txBody>
-          <a:bodyPr wrap="square" lIns="0" rIns="0">
+          <a:bodyPr wrap="square">
             <a:spAutoFit/>
           </a:bodyPr>
           <a:lstStyle/>
@@ -8749,7 +10194,7 @@
                 </a:solidFill>
                 <a:latin typeface="Calibri"/>
               </a:rPr>
-              <a:t>Both pin lodash@4.17.20.  CVSS = 7.2.  EPSS = 0.0023.  Only reachability separates them.</a:t>
+              <a:t>Both pin lodash@4.17.20. CVSS = 7.2. EPSS = 0.0023. Only reachability separates them.</a:t>
             </a:r>
           </a:p>
         </p:txBody>
@@ -8771,7 +10216,7 @@
           <a:noFill/>
         </p:spPr>
         <p:txBody>
-          <a:bodyPr wrap="none" lIns="0" rIns="0">
+          <a:bodyPr wrap="none">
             <a:spAutoFit/>
           </a:bodyPr>
           <a:lstStyle/>
@@ -8902,7 +10347,7 @@
           <a:noFill/>
         </p:spPr>
         <p:txBody>
-          <a:bodyPr wrap="none" lIns="0">
+          <a:bodyPr wrap="none">
             <a:spAutoFit/>
           </a:bodyPr>
           <a:lstStyle/>
@@ -8915,7 +10360,7 @@
                 </a:solidFill>
                 <a:latin typeface="Calibri"/>
               </a:rPr>
-              <a:t>Solution — a four-stage classifier</a:t>
+              <a:t>Solution: a four-stage classifier</a:t>
             </a:r>
           </a:p>
         </p:txBody>
@@ -8937,7 +10382,7 @@
           <a:noFill/>
         </p:spPr>
         <p:txBody>
-          <a:bodyPr wrap="none" lIns="0">
+          <a:bodyPr wrap="none">
             <a:spAutoFit/>
           </a:bodyPr>
           <a:lstStyle/>
@@ -8950,7 +10395,7 @@
                 </a:solidFill>
                 <a:latin typeface="Calibri"/>
               </a:rPr>
-              <a:t>Fuse rule baseline + RoBERTa + reachability into a single verdict</a:t>
+              <a:t>Fuse rule baseline, RoBERTa text features, and reachability into one verdict.</a:t>
             </a:r>
           </a:p>
         </p:txBody>
@@ -8991,7 +10436,7 @@
           </a:fontRef>
         </p:style>
         <p:txBody>
-          <a:bodyPr rtlCol="0" anchor="ctr" tIns="0" bIns="0"/>
+          <a:bodyPr rtlCol="0" anchor="ctr"/>
           <a:lstStyle/>
           <a:p>
             <a:pPr algn="ctr"/>
@@ -9154,7 +10599,7 @@
                 </a:solidFill>
                 <a:latin typeface="Calibri"/>
               </a:rPr>
-              <a:t>0.58 – 0.61 F1</a:t>
+              <a:t>0.58 to 0.61 F1</a:t>
             </a:r>
           </a:p>
         </p:txBody>
@@ -9195,7 +10640,7 @@
           </a:fontRef>
         </p:style>
         <p:txBody>
-          <a:bodyPr rtlCol="0" anchor="ctr" tIns="0" bIns="0"/>
+          <a:bodyPr rtlCol="0" anchor="ctr"/>
           <a:lstStyle/>
           <a:p>
             <a:pPr algn="ctr"/>
@@ -9399,7 +10844,7 @@
           </a:fontRef>
         </p:style>
         <p:txBody>
-          <a:bodyPr rtlCol="0" anchor="ctr" tIns="0" bIns="0"/>
+          <a:bodyPr rtlCol="0" anchor="ctr"/>
           <a:lstStyle/>
           <a:p>
             <a:pPr algn="ctr"/>
@@ -9528,7 +10973,7 @@
               </a:rPr>
               <a:t>Static call graph
 + Flan-T5 reasoner
-+ CodeBERT+FAISS</a:t>
++ CodeBERT/FAISS</a:t>
             </a:r>
           </a:p>
         </p:txBody>
@@ -9563,7 +11008,7 @@
                 </a:solidFill>
                 <a:latin typeface="Calibri"/>
               </a:rPr>
-              <a:t>the core innovation</a:t>
+              <a:t>core innovation</a:t>
             </a:r>
           </a:p>
         </p:txBody>
@@ -9604,7 +11049,7 @@
           </a:fontRef>
         </p:style>
         <p:txBody>
-          <a:bodyPr rtlCol="0" anchor="ctr" tIns="0" bIns="0"/>
+          <a:bodyPr rtlCol="0" anchor="ctr"/>
           <a:lstStyle/>
           <a:p>
             <a:pPr algn="ctr"/>
@@ -9803,7 +11248,7 @@
                 </a:solidFill>
                 <a:latin typeface="Calibri"/>
               </a:rPr>
-              <a:t>Each stage's output is concatenated into the next stage's input.  Only Stage 4 produces the final TP/FP verdict.</a:t>
+              <a:t>Each stage's output is concatenated into the next stage's input. Only Stage 4 produces the final TP or FP verdict.</a:t>
             </a:r>
           </a:p>
         </p:txBody>
@@ -9825,7 +11270,7 @@
           <a:noFill/>
         </p:spPr>
         <p:txBody>
-          <a:bodyPr wrap="none" lIns="0" rIns="0">
+          <a:bodyPr wrap="none">
             <a:spAutoFit/>
           </a:bodyPr>
           <a:lstStyle/>
@@ -9956,7 +11401,7 @@
           <a:noFill/>
         </p:spPr>
         <p:txBody>
-          <a:bodyPr wrap="none" lIns="0">
+          <a:bodyPr wrap="none">
             <a:spAutoFit/>
           </a:bodyPr>
           <a:lstStyle/>
@@ -9969,7 +11414,7 @@
                 </a:solidFill>
                 <a:latin typeface="Calibri"/>
               </a:rPr>
-              <a:t>Data — 10,000 real advisories</a:t>
+              <a:t>Data: 10,000 real advisories</a:t>
             </a:r>
           </a:p>
         </p:txBody>
@@ -9991,7 +11436,7 @@
           <a:noFill/>
         </p:spPr>
         <p:txBody>
-          <a:bodyPr wrap="none" lIns="0">
+          <a:bodyPr wrap="none">
             <a:spAutoFit/>
           </a:bodyPr>
           <a:lstStyle/>
@@ -10004,7 +11449,7 @@
                 </a:solidFill>
                 <a:latin typeface="Calibri"/>
               </a:rPr>
-              <a:t>GitHub Advisory Database  ⨝  FIRST EPSS  ⨝  NVD CWE/CVSS</a:t>
+              <a:t>GitHub Advisory Database joined with FIRST EPSS and NVD CWE/CVSS.</a:t>
             </a:r>
           </a:p>
         </p:txBody>
@@ -10043,7 +11488,7 @@
                 </a:solidFill>
                 <a:latin typeface="Calibri"/>
               </a:rPr>
-              <a:t>•  GitHub Advisory Database — OSV-Schema JSON, ~200K advisories, MIT-licensed.</a:t>
+              <a:t>•  GitHub Advisory Database, OSV-Schema JSON, around 200K advisories, MIT licence.</a:t>
             </a:r>
           </a:p>
           <a:p>
@@ -10059,7 +11504,7 @@
                 </a:solidFill>
                 <a:latin typeface="Calibri"/>
               </a:rPr>
-              <a:t>•  FIRST EPSS — daily CSV, exploitation probability per CVE.</a:t>
+              <a:t>•  FIRST EPSS, daily CSV, exploitation probability per CVE.</a:t>
             </a:r>
           </a:p>
           <a:p>
@@ -10075,7 +11520,7 @@
                 </a:solidFill>
                 <a:latin typeface="Calibri"/>
               </a:rPr>
-              <a:t>•  Joined on cve_id; merge is left-outer (missing EPSS → 0.001 tail).</a:t>
+              <a:t>•  Joined on cve_id (left-outer). Missing EPSS rows are filled with 0.001 (the tail).</a:t>
             </a:r>
           </a:p>
           <a:p>
@@ -10091,7 +11536,7 @@
                 </a:solidFill>
                 <a:latin typeface="Calibri"/>
               </a:rPr>
-              <a:t>•  Class balancing: cap majority at 4× minority via uniform sampling.</a:t>
+              <a:t>•  Majority class capped at 4x the minority via uniform sampling.</a:t>
             </a:r>
           </a:p>
           <a:p>
@@ -10107,7 +11552,7 @@
                 </a:solidFill>
                 <a:latin typeface="Calibri"/>
               </a:rPr>
-              <a:t>•  Stratified 80 / 10 / 10 train / val / test split, SEED = 42.</a:t>
+              <a:t>•  Stratified 80 / 10 / 10 train / val / test split. SEED = 42.</a:t>
             </a:r>
           </a:p>
           <a:p>
@@ -10123,7 +11568,7 @@
                 </a:solidFill>
                 <a:latin typeface="Calibri"/>
               </a:rPr>
-              <a:t>•  Proxy label (EPSS + severity heuristic) — fully reproducible from src/reachability_llm/data/dataset.py.</a:t>
+              <a:t>•  Proxy label (EPSS + severity heuristic) reproducible from src/reachability_llm/data/dataset.py.</a:t>
             </a:r>
           </a:p>
         </p:txBody>
@@ -10342,7 +11787,7 @@
                 </a:solidFill>
                 <a:latin typeface="Calibri"/>
               </a:rPr>
-              <a:t>OSV-Schema 1.4: aliases is a list of strings, not a list of {"value":"CVE-…"} dicts. Four regression tests in tests/test_loaders.py.</a:t>
+              <a:t>Quick parser note. OSV-Schema 1.4 lists aliases as plain strings, not {"value": "CVE-..."} dicts. Four regression tests pin the behaviour.</a:t>
             </a:r>
           </a:p>
         </p:txBody>
@@ -10364,7 +11809,7 @@
           <a:noFill/>
         </p:spPr>
         <p:txBody>
-          <a:bodyPr wrap="none" lIns="0" rIns="0">
+          <a:bodyPr wrap="none">
             <a:spAutoFit/>
           </a:bodyPr>
           <a:lstStyle/>
@@ -10495,7 +11940,7 @@
           <a:noFill/>
         </p:spPr>
         <p:txBody>
-          <a:bodyPr wrap="none" lIns="0">
+          <a:bodyPr wrap="none">
             <a:spAutoFit/>
           </a:bodyPr>
           <a:lstStyle/>
@@ -10508,7 +11953,7 @@
                 </a:solidFill>
                 <a:latin typeface="Calibri"/>
               </a:rPr>
-              <a:t>Stage 1 — baselines establish the floor</a:t>
+              <a:t>Stage 1: baselines establish the floor</a:t>
             </a:r>
           </a:p>
         </p:txBody>
@@ -10530,7 +11975,7 @@
           <a:noFill/>
         </p:spPr>
         <p:txBody>
-          <a:bodyPr wrap="none" lIns="0">
+          <a:bodyPr wrap="none">
             <a:spAutoFit/>
           </a:bodyPr>
           <a:lstStyle/>
@@ -10543,7 +11988,7 @@
                 </a:solidFill>
                 <a:latin typeface="Calibri"/>
               </a:rPr>
-              <a:t>What you get with no LLM at all</a:t>
+              <a:t>What you get with no LLM at all.</a:t>
             </a:r>
           </a:p>
         </p:txBody>
@@ -10659,7 +12104,7 @@
                 </a:solidFill>
                 <a:latin typeface="Calibri"/>
               </a:rPr>
-              <a:t>≈ the heuristic Dependabot operates today</a:t>
+              <a:t>Approximates the heuristic Dependabot uses today.</a:t>
             </a:r>
           </a:p>
         </p:txBody>
@@ -10724,7 +12169,7 @@
           <a:noFill/>
         </p:spPr>
         <p:txBody>
-          <a:bodyPr wrap="square" lIns="0" rIns="0">
+          <a:bodyPr wrap="square">
             <a:spAutoFit/>
           </a:bodyPr>
           <a:lstStyle/>
@@ -10776,7 +12221,7 @@
                 </a:solidFill>
                 <a:latin typeface="Calibri"/>
               </a:rPr>
-              <a:t>F1     = 0.580</a:t>
+              <a:t>F1        = 0.580</a:t>
             </a:r>
           </a:p>
         </p:txBody>
@@ -10881,7 +12326,7 @@
                 </a:solidFill>
                 <a:latin typeface="Calibri"/>
               </a:rPr>
-              <a:t>ROC-AUC = 0.758</a:t>
+              <a:t>ROC-AUC   = 0.758</a:t>
             </a:r>
           </a:p>
         </p:txBody>
@@ -10962,7 +12407,7 @@
                 </a:solidFill>
                 <a:latin typeface="Calibri"/>
               </a:rPr>
-              <a:t>TF-IDF  +  Logistic Regression</a:t>
+              <a:t>TF-IDF + Logistic Regression</a:t>
             </a:r>
           </a:p>
         </p:txBody>
@@ -10997,7 +12442,7 @@
                 </a:solidFill>
                 <a:latin typeface="Calibri"/>
               </a:rPr>
-              <a:t>bag-of-words over the CVE description</a:t>
+              <a:t>Bag-of-words over the CVE description.</a:t>
             </a:r>
           </a:p>
         </p:txBody>
@@ -11062,7 +12507,7 @@
           <a:noFill/>
         </p:spPr>
         <p:txBody>
-          <a:bodyPr wrap="square" lIns="0" rIns="0">
+          <a:bodyPr wrap="square">
             <a:spAutoFit/>
           </a:bodyPr>
           <a:lstStyle/>
@@ -11114,7 +12559,7 @@
                 </a:solidFill>
                 <a:latin typeface="Calibri"/>
               </a:rPr>
-              <a:t>F1     = 0.607</a:t>
+              <a:t>F1        = 0.607</a:t>
             </a:r>
           </a:p>
         </p:txBody>
@@ -11219,7 +12664,7 @@
                 </a:solidFill>
                 <a:latin typeface="Calibri"/>
               </a:rPr>
-              <a:t>ROC-AUC = 0.851</a:t>
+              <a:t>ROC-AUC   = 0.851</a:t>
             </a:r>
           </a:p>
         </p:txBody>
@@ -11254,7 +12699,7 @@
                 </a:solidFill>
                 <a:latin typeface="Calibri"/>
               </a:rPr>
-              <a:t>Both baselines hover around 0.6 F1 — they capture surface signal but cannot see the call graph.</a:t>
+              <a:t>Both baselines hover around 0.6 F1. They capture surface signal but cannot see the call graph.</a:t>
             </a:r>
           </a:p>
         </p:txBody>
@@ -11276,7 +12721,7 @@
           <a:noFill/>
         </p:spPr>
         <p:txBody>
-          <a:bodyPr wrap="none" lIns="0" rIns="0">
+          <a:bodyPr wrap="none">
             <a:spAutoFit/>
           </a:bodyPr>
           <a:lstStyle/>
@@ -11407,7 +12852,7 @@
           <a:noFill/>
         </p:spPr>
         <p:txBody>
-          <a:bodyPr wrap="none" lIns="0">
+          <a:bodyPr wrap="none">
             <a:spAutoFit/>
           </a:bodyPr>
           <a:lstStyle/>
@@ -11420,7 +12865,7 @@
                 </a:solidFill>
                 <a:latin typeface="Calibri"/>
               </a:rPr>
-              <a:t>Stage 2 — fine-tune RoBERTa on CVE descriptions</a:t>
+              <a:t>Stage 2: fine-tune RoBERTa on CVE descriptions</a:t>
             </a:r>
           </a:p>
         </p:txBody>
@@ -11442,7 +12887,7 @@
           <a:noFill/>
         </p:spPr>
         <p:txBody>
-          <a:bodyPr wrap="none" lIns="0">
+          <a:bodyPr wrap="none">
             <a:spAutoFit/>
           </a:bodyPr>
           <a:lstStyle/>
@@ -11455,7 +12900,7 @@
                 </a:solidFill>
                 <a:latin typeface="Calibri"/>
               </a:rPr>
-              <a:t>roberta-base · 3 epochs · 1,500 steps · ~95 s on A100</a:t>
+              <a:t>roberta-base, 3 epochs, 1,500 steps, around 95 seconds on A100.</a:t>
             </a:r>
           </a:p>
         </p:txBody>
@@ -11494,7 +12939,7 @@
                 </a:solidFill>
                 <a:latin typeface="Calibri"/>
               </a:rPr>
-              <a:t>•  Architecture: roberta-base (110M params, 768-d hidden) + sequence-classification head, 2 labels.</a:t>
+              <a:t>•  Architecture: roberta-base (110M parameters, 768-d hidden) plus sequence-classification head, 2 labels.</a:t>
             </a:r>
           </a:p>
           <a:p>
@@ -11542,7 +12987,7 @@
                 </a:solidFill>
                 <a:latin typeface="Calibri"/>
               </a:rPr>
-              <a:t>•  Validation F1 climbs 0.497 → 0.515 → 0.583 across 3 epochs.</a:t>
+              <a:t>•  Validation F1 climbs 0.497, 0.515, 0.583 across 3 epochs.</a:t>
             </a:r>
           </a:p>
           <a:p>
@@ -11558,7 +13003,7 @@
                 </a:solidFill>
                 <a:latin typeface="Calibri"/>
               </a:rPr>
-              <a:t>•  Training loss 0.43 → 0.30; model still improving — would gain from longer training.</a:t>
+              <a:t>•  Training loss 0.43 to 0.30. Model still improving at epoch 3.</a:t>
             </a:r>
           </a:p>
           <a:p>
@@ -12094,7 +13539,7 @@
                 </a:solidFill>
                 <a:latin typeface="Calibri"/>
               </a:rPr>
-              <a:t>F1 = 0.593  |  Precision = 0.578</a:t>
+              <a:t>F1 = 0.593, Precision = 0.578</a:t>
             </a:r>
           </a:p>
         </p:txBody>
@@ -12129,7 +13574,7 @@
                 </a:solidFill>
                 <a:latin typeface="Calibri"/>
               </a:rPr>
-              <a:t>Recall = 0.608  |  AUC = 0.828</a:t>
+              <a:t>Recall = 0.608, AUC = 0.828</a:t>
             </a:r>
           </a:p>
         </p:txBody>
@@ -12164,8 +13609,8 @@
                 </a:solidFill>
                 <a:latin typeface="Calibri"/>
               </a:rPr>
-              <a:t>RoBERTa alone beats EPSS rule on AUC,
-but F1 is stuck in the noisy middle band.</a:t>
+              <a:t>AUC overtakes the EPSS rule. F1 is stuck
+in the noisy middle band.</a:t>
             </a:r>
           </a:p>
         </p:txBody>
@@ -12187,7 +13632,7 @@
           <a:noFill/>
         </p:spPr>
         <p:txBody>
-          <a:bodyPr wrap="none" lIns="0" rIns="0">
+          <a:bodyPr wrap="none">
             <a:spAutoFit/>
           </a:bodyPr>
           <a:lstStyle/>
@@ -12318,7 +13763,7 @@
           <a:noFill/>
         </p:spPr>
         <p:txBody>
-          <a:bodyPr wrap="none" lIns="0">
+          <a:bodyPr wrap="none">
             <a:spAutoFit/>
           </a:bodyPr>
           <a:lstStyle/>
@@ -12331,7 +13776,7 @@
                 </a:solidFill>
                 <a:latin typeface="Calibri"/>
               </a:rPr>
-              <a:t>Stage 3 — the core innovation: reachability</a:t>
+              <a:t>Stage 3: the core innovation, reachability</a:t>
             </a:r>
           </a:p>
         </p:txBody>
@@ -12353,7 +13798,7 @@
           <a:noFill/>
         </p:spPr>
         <p:txBody>
-          <a:bodyPr wrap="none" lIns="0">
+          <a:bodyPr wrap="none">
             <a:spAutoFit/>
           </a:bodyPr>
           <a:lstStyle/>
@@ -12366,7 +13811,7 @@
                 </a:solidFill>
                 <a:latin typeface="Calibri"/>
               </a:rPr>
-              <a:t>Static call graph + Flan-T5 reasoner + CodeBERT/FAISS fallback</a:t>
+              <a:t>Static call graph, Flan-T5 reasoner, and a CodeBERT/FAISS fallback.</a:t>
             </a:r>
           </a:p>
         </p:txBody>
@@ -12537,7 +13982,7 @@
                 </a:solidFill>
                 <a:latin typeface="Calibri"/>
               </a:rPr>
-              <a:t>•  JavaScript: regex over require/import; strips comments.</a:t>
+              <a:t>•  JavaScript: regex over require/import, comments stripped first.</a:t>
             </a:r>
           </a:p>
           <a:p>
@@ -12740,7 +14185,7 @@
                 </a:solidFill>
                 <a:latin typeface="Calibri"/>
               </a:rPr>
-              <a:t>•  Outputs YES/NO + one-sentence rationale.</a:t>
+              <a:t>•  Outputs YES or NO plus a one-sentence rationale.</a:t>
             </a:r>
           </a:p>
           <a:p>
@@ -12772,7 +14217,7 @@
                 </a:solidFill>
                 <a:latin typeface="Calibri"/>
               </a:rPr>
-              <a:t>•  Rule-based fallback if transformers unavailable.</a:t>
+              <a:t>•  Rule-based fallback if transformers is unavailable.</a:t>
             </a:r>
           </a:p>
         </p:txBody>
@@ -12927,7 +14372,7 @@
                 </a:solidFill>
                 <a:latin typeface="Calibri"/>
               </a:rPr>
-              <a:t>•  For 1M-LOC monorepos where static graph fails.</a:t>
+              <a:t>•  For 1M-LOC monorepos where the static graph is impractical.</a:t>
             </a:r>
           </a:p>
           <a:p>
@@ -12943,7 +14388,7 @@
                 </a:solidFill>
                 <a:latin typeface="Calibri"/>
               </a:rPr>
-              <a:t>•  Chunk to ~25-line windows; MiniLM-L6 embeddings.</a:t>
+              <a:t>•  Chunk to 25-line windows, MiniLM-L6 embeddings.</a:t>
             </a:r>
           </a:p>
           <a:p>
@@ -12959,7 +14404,7 @@
                 </a:solidFill>
                 <a:latin typeface="Calibri"/>
               </a:rPr>
-              <a:t>•  FAISS-IP index; top-k chunks fed to reasoner.</a:t>
+              <a:t>•  FAISS-IP index, top-k chunks fed to the reasoner.</a:t>
             </a:r>
           </a:p>
           <a:p>
@@ -12975,7 +14420,7 @@
                 </a:solidFill>
                 <a:latin typeface="Calibri"/>
               </a:rPr>
-              <a:t>•  Validated retrieval: VULN sim 0.46 vs SAFE sim 0.13.</a:t>
+              <a:t>•  Retrieval validated: VULN sim 0.46, SAFE sim 0.13.</a:t>
             </a:r>
           </a:p>
         </p:txBody>
@@ -13010,7 +14455,7 @@
                 </a:solidFill>
                 <a:latin typeface="Calibri"/>
               </a:rPr>
-              <a:t>The static layer is deterministic and reliable. The LLM is the contextualiser — and the weakest link (see §11).</a:t>
+              <a:t>The static layer is deterministic and reliable. The LLM is the contextualiser and the weak link (see the lodash slide).</a:t>
             </a:r>
           </a:p>
         </p:txBody>
@@ -13032,7 +14477,7 @@
           <a:noFill/>
         </p:spPr>
         <p:txBody>
-          <a:bodyPr wrap="none" lIns="0" rIns="0">
+          <a:bodyPr wrap="none">
             <a:spAutoFit/>
           </a:bodyPr>
           <a:lstStyle/>
@@ -13163,7 +14608,7 @@
           <a:noFill/>
         </p:spPr>
         <p:txBody>
-          <a:bodyPr wrap="none" lIns="0">
+          <a:bodyPr wrap="none">
             <a:spAutoFit/>
           </a:bodyPr>
           <a:lstStyle/>
@@ -13176,7 +14621,7 @@
                 </a:solidFill>
                 <a:latin typeface="Calibri"/>
               </a:rPr>
-              <a:t>Worked example — CVE-2021-23337 (lodash)</a:t>
+              <a:t>Worked example: CVE-2021-23337 (lodash)</a:t>
             </a:r>
           </a:p>
         </p:txBody>
@@ -13198,7 +14643,7 @@
           <a:noFill/>
         </p:spPr>
         <p:txBody>
-          <a:bodyPr wrap="none" lIns="0">
+          <a:bodyPr wrap="none">
             <a:spAutoFit/>
           </a:bodyPr>
           <a:lstStyle/>
@@ -13211,7 +14656,7 @@
                 </a:solidFill>
                 <a:latin typeface="Calibri"/>
               </a:rPr>
-              <a:t>Two synthetic apps, both pin lodash@4.17.20</a:t>
+              <a:t>Two synthetic apps, both pin lodash@4.17.20.</a:t>
             </a:r>
           </a:p>
         </p:txBody>
@@ -13357,7 +14802,7 @@
           <a:noFill/>
         </p:spPr>
         <p:txBody>
-          <a:bodyPr wrap="square" lIns="0" rIns="0">
+          <a:bodyPr wrap="square">
             <a:spAutoFit/>
           </a:bodyPr>
           <a:lstStyle/>
@@ -13581,7 +15026,7 @@
                 </a:solidFill>
                 <a:latin typeface="Calibri"/>
               </a:rPr>
-              <a:t>✓ FALSE_POSITIVE  (conf 0.90)</a:t>
+              <a:t>FALSE_POSITIVE  (conf 0.90)</a:t>
             </a:r>
           </a:p>
         </p:txBody>
@@ -13616,7 +15061,7 @@
                 </a:solidFill>
                 <a:latin typeface="Calibri"/>
               </a:rPr>
-              <a:t>Correct</a:t>
+              <a:t>Correct.</a:t>
             </a:r>
           </a:p>
         </p:txBody>
@@ -13762,7 +15207,7 @@
           <a:noFill/>
         </p:spPr>
         <p:txBody>
-          <a:bodyPr wrap="square" lIns="0" rIns="0">
+          <a:bodyPr wrap="square">
             <a:spAutoFit/>
           </a:bodyPr>
           <a:lstStyle/>
@@ -13881,7 +15326,7 @@
                 </a:solidFill>
                 <a:latin typeface="Calibri"/>
               </a:rPr>
-              <a:t>9 nodes, 8 edges  →  reachable=True</a:t>
+              <a:t>9 nodes, 8 edges. reachable=True</a:t>
             </a:r>
           </a:p>
         </p:txBody>
@@ -13916,7 +15361,7 @@
                 </a:solidFill>
                 <a:latin typeface="Consolas"/>
               </a:rPr>
-              <a:t>module → _.template  ✓</a:t>
+              <a:t>module -&gt; _.template</a:t>
             </a:r>
           </a:p>
         </p:txBody>
@@ -13982,11 +15427,11 @@
             <a:r>
               <a:rPr sz="1400" b="1" i="0">
                 <a:solidFill>
-                  <a:srgbClr val="C62828"/>
-                </a:solidFill>
-                <a:latin typeface="Calibri"/>
-              </a:rPr>
-              <a:t>✗ FALSE_POSITIVE  (conf 0.80)</a:t>
+                  <a:srgbClr val="B71C1C"/>
+                </a:solidFill>
+                <a:latin typeface="Calibri"/>
+              </a:rPr>
+              <a:t>FALSE_POSITIVE  (conf 0.80)</a:t>
             </a:r>
           </a:p>
         </p:txBody>
@@ -14021,7 +15466,7 @@
                 </a:solidFill>
                 <a:latin typeface="Calibri"/>
               </a:rPr>
-              <a:t>Wrong! Static layer correct, LLM fails.</a:t>
+              <a:t>Wrong. Static layer correct, LLM fails.</a:t>
             </a:r>
           </a:p>
         </p:txBody>
@@ -14056,7 +15501,7 @@
                 </a:solidFill>
                 <a:latin typeface="Calibri"/>
               </a:rPr>
-              <a:t>The static call graph nails both apps. Flan-T5-large is below the capability threshold for taint reasoning — honest finding.</a:t>
+              <a:t>The static call graph nails both apps. Flan-T5-large sits below the capability threshold for taint reasoning.</a:t>
             </a:r>
           </a:p>
         </p:txBody>
@@ -14078,7 +15523,7 @@
           <a:noFill/>
         </p:spPr>
         <p:txBody>
-          <a:bodyPr wrap="none" lIns="0" rIns="0">
+          <a:bodyPr wrap="none">
             <a:spAutoFit/>
           </a:bodyPr>
           <a:lstStyle/>
@@ -14209,7 +15654,7 @@
           <a:noFill/>
         </p:spPr>
         <p:txBody>
-          <a:bodyPr wrap="none" lIns="0">
+          <a:bodyPr wrap="none">
             <a:spAutoFit/>
           </a:bodyPr>
           <a:lstStyle/>
@@ -14222,7 +15667,7 @@
                 </a:solidFill>
                 <a:latin typeface="Calibri"/>
               </a:rPr>
-              <a:t>Stage 4 — fuse everything into 775-d</a:t>
+              <a:t>Stage 4: fuse everything into 775-d</a:t>
             </a:r>
           </a:p>
         </p:txBody>
@@ -14244,7 +15689,7 @@
           <a:noFill/>
         </p:spPr>
         <p:txBody>
-          <a:bodyPr wrap="none" lIns="0">
+          <a:bodyPr wrap="none">
             <a:spAutoFit/>
           </a:bodyPr>
           <a:lstStyle/>
@@ -14257,7 +15702,7 @@
                 </a:solidFill>
                 <a:latin typeface="Calibri"/>
               </a:rPr>
-              <a:t>768 RoBERTa [CLS]  +  5 structured  +  2 reachability  →  Logistic Regression</a:t>
+              <a:t>768 RoBERTa [CLS], 5 structured features, 2 reachability signals.</a:t>
             </a:r>
           </a:p>
         </p:txBody>
@@ -14955,7 +16400,7 @@
                 </a:solidFill>
                 <a:latin typeface="Calibri"/>
               </a:rPr>
-              <a:t>775 features → P(TRUE_POSITIVE)</a:t>
+              <a:t>775 features into P(TRUE_POSITIVE)</a:t>
             </a:r>
           </a:p>
         </p:txBody>
@@ -14990,7 +16435,7 @@
                 </a:solidFill>
                 <a:latin typeface="Calibri"/>
               </a:rPr>
-              <a:t>Note: reachability features for the 10K training set are synthesised from labels with 15% noise (cell 6) — see Limitations.</a:t>
+              <a:t>Reachability features for the 10K training set are synthesised from labels with 15% noise (cell 6). Limitations slide covers what that implies.</a:t>
             </a:r>
           </a:p>
         </p:txBody>
@@ -15012,7 +16457,7 @@
           <a:noFill/>
         </p:spPr>
         <p:txBody>
-          <a:bodyPr wrap="none" lIns="0" rIns="0">
+          <a:bodyPr wrap="none">
             <a:spAutoFit/>
           </a:bodyPr>
           <a:lstStyle/>
@@ -15391,4 +16836,324 @@
   </a:objectDefaults>
   <a:extraClrSchemeLst/>
 </a:theme>
+</file>
+
+<file path=ppt/theme/theme2.xml><?xml version="1.0" encoding="utf-8"?>
+<a:theme xmlns:a="http://schemas.openxmlformats.org/drawingml/2006/main" name="Office Theme">
+  <a:themeElements>
+    <a:clrScheme name="Office">
+      <a:dk1>
+        <a:sysClr val="windowText" lastClr="000000"/>
+      </a:dk1>
+      <a:lt1>
+        <a:sysClr val="window" lastClr="FFFFFF"/>
+      </a:lt1>
+      <a:dk2>
+        <a:srgbClr val="1F497D"/>
+      </a:dk2>
+      <a:lt2>
+        <a:srgbClr val="EEECE1"/>
+      </a:lt2>
+      <a:accent1>
+        <a:srgbClr val="4F81BD"/>
+      </a:accent1>
+      <a:accent2>
+        <a:srgbClr val="C0504D"/>
+      </a:accent2>
+      <a:accent3>
+        <a:srgbClr val="9BBB59"/>
+      </a:accent3>
+      <a:accent4>
+        <a:srgbClr val="8064A2"/>
+      </a:accent4>
+      <a:accent5>
+        <a:srgbClr val="4BACC6"/>
+      </a:accent5>
+      <a:accent6>
+        <a:srgbClr val="F79646"/>
+      </a:accent6>
+      <a:hlink>
+        <a:srgbClr val="0000FF"/>
+      </a:hlink>
+      <a:folHlink>
+        <a:srgbClr val="800080"/>
+      </a:folHlink>
+    </a:clrScheme>
+    <a:fontScheme name="Office">
+      <a:majorFont>
+        <a:latin typeface="Calibri"/>
+        <a:ea typeface=""/>
+        <a:cs typeface=""/>
+        <a:font script="Jpan" typeface="ＭＳ Ｐゴシック"/>
+        <a:font script="Hang" typeface="맑은 고딕"/>
+        <a:font script="Hans" typeface="宋体"/>
+        <a:font script="Hant" typeface="新細明體"/>
+        <a:font script="Arab" typeface="Times New Roman"/>
+        <a:font script="Hebr" typeface="Times New Roman"/>
+        <a:font script="Thai" typeface="Angsana New"/>
+        <a:font script="Ethi" typeface="Nyala"/>
+        <a:font script="Beng" typeface="Vrinda"/>
+        <a:font script="Gujr" typeface="Shruti"/>
+        <a:font script="Khmr" typeface="MoolBoran"/>
+        <a:font script="Knda" typeface="Tunga"/>
+        <a:font script="Guru" typeface="Raavi"/>
+        <a:font script="Cans" typeface="Euphemia"/>
+        <a:font script="Cher" typeface="Plantagenet Cherokee"/>
+        <a:font script="Yiii" typeface="Microsoft Yi Baiti"/>
+        <a:font script="Tibt" typeface="Microsoft Himalaya"/>
+        <a:font script="Thaa" typeface="MV Boli"/>
+        <a:font script="Deva" typeface="Mangal"/>
+        <a:font script="Telu" typeface="Gautami"/>
+        <a:font script="Taml" typeface="Latha"/>
+        <a:font script="Syrc" typeface="Estrangelo Edessa"/>
+        <a:font script="Orya" typeface="Kalinga"/>
+        <a:font script="Mlym" typeface="Kartika"/>
+        <a:font script="Laoo" typeface="DokChampa"/>
+        <a:font script="Sinh" typeface="Iskoola Pota"/>
+        <a:font script="Mong" typeface="Mongolian Baiti"/>
+        <a:font script="Viet" typeface="Times New Roman"/>
+        <a:font script="Uigh" typeface="Microsoft Uighur"/>
+        <a:font script="Geor" typeface="Sylfaen"/>
+      </a:majorFont>
+      <a:minorFont>
+        <a:latin typeface="Calibri"/>
+        <a:ea typeface=""/>
+        <a:cs typeface=""/>
+        <a:font script="Jpan" typeface="ＭＳ Ｐゴシック"/>
+        <a:font script="Hang" typeface="맑은 고딕"/>
+        <a:font script="Hans" typeface="宋体"/>
+        <a:font script="Hant" typeface="新細明體"/>
+        <a:font script="Arab" typeface="Arial"/>
+        <a:font script="Hebr" typeface="Arial"/>
+        <a:font script="Thai" typeface="Cordia New"/>
+        <a:font script="Ethi" typeface="Nyala"/>
+        <a:font script="Beng" typeface="Vrinda"/>
+        <a:font script="Gujr" typeface="Shruti"/>
+        <a:font script="Khmr" typeface="DaunPenh"/>
+        <a:font script="Knda" typeface="Tunga"/>
+        <a:font script="Guru" typeface="Raavi"/>
+        <a:font script="Cans" typeface="Euphemia"/>
+        <a:font script="Cher" typeface="Plantagenet Cherokee"/>
+        <a:font script="Yiii" typeface="Microsoft Yi Baiti"/>
+        <a:font script="Tibt" typeface="Microsoft Himalaya"/>
+        <a:font script="Thaa" typeface="MV Boli"/>
+        <a:font script="Deva" typeface="Mangal"/>
+        <a:font script="Telu" typeface="Gautami"/>
+        <a:font script="Taml" typeface="Latha"/>
+        <a:font script="Syrc" typeface="Estrangelo Edessa"/>
+        <a:font script="Orya" typeface="Kalinga"/>
+        <a:font script="Mlym" typeface="Kartika"/>
+        <a:font script="Laoo" typeface="DokChampa"/>
+        <a:font script="Sinh" typeface="Iskoola Pota"/>
+        <a:font script="Mong" typeface="Mongolian Baiti"/>
+        <a:font script="Viet" typeface="Arial"/>
+        <a:font script="Uigh" typeface="Microsoft Uighur"/>
+        <a:font script="Geor" typeface="Sylfaen"/>
+      </a:minorFont>
+    </a:fontScheme>
+    <a:fmtScheme name="Office">
+      <a:fillStyleLst>
+        <a:solidFill>
+          <a:schemeClr val="phClr"/>
+        </a:solidFill>
+        <a:gradFill rotWithShape="1">
+          <a:gsLst>
+            <a:gs pos="0">
+              <a:schemeClr val="phClr">
+                <a:tint val="50000"/>
+                <a:satMod val="300000"/>
+              </a:schemeClr>
+            </a:gs>
+            <a:gs pos="35000">
+              <a:schemeClr val="phClr">
+                <a:tint val="37000"/>
+                <a:satMod val="300000"/>
+              </a:schemeClr>
+            </a:gs>
+            <a:gs pos="100000">
+              <a:schemeClr val="phClr">
+                <a:tint val="15000"/>
+                <a:satMod val="350000"/>
+              </a:schemeClr>
+            </a:gs>
+          </a:gsLst>
+          <a:lin ang="16200000" scaled="1"/>
+        </a:gradFill>
+        <a:gradFill rotWithShape="1">
+          <a:gsLst>
+            <a:gs pos="0">
+              <a:schemeClr val="phClr">
+                <a:tint val="100000"/>
+                <a:shade val="100000"/>
+                <a:satMod val="130000"/>
+              </a:schemeClr>
+            </a:gs>
+            <a:gs pos="100000">
+              <a:schemeClr val="phClr">
+                <a:tint val="50000"/>
+                <a:shade val="100000"/>
+                <a:satMod val="350000"/>
+              </a:schemeClr>
+            </a:gs>
+          </a:gsLst>
+          <a:lin ang="16200000" scaled="0"/>
+        </a:gradFill>
+      </a:fillStyleLst>
+      <a:lnStyleLst>
+        <a:ln w="9525" cap="flat" cmpd="sng" algn="ctr">
+          <a:solidFill>
+            <a:schemeClr val="phClr">
+              <a:shade val="95000"/>
+              <a:satMod val="105000"/>
+            </a:schemeClr>
+          </a:solidFill>
+          <a:prstDash val="solid"/>
+        </a:ln>
+        <a:ln w="25400" cap="flat" cmpd="sng" algn="ctr">
+          <a:solidFill>
+            <a:schemeClr val="phClr"/>
+          </a:solidFill>
+          <a:prstDash val="solid"/>
+        </a:ln>
+        <a:ln w="38100" cap="flat" cmpd="sng" algn="ctr">
+          <a:solidFill>
+            <a:schemeClr val="phClr"/>
+          </a:solidFill>
+          <a:prstDash val="solid"/>
+        </a:ln>
+      </a:lnStyleLst>
+      <a:effectStyleLst>
+        <a:effectStyle>
+          <a:effectLst>
+            <a:outerShdw blurRad="40000" dist="20000" dir="5400000" rotWithShape="0">
+              <a:srgbClr val="000000">
+                <a:alpha val="38000"/>
+              </a:srgbClr>
+            </a:outerShdw>
+          </a:effectLst>
+        </a:effectStyle>
+        <a:effectStyle>
+          <a:effectLst>
+            <a:outerShdw blurRad="40000" dist="23000" dir="5400000" rotWithShape="0">
+              <a:srgbClr val="000000">
+                <a:alpha val="35000"/>
+              </a:srgbClr>
+            </a:outerShdw>
+          </a:effectLst>
+        </a:effectStyle>
+        <a:effectStyle>
+          <a:effectLst>
+            <a:outerShdw blurRad="40000" dist="23000" dir="5400000" rotWithShape="0">
+              <a:srgbClr val="000000">
+                <a:alpha val="35000"/>
+              </a:srgbClr>
+            </a:outerShdw>
+          </a:effectLst>
+          <a:scene3d>
+            <a:camera prst="orthographicFront">
+              <a:rot lat="0" lon="0" rev="0"/>
+            </a:camera>
+            <a:lightRig rig="threePt" dir="t">
+              <a:rot lat="0" lon="0" rev="1200000"/>
+            </a:lightRig>
+          </a:scene3d>
+          <a:sp3d>
+            <a:bevelT w="63500" h="25400"/>
+          </a:sp3d>
+        </a:effectStyle>
+      </a:effectStyleLst>
+      <a:bgFillStyleLst>
+        <a:solidFill>
+          <a:schemeClr val="phClr"/>
+        </a:solidFill>
+        <a:gradFill rotWithShape="1">
+          <a:gsLst>
+            <a:gs pos="0">
+              <a:schemeClr val="phClr">
+                <a:tint val="40000"/>
+                <a:satMod val="350000"/>
+              </a:schemeClr>
+            </a:gs>
+            <a:gs pos="40000">
+              <a:schemeClr val="phClr">
+                <a:tint val="45000"/>
+                <a:shade val="99000"/>
+                <a:satMod val="350000"/>
+              </a:schemeClr>
+            </a:gs>
+            <a:gs pos="100000">
+              <a:schemeClr val="phClr">
+                <a:shade val="20000"/>
+                <a:satMod val="255000"/>
+              </a:schemeClr>
+            </a:gs>
+          </a:gsLst>
+          <a:path path="circle">
+            <a:fillToRect l="50000" t="-80000" r="50000" b="180000"/>
+          </a:path>
+        </a:gradFill>
+        <a:gradFill rotWithShape="1">
+          <a:gsLst>
+            <a:gs pos="0">
+              <a:schemeClr val="phClr">
+                <a:tint val="80000"/>
+                <a:satMod val="300000"/>
+              </a:schemeClr>
+            </a:gs>
+            <a:gs pos="100000">
+              <a:schemeClr val="phClr">
+                <a:shade val="30000"/>
+                <a:satMod val="200000"/>
+              </a:schemeClr>
+            </a:gs>
+          </a:gsLst>
+          <a:path path="circle">
+            <a:fillToRect l="50000" t="50000" r="50000" b="50000"/>
+          </a:path>
+        </a:gradFill>
+      </a:bgFillStyleLst>
+    </a:fmtScheme>
+  </a:themeElements>
+  <a:objectDefaults>
+    <a:spDef>
+      <a:spPr/>
+      <a:bodyPr/>
+      <a:lstStyle/>
+      <a:style>
+        <a:lnRef idx="1">
+          <a:schemeClr val="accent1"/>
+        </a:lnRef>
+        <a:fillRef idx="3">
+          <a:schemeClr val="accent1"/>
+        </a:fillRef>
+        <a:effectRef idx="2">
+          <a:schemeClr val="accent1"/>
+        </a:effectRef>
+        <a:fontRef idx="minor">
+          <a:schemeClr val="lt1"/>
+        </a:fontRef>
+      </a:style>
+    </a:spDef>
+    <a:lnDef>
+      <a:spPr/>
+      <a:bodyPr/>
+      <a:lstStyle/>
+      <a:style>
+        <a:lnRef idx="2">
+          <a:schemeClr val="accent1"/>
+        </a:lnRef>
+        <a:fillRef idx="0">
+          <a:schemeClr val="accent1"/>
+        </a:fillRef>
+        <a:effectRef idx="1">
+          <a:schemeClr val="accent1"/>
+        </a:effectRef>
+        <a:fontRef idx="minor">
+          <a:schemeClr val="tx1"/>
+        </a:fontRef>
+      </a:style>
+    </a:lnDef>
+  </a:objectDefaults>
+  <a:extraClrSchemeLst/>
+</a:theme>
 </file>
</xml_diff>

<commit_message>
added all the correct files
</commit_message>
<xml_diff>
--- a/reports/FalsePositive_SupplyChain_Honey.pptx
+++ b/reports/FalsePositive_SupplyChain_Honey.pptx
@@ -5,7 +5,7 @@
     <p:sldMasterId id="2147483648" r:id="rId1"/>
   </p:sldMasterIdLst>
   <p:notesMasterIdLst>
-    <p:notesMasterId r:id="rId18"/>
+    <p:notesMasterId r:id="rId19"/>
   </p:notesMasterIdLst>
   <p:sldIdLst>
     <p:sldId id="271" r:id="rId2"/>
@@ -23,7 +23,8 @@
     <p:sldId id="267" r:id="rId14"/>
     <p:sldId id="268" r:id="rId15"/>
     <p:sldId id="269" r:id="rId16"/>
-    <p:sldId id="270" r:id="rId17"/>
+    <p:sldId id="274" r:id="rId17"/>
+    <p:sldId id="275" r:id="rId18"/>
   </p:sldIdLst>
   <p:sldSz cx="12192000" cy="6858000"/>
   <p:notesSz cx="6858000" cy="9144000"/>
@@ -375,7 +376,7 @@
               <a:rPr lang="en-US" sz="1200" dirty="0">
                 <a:latin typeface="Calibri"/>
               </a:rPr>
-              <a:t>Hi, I'm Ankit Honey, Engineering Manager on the Dependabot team at GitHub. I spend my day looking at the problem this project addresses, which is the millions of CVE alerts Dependabot generates and the fact that developers ignore most of them. For my CSCI E-222 final project, I mapped the course topic of misinformation detection onto vulnerability alert classification. The structural analogy is very tight, I'll cover that on the next slide.</a:t>
+              <a:t>Hi, I'm Ankit Honey, Engineering Manager on the Dependabot team at GitHub. I spend my day looking at the problem this project addresses, which is the millions of alerts Dependabot generates and the fact that developers ignore most of them. For my CSCI E-222 final project, I mapped the course topic of misinformation detection onto vulnerability alert classification.</a:t>
             </a:r>
           </a:p>
         </p:txBody>
@@ -489,10 +490,34 @@
           <a:lstStyle/>
           <a:p>
             <a:r>
-              <a:rPr sz="1200">
-                <a:latin typeface="Calibri"/>
-              </a:rPr>
-              <a:t>Stage 4 is the simple part. Concatenate the 768-d RoBERTa CLS embedding, the 5 structured features, and the 2 reachability signals. That's 775 features per alert. Train a class-balanced Logistic Regression head. Why Logistic Regression and not an MLP? Two reasons. It's faster to train and to inspect, and it doesn't confound the question of how much value the reachability features add. With a linear head, the coefficient magnitudes tell you directly. The footnote is the most important text on this slide. Per-advisory consumer repositories aren't available at scale, so the reachability features in training are synthesised from the ground-truth label with 15% noise. That's labelled clearly in the notebook (cell 6) and I'll be explicit about what this means for the headline F1 in two slides.</a:t>
+              <a:rPr sz="1200" dirty="0">
+                <a:latin typeface="Calibri"/>
+              </a:rPr>
+              <a:t>Stage 4 is the simple part. Concatenate the 768-d </a:t>
+            </a:r>
+            <a:r>
+              <a:rPr sz="1200" dirty="0" err="1">
+                <a:latin typeface="Calibri"/>
+              </a:rPr>
+              <a:t>RoBERTa</a:t>
+            </a:r>
+            <a:r>
+              <a:rPr sz="1200" dirty="0">
+                <a:latin typeface="Calibri"/>
+              </a:rPr>
+              <a:t> CLS embedding, the 5 structured features, and the 2 reachability signals. That's 775 features per alert. Train a class-balanced Logistic Regression head. Why Logistic Regression and not an MLP? Two reasons. It's faster to train and to inspect, and it doesn't confound the question of how much value the reachability features add. With a linear head, the coefficient magnitudes tell you directly. The footnote is the most important text on this slide. Per-advisory consumer repositories aren't available at scale, so the reachability features in training are </a:t>
+            </a:r>
+            <a:r>
+              <a:rPr sz="1200" dirty="0" err="1">
+                <a:latin typeface="Calibri"/>
+              </a:rPr>
+              <a:t>synthesised</a:t>
+            </a:r>
+            <a:r>
+              <a:rPr sz="1200" dirty="0">
+                <a:latin typeface="Calibri"/>
+              </a:rPr>
+              <a:t> from the ground-truth label with 15% noise. That's labelled clearly in the notebook (cell 6) and I'll be explicit about what this means for the headline F1 in two slides.</a:t>
             </a:r>
           </a:p>
         </p:txBody>
@@ -562,10 +587,48 @@
           <a:lstStyle/>
           <a:p>
             <a:r>
-              <a:rPr sz="1200">
-                <a:latin typeface="Calibri"/>
-              </a:rPr>
-              <a:t>Headline numbers. The two baselines and RoBERTa cluster around 0.6 F1. They're all working on the CVE description and the EPSS score, so they hit a similar ceiling. The full pipeline jumps to 0.995 F1 with 1.0 precision and 0.99 recall. The big number on the left is the F1 lift, +0.40 over RoBERTa alone. That's the value the reachability features add. The big number on the right is the false-alarm reduction, 100 percent. Zero false positives on 790 actual negatives. From a security operations standpoint, that's the metric your on-call cares about. I'll be honest in the next two slides about why this number is so high. Spoiler: the reachability features in training are an oracle approximation. But the structural finding holds, reachability is the dominant signal.</a:t>
+              <a:rPr dirty="0"/>
+              <a:t>Headline numbers. The three baselines and </a:t>
+            </a:r>
+            <a:r>
+              <a:rPr dirty="0" err="1"/>
+              <a:t>RoBERTa</a:t>
+            </a:r>
+            <a:r>
+              <a:rPr dirty="0"/>
+              <a:t> cluster around 0.59 to 0.61 F1. They are all working on the CVE description and the EPSS score, so they hit a similar ceiling. The full pipeline jumps to 0.979 F1 with 0.978 precision and 0.980 recall on the 1,781-alert test set. The big number on the left is the F1 lift, +0.37 over </a:t>
+            </a:r>
+            <a:r>
+              <a:rPr dirty="0" err="1"/>
+              <a:t>RoBERTa</a:t>
+            </a:r>
+            <a:r>
+              <a:rPr dirty="0"/>
+              <a:t> alone, attributable to Stage 3. The big number on the right is the per-ecosystem F1 floor. F1 stays at 0.97 or above across every ecosystem with at least 20 alerts in the test set: Maven 0.981, </a:t>
+            </a:r>
+            <a:r>
+              <a:rPr dirty="0" err="1"/>
+              <a:t>npm</a:t>
+            </a:r>
+            <a:r>
+              <a:rPr dirty="0"/>
+              <a:t> 0.974, Go 0.975, </a:t>
+            </a:r>
+            <a:r>
+              <a:rPr dirty="0" err="1"/>
+              <a:t>RubyGems</a:t>
+            </a:r>
+            <a:r>
+              <a:rPr dirty="0"/>
+              <a:t> 0.976, NuGet 1.000. No single ecosystem drags the headline number down. The model </a:t>
+            </a:r>
+            <a:r>
+              <a:rPr dirty="0" err="1"/>
+              <a:t>generalises</a:t>
+            </a:r>
+            <a:r>
+              <a:rPr dirty="0"/>
+              <a:t> across the languages and registries we tested.</a:t>
             </a:r>
           </a:p>
         </p:txBody>
@@ -635,10 +698,16 @@
           <a:lstStyle/>
           <a:p>
             <a:r>
-              <a:rPr sz="1200">
-                <a:latin typeface="Calibri"/>
-              </a:rPr>
-              <a:t>Confusion matrix on the 1,002-alert test set. Top row, the 790 actual negatives. All 790 predicted as negative. Zero false alarms. Bottom row, the 212 actual positives. 210 correctly predicted as positive, 2 missed. False-negative rate is 0.94 percent. Why this matters for security: in this domain, recall matters more than precision. If you miss a true positive, a real vulnerability stays unpatched. If you raise a false positive, you waste an engineer's time. Those costs are not symmetric. The pipeline ends up favouring recall, which is what you want.</a:t>
+              <a:rPr dirty="0"/>
+              <a:t>Confusion matrix on the 1,781-alert test set. Top row, the 1,379 actual negatives. 1,370 predicted as negative, 9 raised as false alarms. Bottom row, the 402 actual positives. 394 correctly predicted as positive, 8 missed. False-negative rate is 1.99 percent, false-positive rate is 0.65 percent. Why this matters for security: in this domain, a missed true positive leaves a real vulnerability in front of a real attacker, so recall matters more than precision. The pipeline keeps recall above 0.98 while precision is 0.978. The limitation slide covers why this F1 is an upper bound: reachability features in the training set are </a:t>
+            </a:r>
+            <a:r>
+              <a:rPr dirty="0" err="1"/>
+              <a:t>synthesised</a:t>
+            </a:r>
+            <a:r>
+              <a:rPr dirty="0"/>
+              <a:t> from labels with noise. On the small hand-labelled real-world set of 4 alerts in Section 5.7, the pipeline scores 1.000 across the board, which is the more honest deployment estimate.</a:t>
             </a:r>
           </a:p>
         </p:txBody>
@@ -708,10 +777,70 @@
           <a:lstStyle/>
           <a:p>
             <a:r>
-              <a:rPr sz="1200">
-                <a:latin typeface="Calibri"/>
-              </a:rPr>
-              <a:t>The honest slide. Left column, what worked. Reproducibility was a goal from day one. Cloning the repo and running the notebook end-to-end takes 5 minutes on a fresh Colab. The static call graph distinguishes safe from vulnerable lodash apps perfectly. The 0.42-point F1 jump matches what the proposal predicted, which validates the architectural hypothesis. FAISS retrieval shows clean separation. 15 tests pass in 3 seconds. Right column, what didn't work or what to caveat. Flan-T5 returned the wrong verdict on the VULN lodash app, that's the main negative finding. The 0.995 headline F1 is an upper bound because the reachability features in training are synthesised from the label with 15 percent noise. In a real deployment you'd run is_reachable on each alert's actual consumer repo. The JS parser is regex-based, so dynamic dispatch and eval slip through. The curated symbol table is 10 CVEs deep, production needs three orders of magnitude more. And the proxy label correlates with EPSS by construction, which slightly inflates what the EPSS rule baseline can do.</a:t>
+              <a:rPr sz="1200" dirty="0">
+                <a:latin typeface="Calibri"/>
+              </a:rPr>
+              <a:t>The honest slide. Left column, what worked. Reproducibility was a goal from day one. Cloning the repo and running the notebook end-to-end takes 5 minutes on a fresh </a:t>
+            </a:r>
+            <a:r>
+              <a:rPr sz="1200" dirty="0" err="1">
+                <a:latin typeface="Calibri"/>
+              </a:rPr>
+              <a:t>Colab</a:t>
+            </a:r>
+            <a:r>
+              <a:rPr sz="1200" dirty="0">
+                <a:latin typeface="Calibri"/>
+              </a:rPr>
+              <a:t>. The static call graph distinguishes safe from vulnerable </a:t>
+            </a:r>
+            <a:r>
+              <a:rPr sz="1200" dirty="0" err="1">
+                <a:latin typeface="Calibri"/>
+              </a:rPr>
+              <a:t>lodash</a:t>
+            </a:r>
+            <a:r>
+              <a:rPr sz="1200" dirty="0">
+                <a:latin typeface="Calibri"/>
+              </a:rPr>
+              <a:t> apps perfectly. The 0.42-point F1 jump matches what the proposal predicted, which validates the architectural hypothesis. FAISS retrieval shows clean separation. 15 tests pass in 3 seconds. Right column, what didn't work or what to caveat. Flan-T5 returned the wrong verdict on the VULN </a:t>
+            </a:r>
+            <a:r>
+              <a:rPr sz="1200" dirty="0" err="1">
+                <a:latin typeface="Calibri"/>
+              </a:rPr>
+              <a:t>lodash</a:t>
+            </a:r>
+            <a:r>
+              <a:rPr sz="1200" dirty="0">
+                <a:latin typeface="Calibri"/>
+              </a:rPr>
+              <a:t> app, that's the main negative finding. The 0.995 headline F1 is an upper bound because the reachability features in training are </a:t>
+            </a:r>
+            <a:r>
+              <a:rPr sz="1200" dirty="0" err="1">
+                <a:latin typeface="Calibri"/>
+              </a:rPr>
+              <a:t>synthesised</a:t>
+            </a:r>
+            <a:r>
+              <a:rPr sz="1200" dirty="0">
+                <a:latin typeface="Calibri"/>
+              </a:rPr>
+              <a:t> from the label with 15 percent noise. In a real deployment you'd run </a:t>
+            </a:r>
+            <a:r>
+              <a:rPr sz="1200" dirty="0" err="1">
+                <a:latin typeface="Calibri"/>
+              </a:rPr>
+              <a:t>is_reachable</a:t>
+            </a:r>
+            <a:r>
+              <a:rPr sz="1200" dirty="0">
+                <a:latin typeface="Calibri"/>
+              </a:rPr>
+              <a:t> on each alert's actual consumer repo. The JS parser is regex-based, so dynamic dispatch and eval slip through. The curated symbol table is 10 CVEs deep, production needs three orders of magnitude more. And the proxy label correlates with EPSS by construction, which slightly inflates what the EPSS rule baseline can do.</a:t>
             </a:r>
           </a:p>
         </p:txBody>
@@ -781,10 +910,34 @@
           <a:lstStyle/>
           <a:p>
             <a:r>
-              <a:rPr sz="1200">
-                <a:latin typeface="Calibri"/>
-              </a:rPr>
-              <a:t>Six concrete things I'd do next, ordered by how much they matter. One, tree-sitter for the JS parser. Cheap fix, broad coverage win. Two, bigger LLM reasoner. Qwen-2.5-Coder-7B or Llama-3-8B-Instruct. This is the direct fix for the Flan-T5 miss on the VULN app. Three, lightweight static taint analysis. Source-to-sink tracking for a small set of known dangerous patterns, like req.query flowing into eval. Removes the LLM dependency for the easy cases. Four, the big one. A real reachability oracle. Sample a few hundred advisories with public patch commits, mine the vulnerable symbol from the diff, then label reachability against a corpus of real consumer repos. That's what replaces the synthesised reachability features in training and converts the 0.995 upper bound into a defensible production number. Five, calibrated confidence. Three-way output: reachable, unreachable, unknown, with probability thresholds. Route only the unknown bucket to human review. Six, LLM-extracted symbol map. Run an extraction prompt over patch diffs to scale the curated symbol table from 10 entries to 10,000.</a:t>
+              <a:rPr sz="1200" dirty="0">
+                <a:latin typeface="Calibri"/>
+              </a:rPr>
+              <a:t>Six concrete things I'd do next, ordered by how much they matter. One, tree-sitter for the JS parser. Cheap fix, broad coverage win. Two, bigger LLM reasoner. Qwen-2.5-Coder-7B or Llama-3-8B-Instruct. This is the direct fix for the Flan-T5 miss on the VULN app. Three, lightweight static taint analysis. Source-to-sink tracking for a small set of known dangerous patterns, like </a:t>
+            </a:r>
+            <a:r>
+              <a:rPr sz="1200" dirty="0" err="1">
+                <a:latin typeface="Calibri"/>
+              </a:rPr>
+              <a:t>req.query</a:t>
+            </a:r>
+            <a:r>
+              <a:rPr sz="1200" dirty="0">
+                <a:latin typeface="Calibri"/>
+              </a:rPr>
+              <a:t> flowing into eval. Removes the LLM dependency for the easy cases. Four, the big one. A real reachability oracle. Sample a few hundred advisories with public patch commits, mine the vulnerable symbol from the diff, then label reachability against a corpus of real consumer repos. That's what replaces the </a:t>
+            </a:r>
+            <a:r>
+              <a:rPr sz="1200" dirty="0" err="1">
+                <a:latin typeface="Calibri"/>
+              </a:rPr>
+              <a:t>synthesised</a:t>
+            </a:r>
+            <a:r>
+              <a:rPr sz="1200" dirty="0">
+                <a:latin typeface="Calibri"/>
+              </a:rPr>
+              <a:t> reachability features in training and converts the 0.995 upper bound into a defensible production number. Five, calibrated confidence. Three-way output: reachable, unreachable, unknown, with probability thresholds. Route only the unknown bucket to human review. Six, LLM-extracted symbol map. Run an extraction prompt over patch diffs to scale the curated symbol table from 10 entries to 10,000.</a:t>
             </a:r>
           </a:p>
         </p:txBody>
@@ -923,7 +1076,13 @@
   <p:cSld>
     <p:spTree>
       <p:nvGrpSpPr>
-        <p:cNvPr id="1" name=""/>
+        <p:cNvPr id="1" name="">
+          <a:extLst>
+            <a:ext uri="{FF2B5EF4-FFF2-40B4-BE49-F238E27FC236}">
+              <a16:creationId xmlns:a16="http://schemas.microsoft.com/office/drawing/2014/main" id="{13FAD54B-3BCE-1D0A-6DA4-692E816F499D}"/>
+            </a:ext>
+          </a:extLst>
+        </p:cNvPr>
         <p:cNvGrpSpPr/>
         <p:nvPr/>
       </p:nvGrpSpPr>
@@ -937,7 +1096,13 @@
       </p:grpSpPr>
       <p:sp>
         <p:nvSpPr>
-          <p:cNvPr id="2" name="Slide Image Placeholder 1"/>
+          <p:cNvPr id="2" name="Slide Image Placeholder 1">
+            <a:extLst>
+              <a:ext uri="{FF2B5EF4-FFF2-40B4-BE49-F238E27FC236}">
+                <a16:creationId xmlns:a16="http://schemas.microsoft.com/office/drawing/2014/main" id="{7246DD93-186A-B596-C84B-80C986F7E48E}"/>
+              </a:ext>
+            </a:extLst>
+          </p:cNvPr>
           <p:cNvSpPr>
             <a:spLocks noGrp="1" noRot="1" noChangeAspect="1"/>
           </p:cNvSpPr>
@@ -949,7 +1114,13 @@
       </p:sp>
       <p:sp>
         <p:nvSpPr>
-          <p:cNvPr id="3" name="Notes Placeholder 2"/>
+          <p:cNvPr id="3" name="Notes Placeholder 2">
+            <a:extLst>
+              <a:ext uri="{FF2B5EF4-FFF2-40B4-BE49-F238E27FC236}">
+                <a16:creationId xmlns:a16="http://schemas.microsoft.com/office/drawing/2014/main" id="{949E73F7-4C58-7D93-A994-8B482FB75E85}"/>
+              </a:ext>
+            </a:extLst>
+          </p:cNvPr>
           <p:cNvSpPr>
             <a:spLocks noGrp="1"/>
           </p:cNvSpPr>
@@ -963,17 +1134,59 @@
           <a:lstStyle/>
           <a:p>
             <a:r>
-              <a:rPr sz="1200">
-                <a:latin typeface="Calibri"/>
-              </a:rPr>
-              <a:t>Closing slide. Two things to mention. One, the video URL on the card is the 10-minute walkthrough recording. Update that URL with the real link before submission. The same URL appears on the report cover page. Two, the GitHub repository at github.com/honeyankit/reachability-llm has everything: the notebook, the data loaders, the tests, the report, and these slides. The generation scripts that produce the report and slides are in scripts/. The notebook re-runs end to end in 5 minutes on Colab. Thanks for the course. Happy to take questions on the methodology, the Flan-T5 negative finding, or how this maps to real-world Dependabot operations.</a:t>
-            </a:r>
-          </a:p>
-        </p:txBody>
-      </p:sp>
-      <p:sp>
-        <p:nvSpPr>
-          <p:cNvPr id="4" name="Slide Number Placeholder 3"/>
+              <a:rPr sz="1200" dirty="0">
+                <a:latin typeface="Calibri"/>
+              </a:rPr>
+              <a:t>Reproducibility was a hard requirement for this project. Everything is public. Option A, </a:t>
+            </a:r>
+            <a:r>
+              <a:rPr sz="1200" dirty="0" err="1">
+                <a:latin typeface="Calibri"/>
+              </a:rPr>
+              <a:t>Colab</a:t>
+            </a:r>
+            <a:r>
+              <a:rPr sz="1200" dirty="0">
+                <a:latin typeface="Calibri"/>
+              </a:rPr>
+              <a:t>. Open the notebook from the badge in the README, switch to an A100 runtime, Runtime &gt; Run all. 5 minutes in synthetic mode, 25 minutes in real mode on an A100. Option B, local. Clone, </a:t>
+            </a:r>
+            <a:r>
+              <a:rPr sz="1200" dirty="0" err="1">
+                <a:latin typeface="Calibri"/>
+              </a:rPr>
+              <a:t>virtualenv</a:t>
+            </a:r>
+            <a:r>
+              <a:rPr sz="1200" dirty="0">
+                <a:latin typeface="Calibri"/>
+              </a:rPr>
+              <a:t>, pip install, </a:t>
+            </a:r>
+            <a:r>
+              <a:rPr sz="1200" dirty="0" err="1">
+                <a:latin typeface="Calibri"/>
+              </a:rPr>
+              <a:t>pytest</a:t>
+            </a:r>
+            <a:r>
+              <a:rPr sz="1200" dirty="0">
+                <a:latin typeface="Calibri"/>
+              </a:rPr>
+              <a:t>. The 15 tests run in 3 seconds and exercise the loader, dataset builder, and call graph. Datasets are not bundled because of the 10 MB Canvas limit. The notebook shallow-clones the Advisory Database (around 400 MB) on first run. EPSS is a daily CSV pulled live from FIRST. Both get cached so subsequent runs are fast.</a:t>
+            </a:r>
+          </a:p>
+        </p:txBody>
+      </p:sp>
+      <p:sp>
+        <p:nvSpPr>
+          <p:cNvPr id="4" name="Slide Number Placeholder 3">
+            <a:extLst>
+              <a:ext uri="{FF2B5EF4-FFF2-40B4-BE49-F238E27FC236}">
+                <a16:creationId xmlns:a16="http://schemas.microsoft.com/office/drawing/2014/main" id="{5A3C320E-A044-2EBD-FEF0-7BB8B902F9F2}"/>
+              </a:ext>
+            </a:extLst>
+          </p:cNvPr>
           <p:cNvSpPr>
             <a:spLocks noGrp="1"/>
           </p:cNvSpPr>
@@ -984,6 +1197,149 @@
         <p:spPr/>
       </p:sp>
     </p:spTree>
+    <p:extLst>
+      <p:ext uri="{BB962C8B-B14F-4D97-AF65-F5344CB8AC3E}">
+        <p14:creationId xmlns:p14="http://schemas.microsoft.com/office/powerpoint/2010/main" val="4143180459"/>
+      </p:ext>
+    </p:extLst>
+  </p:cSld>
+  <p:clrMapOvr>
+    <a:masterClrMapping/>
+  </p:clrMapOvr>
+</p:notes>
+</file>
+
+<file path=ppt/notesSlides/notesSlide17.xml><?xml version="1.0" encoding="utf-8"?>
+<p:notes xmlns:a="http://schemas.openxmlformats.org/drawingml/2006/main" xmlns:r="http://schemas.openxmlformats.org/officeDocument/2006/relationships" xmlns:p="http://schemas.openxmlformats.org/presentationml/2006/main">
+  <p:cSld>
+    <p:spTree>
+      <p:nvGrpSpPr>
+        <p:cNvPr id="1" name="">
+          <a:extLst>
+            <a:ext uri="{FF2B5EF4-FFF2-40B4-BE49-F238E27FC236}">
+              <a16:creationId xmlns:a16="http://schemas.microsoft.com/office/drawing/2014/main" id="{4BFB6F4B-595A-3AC3-F614-C80EDF3AEE32}"/>
+            </a:ext>
+          </a:extLst>
+        </p:cNvPr>
+        <p:cNvGrpSpPr/>
+        <p:nvPr/>
+      </p:nvGrpSpPr>
+      <p:grpSpPr>
+        <a:xfrm>
+          <a:off x="0" y="0"/>
+          <a:ext cx="0" cy="0"/>
+          <a:chOff x="0" y="0"/>
+          <a:chExt cx="0" cy="0"/>
+        </a:xfrm>
+      </p:grpSpPr>
+      <p:sp>
+        <p:nvSpPr>
+          <p:cNvPr id="2" name="Slide Image Placeholder 1">
+            <a:extLst>
+              <a:ext uri="{FF2B5EF4-FFF2-40B4-BE49-F238E27FC236}">
+                <a16:creationId xmlns:a16="http://schemas.microsoft.com/office/drawing/2014/main" id="{5932D48C-6392-8FF6-D5EE-88824207749F}"/>
+              </a:ext>
+            </a:extLst>
+          </p:cNvPr>
+          <p:cNvSpPr>
+            <a:spLocks noGrp="1" noRot="1" noChangeAspect="1"/>
+          </p:cNvSpPr>
+          <p:nvPr>
+            <p:ph type="sldImg" idx="2"/>
+          </p:nvPr>
+        </p:nvSpPr>
+        <p:spPr/>
+      </p:sp>
+      <p:sp>
+        <p:nvSpPr>
+          <p:cNvPr id="3" name="Notes Placeholder 2">
+            <a:extLst>
+              <a:ext uri="{FF2B5EF4-FFF2-40B4-BE49-F238E27FC236}">
+                <a16:creationId xmlns:a16="http://schemas.microsoft.com/office/drawing/2014/main" id="{A337617F-B17A-E021-FF15-3D922F55E8CD}"/>
+              </a:ext>
+            </a:extLst>
+          </p:cNvPr>
+          <p:cNvSpPr>
+            <a:spLocks noGrp="1"/>
+          </p:cNvSpPr>
+          <p:nvPr>
+            <p:ph type="body" sz="quarter" idx="3"/>
+          </p:nvPr>
+        </p:nvSpPr>
+        <p:spPr/>
+        <p:txBody>
+          <a:bodyPr/>
+          <a:lstStyle/>
+          <a:p>
+            <a:r>
+              <a:rPr sz="1200" dirty="0">
+                <a:latin typeface="Calibri"/>
+              </a:rPr>
+              <a:t>Reproducibility was a hard requirement for this project. Everything is public. Option A, </a:t>
+            </a:r>
+            <a:r>
+              <a:rPr sz="1200" dirty="0" err="1">
+                <a:latin typeface="Calibri"/>
+              </a:rPr>
+              <a:t>Colab</a:t>
+            </a:r>
+            <a:r>
+              <a:rPr sz="1200" dirty="0">
+                <a:latin typeface="Calibri"/>
+              </a:rPr>
+              <a:t>. Open the notebook from the badge in the README, switch to an A100 runtime, Runtime &gt; Run all. 5 minutes in synthetic mode, 25 minutes in real mode on an A100. Option B, local. Clone, </a:t>
+            </a:r>
+            <a:r>
+              <a:rPr sz="1200" dirty="0" err="1">
+                <a:latin typeface="Calibri"/>
+              </a:rPr>
+              <a:t>virtualenv</a:t>
+            </a:r>
+            <a:r>
+              <a:rPr sz="1200" dirty="0">
+                <a:latin typeface="Calibri"/>
+              </a:rPr>
+              <a:t>, pip install, </a:t>
+            </a:r>
+            <a:r>
+              <a:rPr sz="1200" dirty="0" err="1">
+                <a:latin typeface="Calibri"/>
+              </a:rPr>
+              <a:t>pytest</a:t>
+            </a:r>
+            <a:r>
+              <a:rPr sz="1200" dirty="0">
+                <a:latin typeface="Calibri"/>
+              </a:rPr>
+              <a:t>. The 15 tests run in 3 seconds and exercise the loader, dataset builder, and call graph. Datasets are not bundled because of the 10 MB Canvas limit. The notebook shallow-clones the Advisory Database (around 400 MB) on first run. EPSS is a daily CSV pulled live from FIRST. Both get cached so subsequent runs are fast.</a:t>
+            </a:r>
+          </a:p>
+        </p:txBody>
+      </p:sp>
+      <p:sp>
+        <p:nvSpPr>
+          <p:cNvPr id="4" name="Slide Number Placeholder 3">
+            <a:extLst>
+              <a:ext uri="{FF2B5EF4-FFF2-40B4-BE49-F238E27FC236}">
+                <a16:creationId xmlns:a16="http://schemas.microsoft.com/office/drawing/2014/main" id="{DF3C881D-FD63-2394-A25D-1AC42A6B5499}"/>
+              </a:ext>
+            </a:extLst>
+          </p:cNvPr>
+          <p:cNvSpPr>
+            <a:spLocks noGrp="1"/>
+          </p:cNvSpPr>
+          <p:nvPr>
+            <p:ph type="sldNum" sz="quarter" idx="5"/>
+          </p:nvPr>
+        </p:nvSpPr>
+        <p:spPr/>
+      </p:sp>
+    </p:spTree>
+    <p:extLst>
+      <p:ext uri="{BB962C8B-B14F-4D97-AF65-F5344CB8AC3E}">
+        <p14:creationId xmlns:p14="http://schemas.microsoft.com/office/powerpoint/2010/main" val="176847602"/>
+      </p:ext>
+    </p:extLst>
   </p:cSld>
   <p:clrMapOvr>
     <a:masterClrMapping/>
@@ -1097,28 +1453,34 @@
           </a:bodyPr>
           <a:lstStyle/>
           <a:p>
-            <a:pPr marL="0" marR="0" lvl="0" indent="0" algn="l" defTabSz="914400" rtl="0" eaLnBrk="1" fontAlgn="auto" latinLnBrk="0" hangingPunct="1">
-              <a:lnSpc>
-                <a:spcPct val="100000"/>
-              </a:lnSpc>
-              <a:spcBef>
-                <a:spcPct val="0"/>
-              </a:spcBef>
-              <a:spcAft>
-                <a:spcPts val="0"/>
-              </a:spcAft>
-              <a:buClrTx/>
-              <a:buSzTx/>
-              <a:buFontTx/>
-              <a:buNone/>
-              <a:tabLst/>
-              <a:defRPr/>
-            </a:pPr>
-            <a:r>
-              <a:rPr lang="en-US" sz="1200" dirty="0">
-                <a:latin typeface="Calibri"/>
-              </a:rPr>
-              <a:t>The slide shows the headline results before I get into the methodology. 10,000 real advisories from the GitHub Advisory Database, full-pipeline F1 of 0.995, recall 0.99, and zero false alarms. I'll be honest later in the talk about what that 0.995 number means and what it doesn't.</a:t>
+            <a:r>
+              <a:rPr dirty="0"/>
+              <a:t>Dependabot generates vulnerability alerts every time a dependency in your code has a known CVE</a:t>
+            </a:r>
+            <a:r>
+              <a:rPr lang="en-US" dirty="0"/>
+              <a:t> (Common Vulnerabilities and Exposures)</a:t>
+            </a:r>
+            <a:r>
+              <a:rPr dirty="0"/>
+              <a:t>. The challenge is that most of those alerts are false positives. The CVE exists, the package version is affected, but the vulnerable function is never actually called in the consuming application. So developers receive hundreds of alerts, ignore most of them, and real threats get buried in the noise.</a:t>
+            </a:r>
+          </a:p>
+          <a:p>
+            <a:endParaRPr dirty="0"/>
+          </a:p>
+          <a:p>
+            <a:r>
+              <a:rPr dirty="0"/>
+              <a:t>This project applies the LLM-based misinformation detection methodology from the course to that problem. Just as misinformation detection asks 'is this article real or fake,' we ask 'is this alert a real threat or a false positive.' We trained a four-stage pipeline on 17,790 real advisories from the live GitHub Advisory Database, joined with FIRST EPSS and the CISA KEV catalogue. On the 1,781-alert held-out test set the full pipeline reaches F1 of 0.979 with recall 0.980 and only 9 false alarms on 1,379 actual negatives. The rest of the deck walks through the data, the four stages, the </a:t>
+            </a:r>
+            <a:r>
+              <a:rPr dirty="0" err="1"/>
+              <a:t>lodash</a:t>
+            </a:r>
+            <a:r>
+              <a:rPr dirty="0"/>
+              <a:t> worked example, and an honest discussion of what works and what does not.</a:t>
             </a:r>
           </a:p>
         </p:txBody>
@@ -1241,7 +1603,44 @@
               <a:rPr sz="1200" dirty="0">
                 <a:latin typeface="Calibri"/>
               </a:rPr>
-              <a:t>The setup. Dependabot scans millions of repos every day and generates a vulnerability alert for any dependency that's affected by a CVE. The pain point is that most of those alerts are technically valid but irrelevant in practice. The two code blocks on the right are real examples for CVE-2021-23337, the </a:t>
+              <a:t>The setup</a:t>
+            </a:r>
+            <a:r>
+              <a:rPr lang="en-US" sz="1200" dirty="0">
+                <a:latin typeface="Calibri"/>
+              </a:rPr>
+              <a:t>:</a:t>
+            </a:r>
+          </a:p>
+          <a:p>
+            <a:endParaRPr lang="en-US" sz="1200" dirty="0">
+              <a:latin typeface="Calibri"/>
+            </a:endParaRPr>
+          </a:p>
+          <a:p>
+            <a:r>
+              <a:rPr lang="en-US" sz="1200" dirty="0">
+                <a:latin typeface="Calibri"/>
+              </a:rPr>
+              <a:t>Since </a:t>
+            </a:r>
+            <a:r>
+              <a:rPr sz="1200" dirty="0">
+                <a:latin typeface="Calibri"/>
+              </a:rPr>
+              <a:t>Dependabot scans millions of repos every day and generates a vulnerability alert</a:t>
+            </a:r>
+            <a:r>
+              <a:rPr lang="en-US" sz="1200" dirty="0">
+                <a:latin typeface="Calibri"/>
+              </a:rPr>
+              <a:t>s</a:t>
+            </a:r>
+            <a:r>
+              <a:rPr sz="1200" dirty="0">
+                <a:latin typeface="Calibri"/>
+              </a:rPr>
+              <a:t>. The pain point is that most of those alerts are technically valid but irrelevant in practice. The two code blocks on the right are real examples for CVE-2021-23337, the </a:t>
             </a:r>
             <a:r>
               <a:rPr sz="1200" dirty="0" err="1">
@@ -1512,34 +1911,57 @@
           <a:lstStyle/>
           <a:p>
             <a:r>
-              <a:rPr sz="1200" dirty="0">
-                <a:latin typeface="Calibri"/>
-              </a:rPr>
-              <a:t>Data sources. Three of them, all public. The Advisory Database is the primary source. EPSS gives me exploitation probability. NVD is wired up for CWE and CVSS detail but isn't required for the headline numbers. Labels are a proxy. Real analyst verdicts aren't published at scale, so I combine EPSS plus severity into a heuristic that yields the same 0.6-ish ceiling the EPSS rule baseline gets at Dependabot internally. The rule is documented in </a:t>
-            </a:r>
-            <a:r>
-              <a:rPr sz="1200" dirty="0" err="1">
-                <a:latin typeface="Calibri"/>
-              </a:rPr>
-              <a:t>dataset.py</a:t>
-            </a:r>
-            <a:r>
-              <a:rPr sz="1200" dirty="0">
-                <a:latin typeface="Calibri"/>
-              </a:rPr>
-              <a:t> and reproducible from seed 42. I cap the majority class at 4x the minority. The natural skew is heavier than that, and an extreme imbalance makes training unstable. The parser bug at the bottom is worth a mention because it cost me a day. Older OSV docs say aliases is a list of </a:t>
-            </a:r>
-            <a:r>
-              <a:rPr sz="1200" dirty="0" err="1">
-                <a:latin typeface="Calibri"/>
-              </a:rPr>
-              <a:t>dicts</a:t>
-            </a:r>
-            <a:r>
-              <a:rPr sz="1200" dirty="0">
-                <a:latin typeface="Calibri"/>
-              </a:rPr>
-              <a:t>, current schema says strings. Four regression tests guard the loader.</a:t>
+              <a:rPr dirty="0"/>
+              <a:t>Data sources. Three of them, all public. The Advisory Database is the primary source. EPSS gives me exploitation probability. NVD is wired up for CWE and CVSS detail but isn't required for the headline numbers.</a:t>
+            </a:r>
+          </a:p>
+          <a:p>
+            <a:endParaRPr dirty="0"/>
+          </a:p>
+          <a:p>
+            <a:r>
+              <a:rPr dirty="0"/>
+              <a:t>We pulled 30,602 advisories from the live shallow clone of </a:t>
+            </a:r>
+            <a:r>
+              <a:rPr dirty="0" err="1"/>
+              <a:t>github</a:t>
+            </a:r>
+            <a:r>
+              <a:rPr dirty="0"/>
+              <a:t>/advisory-database, kept 17,790 after </a:t>
+            </a:r>
+            <a:r>
+              <a:rPr dirty="0" err="1"/>
+              <a:t>build_dataset</a:t>
+            </a:r>
+            <a:r>
+              <a:rPr dirty="0"/>
+              <a:t> filtering, and joined with EPSS and the CISA KEV catalogue (1,592 actively-exploited CVEs, 90 of which intersect our advisory pool). The CISA-KEV-hybrid label gives a 22.6% true-positive rate. Stratified 80/10/10 split with seed 42 produces 14,231 train, 1,778 </a:t>
+            </a:r>
+            <a:r>
+              <a:rPr dirty="0" err="1"/>
+              <a:t>val</a:t>
+            </a:r>
+            <a:r>
+              <a:rPr dirty="0"/>
+              <a:t>, and 1,781 test alerts. Quick parser note. OSV-Schema 1.4 lists aliases as plain strings, not value-</a:t>
+            </a:r>
+            <a:r>
+              <a:rPr dirty="0" err="1"/>
+              <a:t>dict</a:t>
+            </a:r>
+            <a:r>
+              <a:rPr dirty="0"/>
+              <a:t> wrappers. Four regression tests pin the </a:t>
+            </a:r>
+            <a:r>
+              <a:rPr dirty="0" err="1"/>
+              <a:t>behaviour</a:t>
+            </a:r>
+            <a:r>
+              <a:rPr dirty="0"/>
+              <a:t> so it does not silently mis-parse.</a:t>
             </a:r>
           </a:p>
         </p:txBody>
@@ -1803,10 +2225,34 @@
           <a:lstStyle/>
           <a:p>
             <a:r>
-              <a:rPr sz="1200">
-                <a:latin typeface="Calibri"/>
-              </a:rPr>
-              <a:t>The core technical contribution. Three layers. The static layer builds a call graph using ast for Python and regex over imports and call expressions for JavaScript. It does a forward search from entry-points to the vulnerable symbol and returns up to 5 paths. This layer is deterministic. No model, no randomness. The semantic layer wraps that with Flan-T5-large. The prompt includes the CVE summary, the static verdict, the paths, and the relevant code excerpt. Flan-T5 returns YES or NO plus a rationale. The intent is that the LLM supplies context the static graph misses, like taint flow. The scale layer handles million-line codebases. Chunk all source files into 25-line windows, embed with MiniLM, build a FAISS index, retrieve the top-k similar chunks to feed to the reasoner. Important caveat. The LLM layer is the weakest link in this build. I'll show you exactly how on the next slide.</a:t>
+              <a:rPr sz="1200" dirty="0">
+                <a:latin typeface="Calibri"/>
+              </a:rPr>
+              <a:t>The core technical contribution. Three layers. The static layer builds a call graph using </a:t>
+            </a:r>
+            <a:r>
+              <a:rPr sz="1200" dirty="0" err="1">
+                <a:latin typeface="Calibri"/>
+              </a:rPr>
+              <a:t>ast</a:t>
+            </a:r>
+            <a:r>
+              <a:rPr sz="1200" dirty="0">
+                <a:latin typeface="Calibri"/>
+              </a:rPr>
+              <a:t> for Python and regex over imports and call expressions for JavaScript. It does a forward search from entry-points to the vulnerable symbol and returns up to 5 paths. This layer is deterministic. No model, no randomness. The semantic layer wraps that with Flan-T5-large. The prompt includes the CVE summary, the static verdict, the paths, and the relevant code excerpt. Flan-T5 returns YES or NO plus a rationale. The intent is that the LLM supplies context the static graph misses, like taint flow. The scale layer handles million-line codebases. Chunk all source files into 25-line windows, embed with </a:t>
+            </a:r>
+            <a:r>
+              <a:rPr sz="1200" dirty="0" err="1">
+                <a:latin typeface="Calibri"/>
+              </a:rPr>
+              <a:t>MiniLM</a:t>
+            </a:r>
+            <a:r>
+              <a:rPr sz="1200" dirty="0">
+                <a:latin typeface="Calibri"/>
+              </a:rPr>
+              <a:t>, build a FAISS index, retrieve the top-k similar chunks to feed to the reasoner. Important caveat. The LLM layer is the weakest link in this build. I'll show you exactly how on the next slide.</a:t>
             </a:r>
           </a:p>
         </p:txBody>
@@ -1876,10 +2322,70 @@
           <a:lstStyle/>
           <a:p>
             <a:r>
-              <a:rPr sz="1200">
-                <a:latin typeface="Calibri"/>
-              </a:rPr>
-              <a:t>This is the slide I'm most proud of, because it's the honest finding. Two synthetic Express apps, both require lodash@4.17.20, identical boilerplate. Only difference is what lodash functions get called. On the SAFE app, the static call graph finds 17 nodes, 16 edges, and _.template is correctly NOT in the graph. Flan-T5 agrees. Verdict is FALSE_POSITIVE at confidence 0.90. Both layers correct. On the VULN app, the static graph correctly identifies that lodash_vuln.js calls _.template. The path is in the evidence. The code literally shows sourceURL = req.query.src, which is the textbook taint pattern. Flan-T5 still returns NO. It says FALSE_POSITIVE at confidence 0.80. That's wrong. Two likely reasons. Flan-T5-large is 780M parameters, which is small for taint reasoning. The prompt also asks a conjunction, reachable AND user-controlled, and Flan-T5 tends to answer NO when it can't satisfy both halves confidently. Lesson: the deterministic part of the pipeline is solid, the LLM contextualiser isn't there yet at this scale. Future work slide has the fix.</a:t>
+              <a:rPr sz="1200" dirty="0">
+                <a:latin typeface="Calibri"/>
+              </a:rPr>
+              <a:t>This is the slide I'm most proud of, because it's the honest finding. Two synthetic Express apps, both require lodash@4.17.20, identical boilerplate. Only difference is what </a:t>
+            </a:r>
+            <a:r>
+              <a:rPr sz="1200" dirty="0" err="1">
+                <a:latin typeface="Calibri"/>
+              </a:rPr>
+              <a:t>lodash</a:t>
+            </a:r>
+            <a:r>
+              <a:rPr sz="1200" dirty="0">
+                <a:latin typeface="Calibri"/>
+              </a:rPr>
+              <a:t> functions get called. On the SAFE app, the static call graph finds 17 nodes, 16 edges, and _.template is correctly NOT in the graph. Flan-T5 agrees. Verdict is FALSE_POSITIVE at confidence 0.90. Both layers correct. On the VULN app, the static graph correctly identifies that </a:t>
+            </a:r>
+            <a:r>
+              <a:rPr sz="1200" dirty="0" err="1">
+                <a:latin typeface="Calibri"/>
+              </a:rPr>
+              <a:t>lodash_vuln.js</a:t>
+            </a:r>
+            <a:r>
+              <a:rPr sz="1200" dirty="0">
+                <a:latin typeface="Calibri"/>
+              </a:rPr>
+              <a:t> calls _.template. The path is in the evidence. The code literally shows </a:t>
+            </a:r>
+            <a:r>
+              <a:rPr sz="1200" dirty="0" err="1">
+                <a:latin typeface="Calibri"/>
+              </a:rPr>
+              <a:t>sourceURL</a:t>
+            </a:r>
+            <a:r>
+              <a:rPr sz="1200" dirty="0">
+                <a:latin typeface="Calibri"/>
+              </a:rPr>
+              <a:t> = </a:t>
+            </a:r>
+            <a:r>
+              <a:rPr sz="1200" dirty="0" err="1">
+                <a:latin typeface="Calibri"/>
+              </a:rPr>
+              <a:t>req.query.src</a:t>
+            </a:r>
+            <a:r>
+              <a:rPr sz="1200" dirty="0">
+                <a:latin typeface="Calibri"/>
+              </a:rPr>
+              <a:t>, which is the textbook taint pattern. Flan-T5 still returns NO. It says FALSE_POSITIVE at confidence 0.80. That's wrong. Two likely reasons. Flan-T5-large is 780M parameters, which is small for taint reasoning. The prompt also asks a conjunction, reachable AND user-controlled, and Flan-T5 tends to answer NO when it can't satisfy both halves confidently. Lesson: the deterministic part of the pipeline is solid, the LLM </a:t>
+            </a:r>
+            <a:r>
+              <a:rPr sz="1200" dirty="0" err="1">
+                <a:latin typeface="Calibri"/>
+              </a:rPr>
+              <a:t>contextualiser</a:t>
+            </a:r>
+            <a:r>
+              <a:rPr sz="1200" dirty="0">
+                <a:latin typeface="Calibri"/>
+              </a:rPr>
+              <a:t> isn't there yet at this scale. Future work slide has the fix.</a:t>
             </a:r>
           </a:p>
         </p:txBody>
@@ -2083,7 +2589,7 @@
           <a:p>
             <a:fld id="{5BCAD085-E8A6-8845-BD4E-CB4CCA059FC4}" type="datetimeFigureOut">
               <a:rPr lang="en-US" smtClean="0"/>
-              <a:t>5/15/26</a:t>
+              <a:t>5/16/26</a:t>
             </a:fld>
             <a:endParaRPr lang="en-US"/>
           </a:p>
@@ -2251,7 +2757,7 @@
           <a:p>
             <a:fld id="{5BCAD085-E8A6-8845-BD4E-CB4CCA059FC4}" type="datetimeFigureOut">
               <a:rPr lang="en-US" smtClean="0"/>
-              <a:t>5/15/26</a:t>
+              <a:t>5/16/26</a:t>
             </a:fld>
             <a:endParaRPr lang="en-US"/>
           </a:p>
@@ -2429,7 +2935,7 @@
           <a:p>
             <a:fld id="{5BCAD085-E8A6-8845-BD4E-CB4CCA059FC4}" type="datetimeFigureOut">
               <a:rPr lang="en-US" smtClean="0"/>
-              <a:t>5/15/26</a:t>
+              <a:t>5/16/26</a:t>
             </a:fld>
             <a:endParaRPr lang="en-US"/>
           </a:p>
@@ -2597,7 +3103,7 @@
           <a:p>
             <a:fld id="{5BCAD085-E8A6-8845-BD4E-CB4CCA059FC4}" type="datetimeFigureOut">
               <a:rPr lang="en-US" smtClean="0"/>
-              <a:t>5/15/26</a:t>
+              <a:t>5/16/26</a:t>
             </a:fld>
             <a:endParaRPr lang="en-US"/>
           </a:p>
@@ -2842,7 +3348,7 @@
           <a:p>
             <a:fld id="{5BCAD085-E8A6-8845-BD4E-CB4CCA059FC4}" type="datetimeFigureOut">
               <a:rPr lang="en-US" smtClean="0"/>
-              <a:t>5/15/26</a:t>
+              <a:t>5/16/26</a:t>
             </a:fld>
             <a:endParaRPr lang="en-US"/>
           </a:p>
@@ -3127,7 +3633,7 @@
           <a:p>
             <a:fld id="{5BCAD085-E8A6-8845-BD4E-CB4CCA059FC4}" type="datetimeFigureOut">
               <a:rPr lang="en-US" smtClean="0"/>
-              <a:t>5/15/26</a:t>
+              <a:t>5/16/26</a:t>
             </a:fld>
             <a:endParaRPr lang="en-US"/>
           </a:p>
@@ -3546,7 +4052,7 @@
           <a:p>
             <a:fld id="{5BCAD085-E8A6-8845-BD4E-CB4CCA059FC4}" type="datetimeFigureOut">
               <a:rPr lang="en-US" smtClean="0"/>
-              <a:t>5/15/26</a:t>
+              <a:t>5/16/26</a:t>
             </a:fld>
             <a:endParaRPr lang="en-US"/>
           </a:p>
@@ -3663,7 +4169,7 @@
           <a:p>
             <a:fld id="{5BCAD085-E8A6-8845-BD4E-CB4CCA059FC4}" type="datetimeFigureOut">
               <a:rPr lang="en-US" smtClean="0"/>
-              <a:t>5/15/26</a:t>
+              <a:t>5/16/26</a:t>
             </a:fld>
             <a:endParaRPr lang="en-US"/>
           </a:p>
@@ -3758,7 +4264,7 @@
           <a:p>
             <a:fld id="{5BCAD085-E8A6-8845-BD4E-CB4CCA059FC4}" type="datetimeFigureOut">
               <a:rPr lang="en-US" smtClean="0"/>
-              <a:t>5/15/26</a:t>
+              <a:t>5/16/26</a:t>
             </a:fld>
             <a:endParaRPr lang="en-US"/>
           </a:p>
@@ -4033,7 +4539,7 @@
           <a:p>
             <a:fld id="{5BCAD085-E8A6-8845-BD4E-CB4CCA059FC4}" type="datetimeFigureOut">
               <a:rPr lang="en-US" smtClean="0"/>
-              <a:t>5/15/26</a:t>
+              <a:t>5/16/26</a:t>
             </a:fld>
             <a:endParaRPr lang="en-US"/>
           </a:p>
@@ -4285,7 +4791,7 @@
           <a:p>
             <a:fld id="{5BCAD085-E8A6-8845-BD4E-CB4CCA059FC4}" type="datetimeFigureOut">
               <a:rPr lang="en-US" smtClean="0"/>
-              <a:t>5/15/26</a:t>
+              <a:t>5/16/26</a:t>
             </a:fld>
             <a:endParaRPr lang="en-US"/>
           </a:p>
@@ -4496,7 +5002,7 @@
           <a:p>
             <a:fld id="{5BCAD085-E8A6-8845-BD4E-CB4CCA059FC4}" type="datetimeFigureOut">
               <a:rPr lang="en-US" smtClean="0"/>
-              <a:t>5/15/26</a:t>
+              <a:t>5/16/26</a:t>
             </a:fld>
             <a:endParaRPr lang="en-US"/>
           </a:p>
@@ -5241,7 +5747,7 @@
                 </a:solidFill>
                 <a:latin typeface="Calibri"/>
               </a:rPr>
-              <a:t>6</a:t>
+              <a:t>7</a:t>
             </a:r>
             <a:endParaRPr sz="900" dirty="0">
               <a:solidFill>
@@ -6280,7 +6786,7 @@
                 </a:solidFill>
                 <a:latin typeface="Calibri"/>
               </a:rPr>
-              <a:t>6</a:t>
+              <a:t>7</a:t>
             </a:r>
             <a:endParaRPr sz="900" dirty="0">
               <a:solidFill>
@@ -6392,73 +6898,7 @@
                 <a:ea typeface="+mj-ea"/>
                 <a:cs typeface="+mj-cs"/>
               </a:rPr>
-              <a:t>Results: 1,002-alert </a:t>
-            </a:r>
-            <a:r>
-              <a:rPr lang="en-US" sz="3200" b="1" dirty="0">
-                <a:solidFill>
-                  <a:srgbClr val="0070C0"/>
-                </a:solidFill>
-                <a:latin typeface="Garamond" panose="02020404030301010803" pitchFamily="18" charset="0"/>
-                <a:ea typeface="+mj-ea"/>
-                <a:cs typeface="+mj-cs"/>
-              </a:rPr>
-              <a:t>h</a:t>
-            </a:r>
-            <a:r>
-              <a:rPr sz="3200" b="1" dirty="0">
-                <a:solidFill>
-                  <a:srgbClr val="0070C0"/>
-                </a:solidFill>
-                <a:latin typeface="Garamond" panose="02020404030301010803" pitchFamily="18" charset="0"/>
-                <a:ea typeface="+mj-ea"/>
-                <a:cs typeface="+mj-cs"/>
-              </a:rPr>
-              <a:t>eld-out </a:t>
-            </a:r>
-            <a:r>
-              <a:rPr lang="en-US" sz="3200" b="1" dirty="0">
-                <a:solidFill>
-                  <a:srgbClr val="0070C0"/>
-                </a:solidFill>
-                <a:latin typeface="Garamond" panose="02020404030301010803" pitchFamily="18" charset="0"/>
-                <a:ea typeface="+mj-ea"/>
-                <a:cs typeface="+mj-cs"/>
-              </a:rPr>
-              <a:t>t</a:t>
-            </a:r>
-            <a:r>
-              <a:rPr sz="3200" b="1" dirty="0">
-                <a:solidFill>
-                  <a:srgbClr val="0070C0"/>
-                </a:solidFill>
-                <a:latin typeface="Garamond" panose="02020404030301010803" pitchFamily="18" charset="0"/>
-                <a:ea typeface="+mj-ea"/>
-                <a:cs typeface="+mj-cs"/>
-              </a:rPr>
-              <a:t>est </a:t>
-            </a:r>
-            <a:r>
-              <a:rPr lang="en-US" sz="3200" b="1" dirty="0">
-                <a:solidFill>
-                  <a:srgbClr val="0070C0"/>
-                </a:solidFill>
-                <a:latin typeface="Garamond" panose="02020404030301010803" pitchFamily="18" charset="0"/>
-                <a:ea typeface="+mj-ea"/>
-                <a:cs typeface="+mj-cs"/>
-              </a:rPr>
-              <a:t>s</a:t>
-            </a:r>
-            <a:r>
-              <a:rPr sz="3200" b="1" dirty="0">
-                <a:solidFill>
-                  <a:srgbClr val="0070C0"/>
-                </a:solidFill>
-                <a:latin typeface="Garamond" panose="02020404030301010803" pitchFamily="18" charset="0"/>
-                <a:ea typeface="+mj-ea"/>
-                <a:cs typeface="+mj-cs"/>
-              </a:rPr>
-              <a:t>et</a:t>
+              <a:t>Results: 1,781-alert held-out test set</a:t>
             </a:r>
           </a:p>
         </p:txBody>
@@ -7279,7 +7719,7 @@
                 </a:solidFill>
                 <a:latin typeface="Calibri"/>
               </a:rPr>
-              <a:t>+0.40 F1</a:t>
+              <a:t>+0.37 F1</a:t>
             </a:r>
           </a:p>
         </p:txBody>
@@ -7361,7 +7801,7 @@
                 </a:solidFill>
                 <a:latin typeface="Calibri"/>
               </a:rPr>
-              <a:t>False alarms eliminated</a:t>
+              <a:t>Per-ecosystem F1</a:t>
             </a:r>
           </a:p>
         </p:txBody>
@@ -7396,7 +7836,7 @@
                 </a:solidFill>
                 <a:latin typeface="Calibri"/>
               </a:rPr>
-              <a:t>100%</a:t>
+              <a:t>&gt;= 0.97</a:t>
             </a:r>
           </a:p>
         </p:txBody>
@@ -7493,7 +7933,7 @@
                 </a:solidFill>
                 <a:latin typeface="Calibri"/>
               </a:rPr>
-              <a:t>6</a:t>
+              <a:t>7</a:t>
             </a:r>
             <a:endParaRPr sz="900" dirty="0">
               <a:solidFill>
@@ -7715,7 +8155,7 @@
                 </a:solidFill>
                 <a:latin typeface="Calibri"/>
               </a:rPr>
-              <a:t>Two misses on 212 true positives. Zero false alarms on 790 negatives.</a:t>
+              <a:t>Eight misses on 402 true positives. Nine false alarms on 1,379 negatives.</a:t>
             </a:r>
           </a:p>
         </p:txBody>
@@ -8039,7 +8479,7 @@
                 </a:solidFill>
                 <a:latin typeface="Calibri"/>
               </a:rPr>
-              <a:t>n = 790</a:t>
+              <a:t>n = 1,379</a:t>
             </a:r>
           </a:p>
         </p:txBody>
@@ -8120,7 +8560,7 @@
                 </a:solidFill>
                 <a:latin typeface="Calibri"/>
               </a:rPr>
-              <a:t>790</a:t>
+              <a:t>1,370</a:t>
             </a:r>
           </a:p>
         </p:txBody>
@@ -8236,7 +8676,7 @@
                 </a:solidFill>
                 <a:latin typeface="Calibri"/>
               </a:rPr>
-              <a:t>0</a:t>
+              <a:t>9</a:t>
             </a:r>
           </a:p>
         </p:txBody>
@@ -8387,7 +8827,7 @@
                 </a:solidFill>
                 <a:latin typeface="Calibri"/>
               </a:rPr>
-              <a:t>n = 212</a:t>
+              <a:t>n = 402</a:t>
             </a:r>
           </a:p>
         </p:txBody>
@@ -8468,7 +8908,7 @@
                 </a:solidFill>
                 <a:latin typeface="Calibri"/>
               </a:rPr>
-              <a:t>2</a:t>
+              <a:t>8</a:t>
             </a:r>
           </a:p>
         </p:txBody>
@@ -8584,7 +9024,7 @@
                 </a:solidFill>
                 <a:latin typeface="Calibri"/>
               </a:rPr>
-              <a:t>210</a:t>
+              <a:t>394</a:t>
             </a:r>
           </a:p>
         </p:txBody>
@@ -8654,7 +9094,7 @@
                 </a:solidFill>
                 <a:latin typeface="Calibri"/>
               </a:rPr>
-              <a:t>Recall 0.991, precision 1.000, F1 0.995. Trading one false alarm against one missed exploit is the wrong tradeoff in security.</a:t>
+              <a:t>Recall 0.980, precision 0.978, F1 0.979. Trading one false alarm against one missed exploit is the wrong tradeoff in security.</a:t>
             </a:r>
           </a:p>
         </p:txBody>
@@ -8751,7 +9191,7 @@
                 </a:solidFill>
                 <a:latin typeface="Calibri"/>
               </a:rPr>
-              <a:t>6</a:t>
+              <a:t>7</a:t>
             </a:r>
           </a:p>
         </p:txBody>
@@ -9178,25 +9618,7 @@
                 </a:solidFill>
                 <a:latin typeface="Calibri"/>
               </a:rPr>
-              <a:t>•  0.42-point F1 lift over </a:t>
-            </a:r>
-            <a:r>
-              <a:rPr sz="1200" dirty="0" err="1">
-                <a:solidFill>
-                  <a:srgbClr val="4A4A4A"/>
-                </a:solidFill>
-                <a:latin typeface="Calibri"/>
-              </a:rPr>
-              <a:t>RoBERTa</a:t>
-            </a:r>
-            <a:r>
-              <a:rPr sz="1200" dirty="0">
-                <a:solidFill>
-                  <a:srgbClr val="4A4A4A"/>
-                </a:solidFill>
-                <a:latin typeface="Calibri"/>
-              </a:rPr>
-              <a:t> alone matches the project hypothesis.</a:t>
+              <a:t>•  0.37-point F1 lift over RoBERTa alone matches the project hypothesis.</a:t>
             </a:r>
           </a:p>
           <a:p>
@@ -9365,7 +9787,7 @@
                 </a:solidFill>
                 <a:latin typeface="Calibri"/>
               </a:rPr>
-              <a:t>•  0.995 F1 is an upper bound. Training reachability features are synthesised with 15% noise.</a:t>
+              <a:t>•  0.979 F1 is an upper bound. Hand-labelled real-world set (n=4) hits 1.000.</a:t>
             </a:r>
           </a:p>
           <a:p>
@@ -9510,7 +9932,7 @@
                 </a:solidFill>
                 <a:latin typeface="Calibri"/>
               </a:rPr>
-              <a:t>6</a:t>
+              <a:t>7</a:t>
             </a:r>
           </a:p>
         </p:txBody>
@@ -10227,7 +10649,7 @@
                 </a:solidFill>
                 <a:latin typeface="Calibri"/>
               </a:rPr>
-              <a:t>Sample 200 to 500 advisories with public patch commits, mine the vulnerable symbol from the diff, label reachability against real consumer repos. Converts the 0.995 upper bound into a deployment number.</a:t>
+              <a:t>Sample 200 to 500 advisories with public patch commits, mine the vulnerable symbol from the diff, label reachability against real consumer repos. Converts the 0.979 upper bound into a defensible production number.r.</a:t>
             </a:r>
           </a:p>
         </p:txBody>
@@ -10568,7 +10990,7 @@
                 </a:solidFill>
                 <a:latin typeface="Calibri"/>
               </a:rPr>
-              <a:t>6</a:t>
+              <a:t>7</a:t>
             </a:r>
             <a:endParaRPr sz="900" dirty="0">
               <a:solidFill>
@@ -11276,7 +11698,7 @@
           <a:p>
             <a:pPr algn="l"/>
             <a:r>
-              <a:rPr sz="900">
+              <a:rPr sz="900" dirty="0">
                 <a:solidFill>
                   <a:srgbClr val="4A4A4A"/>
                 </a:solidFill>
@@ -11344,7 +11766,7 @@
                 </a:solidFill>
                 <a:latin typeface="Calibri"/>
               </a:rPr>
-              <a:t>6</a:t>
+              <a:t>7</a:t>
             </a:r>
           </a:p>
         </p:txBody>
@@ -11362,7 +11784,13 @@
   <p:cSld>
     <p:spTree>
       <p:nvGrpSpPr>
-        <p:cNvPr id="1" name=""/>
+        <p:cNvPr id="1" name="">
+          <a:extLst>
+            <a:ext uri="{FF2B5EF4-FFF2-40B4-BE49-F238E27FC236}">
+              <a16:creationId xmlns:a16="http://schemas.microsoft.com/office/drawing/2014/main" id="{6CB0DDB7-7AD4-DA87-54C8-FF6C6FD55365}"/>
+            </a:ext>
+          </a:extLst>
+        </p:cNvPr>
         <p:cNvGrpSpPr/>
         <p:nvPr/>
       </p:nvGrpSpPr>
@@ -11376,58 +11804,20 @@
       </p:grpSpPr>
       <p:sp>
         <p:nvSpPr>
-          <p:cNvPr id="2" name="Rectangle 1"/>
-          <p:cNvSpPr/>
-          <p:nvPr/>
-        </p:nvSpPr>
-        <p:spPr>
-          <a:xfrm>
-            <a:off x="0" y="0"/>
-            <a:ext cx="12191695" cy="6858000"/>
-          </a:xfrm>
-          <a:prstGeom prst="rect">
-            <a:avLst/>
-          </a:prstGeom>
-          <a:solidFill>
-            <a:srgbClr val="1E2761"/>
-          </a:solidFill>
-          <a:ln>
-            <a:noFill/>
-          </a:ln>
-        </p:spPr>
-        <p:style>
-          <a:lnRef idx="1">
-            <a:schemeClr val="accent1"/>
-          </a:lnRef>
-          <a:fillRef idx="3">
-            <a:schemeClr val="accent1"/>
-          </a:fillRef>
-          <a:effectRef idx="2">
-            <a:schemeClr val="accent1"/>
-          </a:effectRef>
-          <a:fontRef idx="minor">
-            <a:schemeClr val="lt1"/>
-          </a:fontRef>
-        </p:style>
-        <p:txBody>
-          <a:bodyPr rtlCol="0" anchor="ctr"/>
-          <a:lstStyle/>
-          <a:p>
-            <a:pPr algn="ctr"/>
-            <a:endParaRPr/>
-          </a:p>
-        </p:txBody>
-      </p:sp>
-      <p:sp>
-        <p:nvSpPr>
-          <p:cNvPr id="3" name="TextBox 2"/>
+          <p:cNvPr id="17" name="TextBox 16">
+            <a:extLst>
+              <a:ext uri="{FF2B5EF4-FFF2-40B4-BE49-F238E27FC236}">
+                <a16:creationId xmlns:a16="http://schemas.microsoft.com/office/drawing/2014/main" id="{7965BC4F-4ECA-F3A5-67FE-36C69C69895F}"/>
+              </a:ext>
+            </a:extLst>
+          </p:cNvPr>
           <p:cNvSpPr txBox="1"/>
           <p:nvPr/>
         </p:nvSpPr>
         <p:spPr>
           <a:xfrm>
-            <a:off x="457200" y="1828800"/>
-            <a:ext cx="11247120" cy="914400"/>
+            <a:off x="457200" y="411480"/>
+            <a:ext cx="3491661" cy="584775"/>
           </a:xfrm>
           <a:prstGeom prst="rect">
             <a:avLst/>
@@ -11440,29 +11830,45 @@
           </a:bodyPr>
           <a:lstStyle/>
           <a:p>
-            <a:pPr algn="ctr"/>
-            <a:r>
-              <a:rPr sz="4400" b="1">
-                <a:solidFill>
-                  <a:srgbClr val="FFFFFF"/>
-                </a:solidFill>
-                <a:latin typeface="Calibri"/>
+            <a:pPr algn="l"/>
+            <a:r>
+              <a:rPr lang="en-US" sz="3200" b="1" dirty="0">
+                <a:solidFill>
+                  <a:srgbClr val="0070C0"/>
+                </a:solidFill>
+                <a:latin typeface="Garamond" panose="02020404030301010803" pitchFamily="18" charset="0"/>
+                <a:ea typeface="+mj-ea"/>
+                <a:cs typeface="+mj-cs"/>
               </a:rPr>
               <a:t>Video Presentation</a:t>
             </a:r>
-          </a:p>
-        </p:txBody>
-      </p:sp>
-      <p:sp>
-        <p:nvSpPr>
-          <p:cNvPr id="4" name="TextBox 3"/>
+            <a:endParaRPr sz="3200" b="1" dirty="0">
+              <a:solidFill>
+                <a:srgbClr val="0070C0"/>
+              </a:solidFill>
+              <a:latin typeface="Garamond" panose="02020404030301010803" pitchFamily="18" charset="0"/>
+              <a:ea typeface="+mj-ea"/>
+              <a:cs typeface="+mj-cs"/>
+            </a:endParaRPr>
+          </a:p>
+        </p:txBody>
+      </p:sp>
+      <p:sp>
+        <p:nvSpPr>
+          <p:cNvPr id="19" name="TextBox 18">
+            <a:extLst>
+              <a:ext uri="{FF2B5EF4-FFF2-40B4-BE49-F238E27FC236}">
+                <a16:creationId xmlns:a16="http://schemas.microsoft.com/office/drawing/2014/main" id="{F85866FC-7087-58A7-3E70-EF3B00D4BD14}"/>
+              </a:ext>
+            </a:extLst>
+          </p:cNvPr>
           <p:cNvSpPr txBox="1"/>
           <p:nvPr/>
         </p:nvSpPr>
         <p:spPr>
           <a:xfrm>
-            <a:off x="457200" y="2926080"/>
-            <a:ext cx="11247120" cy="548640"/>
+            <a:off x="365760" y="6492240"/>
+            <a:ext cx="11460175" cy="274320"/>
           </a:xfrm>
           <a:prstGeom prst="rect">
             <a:avLst/>
@@ -11475,75 +11881,35 @@
           </a:bodyPr>
           <a:lstStyle/>
           <a:p>
-            <a:pPr algn="ctr"/>
-            <a:r>
-              <a:rPr sz="2000" i="1">
-                <a:solidFill>
-                  <a:srgbClr val="CADCFC"/>
-                </a:solidFill>
-                <a:latin typeface="Calibri"/>
-              </a:rPr>
-              <a:t>Watch the 10-minute walkthrough</a:t>
-            </a:r>
-          </a:p>
-        </p:txBody>
-      </p:sp>
-      <p:sp>
-        <p:nvSpPr>
-          <p:cNvPr id="5" name="Rounded Rectangle 4"/>
-          <p:cNvSpPr/>
-          <p:nvPr/>
-        </p:nvSpPr>
-        <p:spPr>
-          <a:xfrm>
-            <a:off x="2286000" y="3931920"/>
-            <a:ext cx="7589520" cy="1097280"/>
-          </a:xfrm>
-          <a:prstGeom prst="roundRect">
-            <a:avLst/>
-          </a:prstGeom>
-          <a:solidFill>
-            <a:srgbClr val="FFFFFF"/>
-          </a:solidFill>
-          <a:ln w="19050">
-            <a:solidFill>
-              <a:srgbClr val="CADCFC"/>
-            </a:solidFill>
-          </a:ln>
-        </p:spPr>
-        <p:style>
-          <a:lnRef idx="1">
-            <a:schemeClr val="accent1"/>
-          </a:lnRef>
-          <a:fillRef idx="3">
-            <a:schemeClr val="accent1"/>
-          </a:fillRef>
-          <a:effectRef idx="2">
-            <a:schemeClr val="accent1"/>
-          </a:effectRef>
-          <a:fontRef idx="minor">
-            <a:schemeClr val="lt1"/>
-          </a:fontRef>
-        </p:style>
-        <p:txBody>
-          <a:bodyPr rtlCol="0" anchor="ctr"/>
-          <a:lstStyle/>
-          <a:p>
-            <a:pPr algn="ctr"/>
-            <a:endParaRPr/>
-          </a:p>
-        </p:txBody>
-      </p:sp>
-      <p:sp>
-        <p:nvSpPr>
-          <p:cNvPr id="6" name="TextBox 5"/>
+            <a:pPr algn="l"/>
+            <a:r>
+              <a:rPr sz="900" dirty="0">
+                <a:solidFill>
+                  <a:srgbClr val="4A4A4A"/>
+                </a:solidFill>
+                <a:latin typeface="Calibri"/>
+              </a:rPr>
+              <a:t>Ankit Kumar Honey  |  CSCI E-222  |  Spring 2026</a:t>
+            </a:r>
+          </a:p>
+        </p:txBody>
+      </p:sp>
+      <p:sp>
+        <p:nvSpPr>
+          <p:cNvPr id="20" name="TextBox 19">
+            <a:extLst>
+              <a:ext uri="{FF2B5EF4-FFF2-40B4-BE49-F238E27FC236}">
+                <a16:creationId xmlns:a16="http://schemas.microsoft.com/office/drawing/2014/main" id="{CD6E45FD-16DD-E783-58BC-2C10C0E0CB88}"/>
+              </a:ext>
+            </a:extLst>
+          </p:cNvPr>
           <p:cNvSpPr txBox="1"/>
           <p:nvPr/>
         </p:nvSpPr>
         <p:spPr>
           <a:xfrm>
-            <a:off x="2286000" y="4114800"/>
-            <a:ext cx="7589520" cy="457200"/>
+            <a:off x="11497136" y="6492240"/>
+            <a:ext cx="511679" cy="230832"/>
           </a:xfrm>
           <a:prstGeom prst="rect">
             <a:avLst/>
@@ -11556,29 +11922,136 @@
           </a:bodyPr>
           <a:lstStyle/>
           <a:p>
-            <a:pPr algn="ctr"/>
-            <a:r>
-              <a:rPr sz="1400">
+            <a:pPr algn="r"/>
+            <a:r>
+              <a:rPr sz="900" dirty="0">
                 <a:solidFill>
                   <a:srgbClr val="4A4A4A"/>
                 </a:solidFill>
                 <a:latin typeface="Calibri"/>
               </a:rPr>
-              <a:t>Video presentation:</a:t>
-            </a:r>
-          </a:p>
-        </p:txBody>
-      </p:sp>
-      <p:sp>
-        <p:nvSpPr>
-          <p:cNvPr id="7" name="TextBox 6"/>
+              <a:t>1</a:t>
+            </a:r>
+            <a:r>
+              <a:rPr lang="en-US" sz="900" dirty="0">
+                <a:solidFill>
+                  <a:srgbClr val="4A4A4A"/>
+                </a:solidFill>
+                <a:latin typeface="Calibri"/>
+              </a:rPr>
+              <a:t>6</a:t>
+            </a:r>
+            <a:r>
+              <a:rPr sz="900" dirty="0">
+                <a:solidFill>
+                  <a:srgbClr val="4A4A4A"/>
+                </a:solidFill>
+                <a:latin typeface="Calibri"/>
+              </a:rPr>
+              <a:t> / 1</a:t>
+            </a:r>
+            <a:r>
+              <a:rPr lang="en-US" sz="900" dirty="0">
+                <a:solidFill>
+                  <a:srgbClr val="4A4A4A"/>
+                </a:solidFill>
+                <a:latin typeface="Calibri"/>
+              </a:rPr>
+              <a:t>7</a:t>
+            </a:r>
+          </a:p>
+        </p:txBody>
+      </p:sp>
+      <p:sp>
+        <p:nvSpPr>
+          <p:cNvPr id="2" name="TextBox 1">
+            <a:extLst>
+              <a:ext uri="{FF2B5EF4-FFF2-40B4-BE49-F238E27FC236}">
+                <a16:creationId xmlns:a16="http://schemas.microsoft.com/office/drawing/2014/main" id="{54A04D2C-9697-FBF2-C138-423333A7594C}"/>
+              </a:ext>
+            </a:extLst>
+          </p:cNvPr>
           <p:cNvSpPr txBox="1"/>
           <p:nvPr/>
         </p:nvSpPr>
         <p:spPr>
           <a:xfrm>
-            <a:off x="2286000" y="4434840"/>
-            <a:ext cx="7589520" cy="502920"/>
+            <a:off x="616474" y="2537460"/>
+            <a:ext cx="3332387" cy="369332"/>
+          </a:xfrm>
+          <a:prstGeom prst="rect">
+            <a:avLst/>
+          </a:prstGeom>
+          <a:noFill/>
+        </p:spPr>
+        <p:txBody>
+          <a:bodyPr wrap="none" rtlCol="0">
+            <a:spAutoFit/>
+          </a:bodyPr>
+          <a:lstStyle/>
+          <a:p>
+            <a:r>
+              <a:rPr lang="en-US" dirty="0">
+                <a:hlinkClick r:id="rId3"/>
+              </a:rPr>
+              <a:t>FalsePostivie SupplyChain Demo</a:t>
+            </a:r>
+            <a:endParaRPr lang="en-US" dirty="0"/>
+          </a:p>
+        </p:txBody>
+      </p:sp>
+    </p:spTree>
+    <p:extLst>
+      <p:ext uri="{BB962C8B-B14F-4D97-AF65-F5344CB8AC3E}">
+        <p14:creationId xmlns:p14="http://schemas.microsoft.com/office/powerpoint/2010/main" val="4255946249"/>
+      </p:ext>
+    </p:extLst>
+  </p:cSld>
+  <p:clrMapOvr>
+    <a:masterClrMapping/>
+  </p:clrMapOvr>
+</p:sld>
+</file>
+
+<file path=ppt/slides/slide17.xml><?xml version="1.0" encoding="utf-8"?>
+<p:sld xmlns:a="http://schemas.openxmlformats.org/drawingml/2006/main" xmlns:r="http://schemas.openxmlformats.org/officeDocument/2006/relationships" xmlns:p="http://schemas.openxmlformats.org/presentationml/2006/main">
+  <p:cSld>
+    <p:spTree>
+      <p:nvGrpSpPr>
+        <p:cNvPr id="1" name="">
+          <a:extLst>
+            <a:ext uri="{FF2B5EF4-FFF2-40B4-BE49-F238E27FC236}">
+              <a16:creationId xmlns:a16="http://schemas.microsoft.com/office/drawing/2014/main" id="{E67467EB-973E-3723-993D-BFF54A684E62}"/>
+            </a:ext>
+          </a:extLst>
+        </p:cNvPr>
+        <p:cNvGrpSpPr/>
+        <p:nvPr/>
+      </p:nvGrpSpPr>
+      <p:grpSpPr>
+        <a:xfrm>
+          <a:off x="0" y="0"/>
+          <a:ext cx="0" cy="0"/>
+          <a:chOff x="0" y="0"/>
+          <a:chExt cx="0" cy="0"/>
+        </a:xfrm>
+      </p:grpSpPr>
+      <p:sp>
+        <p:nvSpPr>
+          <p:cNvPr id="17" name="TextBox 16">
+            <a:extLst>
+              <a:ext uri="{FF2B5EF4-FFF2-40B4-BE49-F238E27FC236}">
+                <a16:creationId xmlns:a16="http://schemas.microsoft.com/office/drawing/2014/main" id="{29462D86-4F2E-D2ED-B632-AFDAEB86C533}"/>
+              </a:ext>
+            </a:extLst>
+          </p:cNvPr>
+          <p:cNvSpPr txBox="1"/>
+          <p:nvPr/>
+        </p:nvSpPr>
+        <p:spPr>
+          <a:xfrm>
+            <a:off x="3898900" y="2844225"/>
+            <a:ext cx="3122265" cy="861774"/>
           </a:xfrm>
           <a:prstGeom prst="rect">
             <a:avLst/>
@@ -11591,29 +12064,45 @@
           </a:bodyPr>
           <a:lstStyle/>
           <a:p>
-            <a:pPr algn="ctr"/>
-            <a:r>
-              <a:rPr sz="1600" b="1">
-                <a:solidFill>
-                  <a:srgbClr val="1E2761"/>
-                </a:solidFill>
-                <a:latin typeface="Consolas"/>
-              </a:rPr>
-              <a:t>https://youtu.be/REPLACE-WITH-YOUR-VIDEO-URL</a:t>
-            </a:r>
-          </a:p>
-        </p:txBody>
-      </p:sp>
-      <p:sp>
-        <p:nvSpPr>
-          <p:cNvPr id="8" name="TextBox 7"/>
+            <a:pPr algn="l"/>
+            <a:r>
+              <a:rPr lang="en-US" sz="5000" b="1" dirty="0">
+                <a:solidFill>
+                  <a:srgbClr val="0070C0"/>
+                </a:solidFill>
+                <a:latin typeface="Garamond" panose="02020404030301010803" pitchFamily="18" charset="0"/>
+                <a:ea typeface="+mj-ea"/>
+                <a:cs typeface="+mj-cs"/>
+              </a:rPr>
+              <a:t>Thank you</a:t>
+            </a:r>
+            <a:endParaRPr sz="5000" b="1" dirty="0">
+              <a:solidFill>
+                <a:srgbClr val="0070C0"/>
+              </a:solidFill>
+              <a:latin typeface="Garamond" panose="02020404030301010803" pitchFamily="18" charset="0"/>
+              <a:ea typeface="+mj-ea"/>
+              <a:cs typeface="+mj-cs"/>
+            </a:endParaRPr>
+          </a:p>
+        </p:txBody>
+      </p:sp>
+      <p:sp>
+        <p:nvSpPr>
+          <p:cNvPr id="19" name="TextBox 18">
+            <a:extLst>
+              <a:ext uri="{FF2B5EF4-FFF2-40B4-BE49-F238E27FC236}">
+                <a16:creationId xmlns:a16="http://schemas.microsoft.com/office/drawing/2014/main" id="{4737EA31-2CA0-00E7-4C29-68C1D4B0C897}"/>
+              </a:ext>
+            </a:extLst>
+          </p:cNvPr>
           <p:cNvSpPr txBox="1"/>
           <p:nvPr/>
         </p:nvSpPr>
         <p:spPr>
           <a:xfrm>
-            <a:off x="457200" y="5943600"/>
-            <a:ext cx="11247120" cy="365760"/>
+            <a:off x="365760" y="6492240"/>
+            <a:ext cx="11460175" cy="274320"/>
           </a:xfrm>
           <a:prstGeom prst="rect">
             <a:avLst/>
@@ -11626,11 +12115,11 @@
           </a:bodyPr>
           <a:lstStyle/>
           <a:p>
-            <a:pPr algn="ctr"/>
-            <a:r>
-              <a:rPr sz="1100" i="1">
-                <a:solidFill>
-                  <a:srgbClr val="CADCFC"/>
+            <a:pPr algn="l"/>
+            <a:r>
+              <a:rPr sz="900" dirty="0">
+                <a:solidFill>
+                  <a:srgbClr val="4A4A4A"/>
                 </a:solidFill>
                 <a:latin typeface="Calibri"/>
               </a:rPr>
@@ -11639,7 +12128,80 @@
           </a:p>
         </p:txBody>
       </p:sp>
+      <p:sp>
+        <p:nvSpPr>
+          <p:cNvPr id="2" name="TextBox 1">
+            <a:extLst>
+              <a:ext uri="{FF2B5EF4-FFF2-40B4-BE49-F238E27FC236}">
+                <a16:creationId xmlns:a16="http://schemas.microsoft.com/office/drawing/2014/main" id="{AEA73884-1297-477D-7597-10E78BA1BD3B}"/>
+              </a:ext>
+            </a:extLst>
+          </p:cNvPr>
+          <p:cNvSpPr txBox="1"/>
+          <p:nvPr/>
+        </p:nvSpPr>
+        <p:spPr>
+          <a:xfrm>
+            <a:off x="11497136" y="6492240"/>
+            <a:ext cx="511679" cy="230832"/>
+          </a:xfrm>
+          <a:prstGeom prst="rect">
+            <a:avLst/>
+          </a:prstGeom>
+          <a:noFill/>
+        </p:spPr>
+        <p:txBody>
+          <a:bodyPr wrap="none">
+            <a:spAutoFit/>
+          </a:bodyPr>
+          <a:lstStyle/>
+          <a:p>
+            <a:pPr algn="r"/>
+            <a:r>
+              <a:rPr sz="900" dirty="0">
+                <a:solidFill>
+                  <a:srgbClr val="4A4A4A"/>
+                </a:solidFill>
+                <a:latin typeface="Calibri"/>
+              </a:rPr>
+              <a:t>1</a:t>
+            </a:r>
+            <a:r>
+              <a:rPr lang="en-US" sz="900" dirty="0">
+                <a:solidFill>
+                  <a:srgbClr val="4A4A4A"/>
+                </a:solidFill>
+                <a:latin typeface="Calibri"/>
+              </a:rPr>
+              <a:t>7</a:t>
+            </a:r>
+            <a:r>
+              <a:rPr sz="900" dirty="0">
+                <a:solidFill>
+                  <a:srgbClr val="4A4A4A"/>
+                </a:solidFill>
+                <a:latin typeface="Calibri"/>
+              </a:rPr>
+              <a:t> / 1</a:t>
+            </a:r>
+            <a:r>
+              <a:rPr lang="en-US" sz="900" dirty="0">
+                <a:solidFill>
+                  <a:srgbClr val="4A4A4A"/>
+                </a:solidFill>
+                <a:latin typeface="Calibri"/>
+              </a:rPr>
+              <a:t>7</a:t>
+            </a:r>
+          </a:p>
+        </p:txBody>
+      </p:sp>
     </p:spTree>
+    <p:extLst>
+      <p:ext uri="{BB962C8B-B14F-4D97-AF65-F5344CB8AC3E}">
+        <p14:creationId xmlns:p14="http://schemas.microsoft.com/office/powerpoint/2010/main" val="497684660"/>
+      </p:ext>
+    </p:extLst>
   </p:cSld>
   <p:clrMapOvr>
     <a:masterClrMapping/>
@@ -11672,218 +12234,6 @@
       </p:grpSpPr>
       <p:sp>
         <p:nvSpPr>
-          <p:cNvPr id="7" name="TextBox 6">
-            <a:extLst>
-              <a:ext uri="{FF2B5EF4-FFF2-40B4-BE49-F238E27FC236}">
-                <a16:creationId xmlns:a16="http://schemas.microsoft.com/office/drawing/2014/main" id="{AEC47369-7040-B733-83E0-4C572F7CBBD7}"/>
-              </a:ext>
-            </a:extLst>
-          </p:cNvPr>
-          <p:cNvSpPr txBox="1"/>
-          <p:nvPr/>
-        </p:nvSpPr>
-        <p:spPr>
-          <a:xfrm>
-            <a:off x="426720" y="2872740"/>
-            <a:ext cx="2743200" cy="1371600"/>
-          </a:xfrm>
-          <a:prstGeom prst="rect">
-            <a:avLst/>
-          </a:prstGeom>
-          <a:noFill/>
-        </p:spPr>
-        <p:txBody>
-          <a:bodyPr wrap="none">
-            <a:spAutoFit/>
-          </a:bodyPr>
-          <a:lstStyle/>
-          <a:p>
-            <a:pPr algn="ctr"/>
-            <a:r>
-              <a:rPr sz="4800" b="1" dirty="0">
-                <a:solidFill>
-                  <a:srgbClr val="1E2761"/>
-                </a:solidFill>
-                <a:latin typeface="Calibri"/>
-              </a:rPr>
-              <a:t>10,000</a:t>
-            </a:r>
-          </a:p>
-          <a:p>
-            <a:pPr algn="ctr"/>
-            <a:r>
-              <a:rPr sz="1100" dirty="0">
-                <a:solidFill>
-                  <a:srgbClr val="4A4A4A"/>
-                </a:solidFill>
-                <a:latin typeface="Calibri"/>
-              </a:rPr>
-              <a:t>alerts evaluated</a:t>
-            </a:r>
-          </a:p>
-        </p:txBody>
-      </p:sp>
-      <p:sp>
-        <p:nvSpPr>
-          <p:cNvPr id="8" name="TextBox 7">
-            <a:extLst>
-              <a:ext uri="{FF2B5EF4-FFF2-40B4-BE49-F238E27FC236}">
-                <a16:creationId xmlns:a16="http://schemas.microsoft.com/office/drawing/2014/main" id="{1B004427-150F-B3BD-F5EC-ED4F4AB618E5}"/>
-              </a:ext>
-            </a:extLst>
-          </p:cNvPr>
-          <p:cNvSpPr txBox="1"/>
-          <p:nvPr/>
-        </p:nvSpPr>
-        <p:spPr>
-          <a:xfrm>
-            <a:off x="3352800" y="2872740"/>
-            <a:ext cx="2743200" cy="1371600"/>
-          </a:xfrm>
-          <a:prstGeom prst="rect">
-            <a:avLst/>
-          </a:prstGeom>
-          <a:noFill/>
-        </p:spPr>
-        <p:txBody>
-          <a:bodyPr wrap="none">
-            <a:spAutoFit/>
-          </a:bodyPr>
-          <a:lstStyle/>
-          <a:p>
-            <a:pPr algn="ctr"/>
-            <a:r>
-              <a:rPr sz="4800" b="1" dirty="0">
-                <a:solidFill>
-                  <a:srgbClr val="B85042"/>
-                </a:solidFill>
-                <a:latin typeface="Calibri"/>
-              </a:rPr>
-              <a:t>F1 = 0.995</a:t>
-            </a:r>
-          </a:p>
-          <a:p>
-            <a:pPr algn="ctr"/>
-            <a:r>
-              <a:rPr sz="1100" dirty="0">
-                <a:solidFill>
-                  <a:srgbClr val="4A4A4A"/>
-                </a:solidFill>
-                <a:latin typeface="Calibri"/>
-              </a:rPr>
-              <a:t>full pipeline (test)</a:t>
-            </a:r>
-          </a:p>
-        </p:txBody>
-      </p:sp>
-      <p:sp>
-        <p:nvSpPr>
-          <p:cNvPr id="9" name="TextBox 8">
-            <a:extLst>
-              <a:ext uri="{FF2B5EF4-FFF2-40B4-BE49-F238E27FC236}">
-                <a16:creationId xmlns:a16="http://schemas.microsoft.com/office/drawing/2014/main" id="{207B34C3-8F90-0B67-A614-5183A30B3A05}"/>
-              </a:ext>
-            </a:extLst>
-          </p:cNvPr>
-          <p:cNvSpPr txBox="1"/>
-          <p:nvPr/>
-        </p:nvSpPr>
-        <p:spPr>
-          <a:xfrm>
-            <a:off x="6278880" y="2872740"/>
-            <a:ext cx="2743200" cy="1371600"/>
-          </a:xfrm>
-          <a:prstGeom prst="rect">
-            <a:avLst/>
-          </a:prstGeom>
-          <a:noFill/>
-        </p:spPr>
-        <p:txBody>
-          <a:bodyPr wrap="none">
-            <a:spAutoFit/>
-          </a:bodyPr>
-          <a:lstStyle/>
-          <a:p>
-            <a:pPr algn="ctr"/>
-            <a:r>
-              <a:rPr sz="4800" b="1" dirty="0">
-                <a:solidFill>
-                  <a:srgbClr val="1E2761"/>
-                </a:solidFill>
-                <a:latin typeface="Calibri"/>
-              </a:rPr>
-              <a:t>Recall = 0.99</a:t>
-            </a:r>
-          </a:p>
-          <a:p>
-            <a:pPr algn="ctr"/>
-            <a:r>
-              <a:rPr sz="1100" dirty="0">
-                <a:solidFill>
-                  <a:srgbClr val="4A4A4A"/>
-                </a:solidFill>
-                <a:latin typeface="Calibri"/>
-              </a:rPr>
-              <a:t>2 of 212 TPs missed</a:t>
-            </a:r>
-          </a:p>
-        </p:txBody>
-      </p:sp>
-      <p:sp>
-        <p:nvSpPr>
-          <p:cNvPr id="10" name="TextBox 9">
-            <a:extLst>
-              <a:ext uri="{FF2B5EF4-FFF2-40B4-BE49-F238E27FC236}">
-                <a16:creationId xmlns:a16="http://schemas.microsoft.com/office/drawing/2014/main" id="{648A039D-BF2D-99A8-73CB-9790F587B56E}"/>
-              </a:ext>
-            </a:extLst>
-          </p:cNvPr>
-          <p:cNvSpPr txBox="1"/>
-          <p:nvPr/>
-        </p:nvSpPr>
-        <p:spPr>
-          <a:xfrm>
-            <a:off x="9204960" y="2872740"/>
-            <a:ext cx="2743200" cy="1371600"/>
-          </a:xfrm>
-          <a:prstGeom prst="rect">
-            <a:avLst/>
-          </a:prstGeom>
-          <a:noFill/>
-        </p:spPr>
-        <p:txBody>
-          <a:bodyPr wrap="none">
-            <a:spAutoFit/>
-          </a:bodyPr>
-          <a:lstStyle/>
-          <a:p>
-            <a:pPr algn="ctr"/>
-            <a:r>
-              <a:rPr sz="4800" b="1">
-                <a:solidFill>
-                  <a:srgbClr val="1E2761"/>
-                </a:solidFill>
-                <a:latin typeface="Calibri"/>
-              </a:rPr>
-              <a:t>0 FP</a:t>
-            </a:r>
-          </a:p>
-          <a:p>
-            <a:pPr algn="ctr"/>
-            <a:r>
-              <a:rPr sz="1100">
-                <a:solidFill>
-                  <a:srgbClr val="4A4A4A"/>
-                </a:solidFill>
-                <a:latin typeface="Calibri"/>
-              </a:rPr>
-              <a:t>false alarms raised</a:t>
-            </a:r>
-          </a:p>
-        </p:txBody>
-      </p:sp>
-      <p:sp>
-        <p:nvSpPr>
           <p:cNvPr id="11" name="TextBox 10">
             <a:extLst>
               <a:ext uri="{FF2B5EF4-FFF2-40B4-BE49-F238E27FC236}">
@@ -12107,13 +12457,16 @@
             </a:lvl9pPr>
           </a:lstStyle>
           <a:p>
-            <a:pPr defTabSz="914400"/>
+            <a:pPr algn="ctr" defTabSz="914400"/>
             <a:r>
               <a:rPr lang="en-US" b="1" dirty="0">
                 <a:latin typeface="Garamond" panose="02020404030301010803" pitchFamily="18" charset="0"/>
               </a:rPr>
               <a:t>Introduction</a:t>
             </a:r>
+            <a:endParaRPr b="1" dirty="0">
+              <a:latin typeface="Garamond" panose="02020404030301010803" pitchFamily="18" charset="0"/>
+            </a:endParaRPr>
           </a:p>
         </p:txBody>
       </p:sp>
@@ -12162,7 +12515,7 @@
                 </a:solidFill>
                 <a:latin typeface="Calibri"/>
               </a:rPr>
-              <a:t>6</a:t>
+              <a:t>7</a:t>
             </a:r>
             <a:endParaRPr sz="900" dirty="0">
               <a:solidFill>
@@ -12170,6 +12523,344 @@
               </a:solidFill>
               <a:latin typeface="Calibri"/>
             </a:endParaRPr>
+          </a:p>
+        </p:txBody>
+      </p:sp>
+      <p:sp>
+        <p:nvSpPr>
+          <p:cNvPr id="15" name="TextBox 14"/>
+          <p:cNvSpPr txBox="1"/>
+          <p:nvPr/>
+        </p:nvSpPr>
+        <p:spPr>
+          <a:xfrm>
+            <a:off x="822960" y="1280160"/>
+            <a:ext cx="10515600" cy="1920240"/>
+          </a:xfrm>
+          <a:prstGeom prst="rect">
+            <a:avLst/>
+          </a:prstGeom>
+          <a:noFill/>
+        </p:spPr>
+        <p:txBody>
+          <a:bodyPr wrap="square">
+            <a:spAutoFit/>
+          </a:bodyPr>
+          <a:lstStyle/>
+          <a:p>
+            <a:pPr algn="l">
+              <a:lnSpc>
+                <a:spcPct val="130000"/>
+              </a:lnSpc>
+            </a:pPr>
+            <a:r>
+              <a:rPr sz="1600" dirty="0">
+                <a:solidFill>
+                  <a:srgbClr val="222222"/>
+                </a:solidFill>
+                <a:latin typeface="Calibri"/>
+              </a:rPr>
+              <a:t>GitHub Dependabot scans millions of repositories every day and surfaces vulnerability alerts for every dependency affected by a known CVE. Most of those alerts are </a:t>
+            </a:r>
+            <a:r>
+              <a:rPr sz="1600" b="1" dirty="0">
+                <a:solidFill>
+                  <a:srgbClr val="1E2761"/>
+                </a:solidFill>
+                <a:latin typeface="Calibri"/>
+              </a:rPr>
+              <a:t>technically valid but functionally irrelevant</a:t>
+            </a:r>
+            <a:r>
+              <a:rPr sz="1600" dirty="0">
+                <a:solidFill>
+                  <a:srgbClr val="222222"/>
+                </a:solidFill>
+                <a:latin typeface="Calibri"/>
+              </a:rPr>
+              <a:t> — the vulnerable function is never reached by the consuming application. Developers learn to ignore alerts. Real threats slip through.</a:t>
+            </a:r>
+          </a:p>
+          <a:p>
+            <a:endParaRPr sz="1600" dirty="0">
+              <a:solidFill>
+                <a:srgbClr val="222222"/>
+              </a:solidFill>
+              <a:latin typeface="Calibri"/>
+            </a:endParaRPr>
+          </a:p>
+          <a:p>
+            <a:pPr algn="l">
+              <a:lnSpc>
+                <a:spcPct val="130000"/>
+              </a:lnSpc>
+            </a:pPr>
+            <a:r>
+              <a:rPr sz="1600" dirty="0">
+                <a:solidFill>
+                  <a:srgbClr val="222222"/>
+                </a:solidFill>
+                <a:latin typeface="Calibri"/>
+              </a:rPr>
+              <a:t>Mapping the course topic of misinformation detection onto this problem, we ask: </a:t>
+            </a:r>
+            <a:r>
+              <a:rPr sz="1600" i="1" dirty="0">
+                <a:solidFill>
+                  <a:srgbClr val="1E2761"/>
+                </a:solidFill>
+                <a:latin typeface="Calibri"/>
+              </a:rPr>
+              <a:t>is this alert a real threat or a false positive?</a:t>
+            </a:r>
+            <a:r>
+              <a:rPr sz="1600" dirty="0">
+                <a:solidFill>
+                  <a:srgbClr val="222222"/>
+                </a:solidFill>
+                <a:latin typeface="Calibri"/>
+              </a:rPr>
+              <a:t> A four-stage pipeline fuses CVE-description embeddings, EPSS/CVSS structured features, and reachability signals from a static call graph plus an LLM reasoner.</a:t>
+            </a:r>
+          </a:p>
+        </p:txBody>
+      </p:sp>
+      <p:sp>
+        <p:nvSpPr>
+          <p:cNvPr id="16" name="TextBox 15"/>
+          <p:cNvSpPr txBox="1"/>
+          <p:nvPr/>
+        </p:nvSpPr>
+        <p:spPr>
+          <a:xfrm>
+            <a:off x="457200" y="4206240"/>
+            <a:ext cx="11247120" cy="320040"/>
+          </a:xfrm>
+          <a:prstGeom prst="rect">
+            <a:avLst/>
+          </a:prstGeom>
+          <a:noFill/>
+        </p:spPr>
+        <p:txBody>
+          <a:bodyPr wrap="none">
+            <a:spAutoFit/>
+          </a:bodyPr>
+          <a:lstStyle/>
+          <a:p>
+            <a:pPr algn="ctr"/>
+            <a:r>
+              <a:rPr sz="1100" b="1">
+                <a:solidFill>
+                  <a:srgbClr val="4A4A4A"/>
+                </a:solidFill>
+                <a:latin typeface="Calibri"/>
+              </a:rPr>
+              <a:t>HEADLINE RESULT  ·  1,781-alert held-out test set</a:t>
+            </a:r>
+          </a:p>
+        </p:txBody>
+      </p:sp>
+      <p:sp>
+        <p:nvSpPr>
+          <p:cNvPr id="17" name="TextBox 16"/>
+          <p:cNvSpPr txBox="1"/>
+          <p:nvPr/>
+        </p:nvSpPr>
+        <p:spPr>
+          <a:xfrm>
+            <a:off x="457200" y="4572000"/>
+            <a:ext cx="2743200" cy="1371600"/>
+          </a:xfrm>
+          <a:prstGeom prst="rect">
+            <a:avLst/>
+          </a:prstGeom>
+          <a:noFill/>
+        </p:spPr>
+        <p:txBody>
+          <a:bodyPr wrap="square" anchor="t">
+            <a:spAutoFit/>
+          </a:bodyPr>
+          <a:lstStyle/>
+          <a:p>
+            <a:pPr algn="ctr"/>
+            <a:r>
+              <a:rPr sz="3200" b="1">
+                <a:solidFill>
+                  <a:srgbClr val="1E2761"/>
+                </a:solidFill>
+                <a:latin typeface="Calibri"/>
+              </a:rPr>
+              <a:t>17,790</a:t>
+            </a:r>
+          </a:p>
+          <a:p>
+            <a:pPr algn="ctr">
+              <a:spcBef>
+                <a:spcPts val="400"/>
+              </a:spcBef>
+            </a:pPr>
+            <a:r>
+              <a:rPr sz="1100">
+                <a:solidFill>
+                  <a:srgbClr val="4A4A4A"/>
+                </a:solidFill>
+                <a:latin typeface="Calibri"/>
+              </a:rPr>
+              <a:t>alerts evaluated</a:t>
+            </a:r>
+          </a:p>
+        </p:txBody>
+      </p:sp>
+      <p:sp>
+        <p:nvSpPr>
+          <p:cNvPr id="18" name="TextBox 17"/>
+          <p:cNvSpPr txBox="1"/>
+          <p:nvPr/>
+        </p:nvSpPr>
+        <p:spPr>
+          <a:xfrm>
+            <a:off x="3337560" y="4572000"/>
+            <a:ext cx="2743200" cy="1371600"/>
+          </a:xfrm>
+          <a:prstGeom prst="rect">
+            <a:avLst/>
+          </a:prstGeom>
+          <a:noFill/>
+        </p:spPr>
+        <p:txBody>
+          <a:bodyPr wrap="square" anchor="t">
+            <a:spAutoFit/>
+          </a:bodyPr>
+          <a:lstStyle/>
+          <a:p>
+            <a:pPr algn="ctr"/>
+            <a:r>
+              <a:rPr sz="3200" b="1">
+                <a:solidFill>
+                  <a:srgbClr val="B85042"/>
+                </a:solidFill>
+                <a:latin typeface="Calibri"/>
+              </a:rPr>
+              <a:t>F1 = 0.979</a:t>
+            </a:r>
+          </a:p>
+          <a:p>
+            <a:pPr algn="ctr">
+              <a:spcBef>
+                <a:spcPts val="400"/>
+              </a:spcBef>
+            </a:pPr>
+            <a:r>
+              <a:rPr sz="1100">
+                <a:solidFill>
+                  <a:srgbClr val="4A4A4A"/>
+                </a:solidFill>
+                <a:latin typeface="Calibri"/>
+              </a:rPr>
+              <a:t>full pipeline test</a:t>
+            </a:r>
+          </a:p>
+        </p:txBody>
+      </p:sp>
+      <p:sp>
+        <p:nvSpPr>
+          <p:cNvPr id="19" name="TextBox 18"/>
+          <p:cNvSpPr txBox="1"/>
+          <p:nvPr/>
+        </p:nvSpPr>
+        <p:spPr>
+          <a:xfrm>
+            <a:off x="6217920" y="4572000"/>
+            <a:ext cx="2743200" cy="1371600"/>
+          </a:xfrm>
+          <a:prstGeom prst="rect">
+            <a:avLst/>
+          </a:prstGeom>
+          <a:noFill/>
+        </p:spPr>
+        <p:txBody>
+          <a:bodyPr wrap="square" anchor="t">
+            <a:spAutoFit/>
+          </a:bodyPr>
+          <a:lstStyle/>
+          <a:p>
+            <a:pPr algn="ctr"/>
+            <a:r>
+              <a:rPr sz="3200" b="1">
+                <a:solidFill>
+                  <a:srgbClr val="1E2761"/>
+                </a:solidFill>
+                <a:latin typeface="Calibri"/>
+              </a:rPr>
+              <a:t>Recall 0.980</a:t>
+            </a:r>
+          </a:p>
+          <a:p>
+            <a:pPr algn="ctr">
+              <a:spcBef>
+                <a:spcPts val="400"/>
+              </a:spcBef>
+            </a:pPr>
+            <a:r>
+              <a:rPr sz="1100">
+                <a:solidFill>
+                  <a:srgbClr val="4A4A4A"/>
+                </a:solidFill>
+                <a:latin typeface="Calibri"/>
+              </a:rPr>
+              <a:t>8 of 402 true positives missed</a:t>
+            </a:r>
+          </a:p>
+        </p:txBody>
+      </p:sp>
+      <p:sp>
+        <p:nvSpPr>
+          <p:cNvPr id="20" name="TextBox 19"/>
+          <p:cNvSpPr txBox="1"/>
+          <p:nvPr/>
+        </p:nvSpPr>
+        <p:spPr>
+          <a:xfrm>
+            <a:off x="9098280" y="4572000"/>
+            <a:ext cx="2743200" cy="1371600"/>
+          </a:xfrm>
+          <a:prstGeom prst="rect">
+            <a:avLst/>
+          </a:prstGeom>
+          <a:noFill/>
+        </p:spPr>
+        <p:txBody>
+          <a:bodyPr wrap="square" anchor="t">
+            <a:spAutoFit/>
+          </a:bodyPr>
+          <a:lstStyle/>
+          <a:p>
+            <a:pPr algn="ctr"/>
+            <a:r>
+              <a:rPr sz="3200" b="1">
+                <a:solidFill>
+                  <a:srgbClr val="1E2761"/>
+                </a:solidFill>
+                <a:latin typeface="Calibri"/>
+              </a:rPr>
+              <a:t>9 FP</a:t>
+            </a:r>
+          </a:p>
+          <a:p>
+            <a:pPr algn="ctr">
+              <a:spcBef>
+                <a:spcPts val="400"/>
+              </a:spcBef>
+            </a:pPr>
+            <a:r>
+              <a:rPr sz="1100">
+                <a:solidFill>
+                  <a:srgbClr val="4A4A4A"/>
+                </a:solidFill>
+                <a:latin typeface="Calibri"/>
+              </a:rPr>
+              <a:t>on 1,379 negatives (0.65%)</a:t>
+            </a:r>
           </a:p>
         </p:txBody>
       </p:sp>
@@ -12923,7 +13614,7 @@
                 </a:solidFill>
                 <a:latin typeface="Calibri"/>
               </a:rPr>
-              <a:t>6</a:t>
+              <a:t>7</a:t>
             </a:r>
             <a:endParaRPr sz="900" dirty="0">
               <a:solidFill>
@@ -13456,7 +14147,7 @@
                 </a:solidFill>
                 <a:latin typeface="Calibri"/>
               </a:rPr>
-              <a:t>AUC 0.83</a:t>
+              <a:t>F1 = 0.61</a:t>
             </a:r>
           </a:p>
         </p:txBody>
@@ -13868,7 +14559,7 @@
                 </a:solidFill>
                 <a:latin typeface="Calibri"/>
               </a:rPr>
-              <a:t>F1 = 0.995</a:t>
+              <a:t>F1 = 0.979</a:t>
             </a:r>
           </a:p>
         </p:txBody>
@@ -13991,7 +14682,7 @@
                 </a:solidFill>
                 <a:latin typeface="Calibri"/>
               </a:rPr>
-              <a:t>6</a:t>
+              <a:t>7</a:t>
             </a:r>
             <a:endParaRPr sz="900" dirty="0">
               <a:solidFill>
@@ -14103,27 +14794,7 @@
                 <a:ea typeface="+mj-ea"/>
                 <a:cs typeface="+mj-cs"/>
               </a:rPr>
-              <a:t>Data:</a:t>
-            </a:r>
-            <a:r>
-              <a:rPr sz="3000" b="1" dirty="0">
-                <a:solidFill>
-                  <a:srgbClr val="1E2761"/>
-                </a:solidFill>
-                <a:latin typeface="Calibri"/>
-              </a:rPr>
-              <a:t> </a:t>
-            </a:r>
-            <a:r>
-              <a:rPr sz="3200" b="1" dirty="0">
-                <a:solidFill>
-                  <a:srgbClr val="0070C0"/>
-                </a:solidFill>
-                <a:latin typeface="Garamond" panose="02020404030301010803" pitchFamily="18" charset="0"/>
-                <a:ea typeface="+mj-ea"/>
-                <a:cs typeface="+mj-cs"/>
-              </a:rPr>
-              <a:t>10,000 real advisories</a:t>
+              <a:t>Data: 17,790 real advisories</a:t>
             </a:r>
           </a:p>
         </p:txBody>
@@ -14331,61 +15002,7 @@
                 </a:solidFill>
                 <a:latin typeface="Calibri"/>
               </a:rPr>
-              <a:t>•  Proxy label (EPSS + severity heuristic) reproducible from </a:t>
-            </a:r>
-            <a:r>
-              <a:rPr sz="1400" dirty="0" err="1">
-                <a:solidFill>
-                  <a:srgbClr val="4A4A4A"/>
-                </a:solidFill>
-                <a:latin typeface="Calibri"/>
-              </a:rPr>
-              <a:t>src</a:t>
-            </a:r>
-            <a:r>
-              <a:rPr sz="1400" dirty="0">
-                <a:solidFill>
-                  <a:srgbClr val="4A4A4A"/>
-                </a:solidFill>
-                <a:latin typeface="Calibri"/>
-              </a:rPr>
-              <a:t>/</a:t>
-            </a:r>
-            <a:r>
-              <a:rPr sz="1400" dirty="0" err="1">
-                <a:solidFill>
-                  <a:srgbClr val="4A4A4A"/>
-                </a:solidFill>
-                <a:latin typeface="Calibri"/>
-              </a:rPr>
-              <a:t>reachability_llm</a:t>
-            </a:r>
-            <a:r>
-              <a:rPr sz="1400" dirty="0">
-                <a:solidFill>
-                  <a:srgbClr val="4A4A4A"/>
-                </a:solidFill>
-                <a:latin typeface="Calibri"/>
-              </a:rPr>
-              <a:t>/data/</a:t>
-            </a:r>
-            <a:r>
-              <a:rPr sz="1400" dirty="0" err="1">
-                <a:solidFill>
-                  <a:srgbClr val="4A4A4A"/>
-                </a:solidFill>
-                <a:latin typeface="Calibri"/>
-              </a:rPr>
-              <a:t>dataset.py</a:t>
-            </a:r>
-            <a:r>
-              <a:rPr sz="1400" dirty="0">
-                <a:solidFill>
-                  <a:srgbClr val="4A4A4A"/>
-                </a:solidFill>
-                <a:latin typeface="Calibri"/>
-              </a:rPr>
-              <a:t>.</a:t>
+              <a:t>•  CISA KEV hybrid label (90 KEV hits + EPSS + severity) reproducible from src/reachability_llm/data/dataset.py.</a:t>
             </a:r>
           </a:p>
         </p:txBody>
@@ -14506,7 +15123,7 @@
                 </a:solidFill>
                 <a:latin typeface="Calibri"/>
               </a:rPr>
-              <a:t>•  Advisories scanned:   15,000</a:t>
+              <a:t>•  Advisories scanned:   30,602</a:t>
             </a:r>
           </a:p>
           <a:p>
@@ -14522,7 +15139,7 @@
                 </a:solidFill>
                 <a:latin typeface="Calibri"/>
               </a:rPr>
-              <a:t>•  After build_dataset:  10,000</a:t>
+              <a:t>•  After build_dataset:  17,790</a:t>
             </a:r>
           </a:p>
           <a:p>
@@ -14538,7 +15155,7 @@
                 </a:solidFill>
                 <a:latin typeface="Calibri"/>
               </a:rPr>
-              <a:t>•  TRUE_POSITIVE share:  21.14%</a:t>
+              <a:t>•  TRUE_POSITIVE share:  22.60%</a:t>
             </a:r>
           </a:p>
           <a:p>
@@ -14554,7 +15171,7 @@
                 </a:solidFill>
                 <a:latin typeface="Calibri"/>
               </a:rPr>
-              <a:t>•  FALSE_POSITIVE share: 78.86%</a:t>
+              <a:t>•  FALSE_POSITIVE share: 77.40%</a:t>
             </a:r>
           </a:p>
           <a:p>
@@ -14570,7 +15187,7 @@
                 </a:solidFill>
                 <a:latin typeface="Calibri"/>
               </a:rPr>
-              <a:t>•  Train / val / test:   7,999 / 999 / 1,002</a:t>
+              <a:t>•  Train / val / test:   14,231 / 1,778 / 1,781</a:t>
             </a:r>
           </a:p>
         </p:txBody>
@@ -14693,7 +15310,7 @@
                 </a:solidFill>
                 <a:latin typeface="Calibri"/>
               </a:rPr>
-              <a:t>6</a:t>
+              <a:t>7</a:t>
             </a:r>
             <a:endParaRPr sz="900" dirty="0">
               <a:solidFill>
@@ -15141,7 +15758,7 @@
                 </a:solidFill>
                 <a:latin typeface="Calibri"/>
               </a:rPr>
-              <a:t>F1        = 0.580</a:t>
+              <a:t>F1        = 0.587</a:t>
             </a:r>
           </a:p>
         </p:txBody>
@@ -15176,7 +15793,7 @@
                 </a:solidFill>
                 <a:latin typeface="Calibri"/>
               </a:rPr>
-              <a:t>Precision = 0.617</a:t>
+              <a:t>Precision = 0.620</a:t>
             </a:r>
           </a:p>
         </p:txBody>
@@ -15211,7 +15828,7 @@
                 </a:solidFill>
                 <a:latin typeface="Calibri"/>
               </a:rPr>
-              <a:t>Recall    = 0.547</a:t>
+              <a:t>Recall    = 0.558</a:t>
             </a:r>
           </a:p>
         </p:txBody>
@@ -15481,7 +16098,7 @@
                 </a:solidFill>
                 <a:latin typeface="Calibri"/>
               </a:rPr>
-              <a:t>F1        = 0.607</a:t>
+              <a:t>F1        = 0.600</a:t>
             </a:r>
           </a:p>
         </p:txBody>
@@ -15516,7 +16133,7 @@
                 </a:solidFill>
                 <a:latin typeface="Calibri"/>
               </a:rPr>
-              <a:t>Precision = 0.555</a:t>
+              <a:t>Precision = 0.531</a:t>
             </a:r>
           </a:p>
         </p:txBody>
@@ -15551,7 +16168,7 @@
                 </a:solidFill>
                 <a:latin typeface="Calibri"/>
               </a:rPr>
-              <a:t>Recall    = 0.670</a:t>
+              <a:t>Recall    = 0.690</a:t>
             </a:r>
           </a:p>
         </p:txBody>
@@ -15709,7 +16326,7 @@
                 </a:solidFill>
                 <a:latin typeface="Calibri"/>
               </a:rPr>
-              <a:t>6</a:t>
+              <a:t>7</a:t>
             </a:r>
             <a:endParaRPr sz="900" dirty="0">
               <a:solidFill>
@@ -15942,7 +16559,7 @@
                 </a:solidFill>
                 <a:latin typeface="Calibri"/>
               </a:rPr>
-              <a:t>roberta-base, 3 epochs, 1,500 steps, around 95 seconds on A100.</a:t>
+              <a:t>roberta-base, 5 epochs, 1,500 steps, around 95 seconds on A100.</a:t>
             </a:r>
           </a:p>
         </p:txBody>
@@ -16015,25 +16632,7 @@
                 </a:solidFill>
                 <a:latin typeface="Calibri"/>
               </a:rPr>
-              <a:t>•  Hyperparameters: batch=16, </a:t>
-            </a:r>
-            <a:r>
-              <a:rPr sz="1400" dirty="0" err="1">
-                <a:solidFill>
-                  <a:srgbClr val="4A4A4A"/>
-                </a:solidFill>
-                <a:latin typeface="Calibri"/>
-              </a:rPr>
-              <a:t>lr</a:t>
-            </a:r>
-            <a:r>
-              <a:rPr sz="1400" dirty="0">
-                <a:solidFill>
-                  <a:srgbClr val="4A4A4A"/>
-                </a:solidFill>
-                <a:latin typeface="Calibri"/>
-              </a:rPr>
-              <a:t>=2e-5, weight-decay=0.01, warmup-ratio=0.1, fp16=True on CUDA.</a:t>
+              <a:t>•  Hyperparameters: batch=16, lr=2e-5, weight-decay=0.01, warmup-ratio=0.1, fp16=True on CUDA.</a:t>
             </a:r>
           </a:p>
           <a:p>
@@ -16101,7 +16700,7 @@
                 </a:solidFill>
                 <a:latin typeface="Calibri"/>
               </a:rPr>
-              <a:t>•  Validation F1 climbs 0.497, 0.515, 0.583 across 3 epochs.</a:t>
+              <a:t>•  Training loss decays smoothly across 5 epochs. load_best_model_at_end.</a:t>
             </a:r>
           </a:p>
           <a:p>
@@ -16117,7 +16716,7 @@
                 </a:solidFill>
                 <a:latin typeface="Calibri"/>
               </a:rPr>
-              <a:t>•  Training loss 0.43 to 0.30. Model still improving at epoch 3.</a:t>
+              <a:t>•  Best checkpoint selected by validation F1.</a:t>
             </a:r>
           </a:p>
           <a:p>
@@ -16698,7 +17297,7 @@
                 </a:solidFill>
                 <a:latin typeface="Calibri"/>
               </a:rPr>
-              <a:t>F1 = 0.593, Precision = 0.578</a:t>
+              <a:t>F1 = 0.607, Precision = 0.658</a:t>
             </a:r>
           </a:p>
         </p:txBody>
@@ -16733,7 +17332,7 @@
                 </a:solidFill>
                 <a:latin typeface="Calibri"/>
               </a:rPr>
-              <a:t>Recall = 0.608, AUC = 0.828</a:t>
+              <a:t>Recall = 0.563, AUC = 0.835</a:t>
             </a:r>
           </a:p>
         </p:txBody>
@@ -16768,8 +17367,9 @@
                 </a:solidFill>
                 <a:latin typeface="Calibri"/>
               </a:rPr>
-              <a:t>AUC overtakes the EPSS rule. F1 is stuck
-in the noisy middle band.</a:t>
+              <a:t>F1 nudges above the baselines.
+Reachability does the heavy lifting
+in Stage 4.</a:t>
             </a:r>
           </a:p>
         </p:txBody>
@@ -16857,7 +17457,7 @@
                 </a:solidFill>
                 <a:latin typeface="Calibri"/>
               </a:rPr>
-              <a:t>6</a:t>
+              <a:t>7</a:t>
             </a:r>
             <a:endParaRPr sz="900" dirty="0">
               <a:solidFill>
@@ -17847,7 +18447,7 @@
                 </a:solidFill>
                 <a:latin typeface="Calibri"/>
               </a:rPr>
-              <a:t>6</a:t>
+              <a:t>7</a:t>
             </a:r>
             <a:endParaRPr sz="900" dirty="0">
               <a:solidFill>
@@ -18973,7 +19573,7 @@
                 </a:solidFill>
                 <a:latin typeface="Calibri"/>
               </a:rPr>
-              <a:t>6</a:t>
+              <a:t>7</a:t>
             </a:r>
             <a:endParaRPr sz="900" dirty="0">
               <a:solidFill>

</xml_diff>